<commit_message>
Redesign deck figures as slide-native visuals (deck-scale, no shrunken paper diagrams)
</commit_message>
<xml_diff>
--- a/Gisting-CTO-deck.pptx
+++ b/Gisting-CTO-deck.pptx
@@ -3763,8 +3763,8 @@
         </p:nvSpPr>
         <p:spPr>
           <a:xfrm>
-            <a:off x="530352" y="1993391"/>
-            <a:ext cx="7534656" cy="2108546"/>
+            <a:off x="640080" y="2560320"/>
+            <a:ext cx="1828800" cy="960120"/>
           </a:xfrm>
           <a:prstGeom prst="roundRect">
             <a:avLst>
@@ -3772,7 +3772,7 @@
             </a:avLst>
           </a:prstGeom>
           <a:solidFill>
-            <a:srgbClr val="FFFFFF"/>
+            <a:srgbClr val="141D21"/>
           </a:solidFill>
           <a:ln w="12700">
             <a:solidFill>
@@ -3803,30 +3803,48 @@
           </a:p>
         </p:txBody>
       </p:sp>
-      <p:pic>
-        <p:nvPicPr>
-          <p:cNvPr id="6" name="Picture 5" descr="fig_loop.png"/>
-          <p:cNvPicPr>
-            <a:picLocks noChangeAspect="1"/>
-          </p:cNvPicPr>
-          <p:nvPr/>
-        </p:nvPicPr>
-        <p:blipFill>
-          <a:blip r:embed="rId2"/>
-          <a:stretch>
-            <a:fillRect/>
-          </a:stretch>
-        </p:blipFill>
-        <p:spPr>
-          <a:xfrm>
-            <a:off x="640080" y="2103120"/>
-            <a:ext cx="7315200" cy="1889090"/>
+      <p:sp>
+        <p:nvSpPr>
+          <p:cNvPr id="6" name="TextBox 5"/>
+          <p:cNvSpPr txBox="1"/>
+          <p:nvPr/>
+        </p:nvSpPr>
+        <p:spPr>
+          <a:xfrm>
+            <a:off x="640080" y="2560320"/>
+            <a:ext cx="1828800" cy="960120"/>
           </a:xfrm>
           <a:prstGeom prst="rect">
             <a:avLst/>
           </a:prstGeom>
-        </p:spPr>
-      </p:pic>
+          <a:noFill/>
+        </p:spPr>
+        <p:txBody>
+          <a:bodyPr wrap="square" anchor="ctr">
+            <a:spAutoFit/>
+          </a:bodyPr>
+          <a:lstStyle/>
+          <a:p>
+            <a:pPr algn="ctr">
+              <a:lnSpc>
+                <a:spcPct val="100000"/>
+              </a:lnSpc>
+              <a:spcAft>
+                <a:spcPts val="0"/>
+              </a:spcAft>
+            </a:pPr>
+            <a:r>
+              <a:rPr sz="1400" b="1">
+                <a:solidFill>
+                  <a:srgbClr val="FFFFFF"/>
+                </a:solidFill>
+                <a:latin typeface="Calibri"/>
+              </a:rPr>
+              <a:t>Provision GPU</a:t>
+            </a:r>
+          </a:p>
+        </p:txBody>
+      </p:sp>
       <p:sp>
         <p:nvSpPr>
           <p:cNvPr id="7" name="TextBox 6"/>
@@ -3835,8 +3853,756 @@
         </p:nvSpPr>
         <p:spPr>
           <a:xfrm>
-            <a:off x="8321040" y="2103120"/>
-            <a:ext cx="3291840" cy="4023360"/>
+            <a:off x="2468880" y="2560320"/>
+            <a:ext cx="502920" cy="960120"/>
+          </a:xfrm>
+          <a:prstGeom prst="rect">
+            <a:avLst/>
+          </a:prstGeom>
+          <a:noFill/>
+        </p:spPr>
+        <p:txBody>
+          <a:bodyPr wrap="square" anchor="ctr">
+            <a:spAutoFit/>
+          </a:bodyPr>
+          <a:lstStyle/>
+          <a:p>
+            <a:pPr algn="ctr">
+              <a:lnSpc>
+                <a:spcPct val="100000"/>
+              </a:lnSpc>
+              <a:spcAft>
+                <a:spcPts val="0"/>
+              </a:spcAft>
+            </a:pPr>
+            <a:r>
+              <a:rPr sz="2000" b="1">
+                <a:solidFill>
+                  <a:srgbClr val="3FB0C6"/>
+                </a:solidFill>
+                <a:latin typeface="Calibri"/>
+              </a:rPr>
+              <a:t>→</a:t>
+            </a:r>
+          </a:p>
+        </p:txBody>
+      </p:sp>
+      <p:sp>
+        <p:nvSpPr>
+          <p:cNvPr id="8" name="Rounded Rectangle 7"/>
+          <p:cNvSpPr/>
+          <p:nvPr/>
+        </p:nvSpPr>
+        <p:spPr>
+          <a:xfrm>
+            <a:off x="2971800" y="2560320"/>
+            <a:ext cx="1234440" cy="960120"/>
+          </a:xfrm>
+          <a:prstGeom prst="roundRect">
+            <a:avLst>
+              <a:gd name="adj" fmla="val 6000"/>
+            </a:avLst>
+          </a:prstGeom>
+          <a:solidFill>
+            <a:srgbClr val="141D21"/>
+          </a:solidFill>
+          <a:ln w="12700">
+            <a:solidFill>
+              <a:srgbClr val="25333A"/>
+            </a:solidFill>
+          </a:ln>
+          <a:effectLst/>
+        </p:spPr>
+        <p:style>
+          <a:lnRef idx="1">
+            <a:schemeClr val="accent1"/>
+          </a:lnRef>
+          <a:fillRef idx="3">
+            <a:schemeClr val="accent1"/>
+          </a:fillRef>
+          <a:effectRef idx="2">
+            <a:schemeClr val="accent1"/>
+          </a:effectRef>
+          <a:fontRef idx="minor">
+            <a:schemeClr val="lt1"/>
+          </a:fontRef>
+        </p:style>
+        <p:txBody>
+          <a:bodyPr rtlCol="0" anchor="ctr"/>
+          <a:lstStyle/>
+          <a:p>
+            <a:pPr algn="ctr"/>
+          </a:p>
+        </p:txBody>
+      </p:sp>
+      <p:sp>
+        <p:nvSpPr>
+          <p:cNvPr id="9" name="TextBox 8"/>
+          <p:cNvSpPr txBox="1"/>
+          <p:nvPr/>
+        </p:nvSpPr>
+        <p:spPr>
+          <a:xfrm>
+            <a:off x="2971800" y="2560320"/>
+            <a:ext cx="1234440" cy="960120"/>
+          </a:xfrm>
+          <a:prstGeom prst="rect">
+            <a:avLst/>
+          </a:prstGeom>
+          <a:noFill/>
+        </p:spPr>
+        <p:txBody>
+          <a:bodyPr wrap="square" anchor="ctr">
+            <a:spAutoFit/>
+          </a:bodyPr>
+          <a:lstStyle/>
+          <a:p>
+            <a:pPr algn="ctr">
+              <a:lnSpc>
+                <a:spcPct val="100000"/>
+              </a:lnSpc>
+              <a:spcAft>
+                <a:spcPts val="0"/>
+              </a:spcAft>
+            </a:pPr>
+            <a:r>
+              <a:rPr sz="1400" b="1">
+                <a:solidFill>
+                  <a:srgbClr val="FFFFFF"/>
+                </a:solidFill>
+                <a:latin typeface="Calibri"/>
+              </a:rPr>
+              <a:t>Train</a:t>
+            </a:r>
+          </a:p>
+        </p:txBody>
+      </p:sp>
+      <p:sp>
+        <p:nvSpPr>
+          <p:cNvPr id="10" name="TextBox 9"/>
+          <p:cNvSpPr txBox="1"/>
+          <p:nvPr/>
+        </p:nvSpPr>
+        <p:spPr>
+          <a:xfrm>
+            <a:off x="4206240" y="2560320"/>
+            <a:ext cx="502920" cy="960120"/>
+          </a:xfrm>
+          <a:prstGeom prst="rect">
+            <a:avLst/>
+          </a:prstGeom>
+          <a:noFill/>
+        </p:spPr>
+        <p:txBody>
+          <a:bodyPr wrap="square" anchor="ctr">
+            <a:spAutoFit/>
+          </a:bodyPr>
+          <a:lstStyle/>
+          <a:p>
+            <a:pPr algn="ctr">
+              <a:lnSpc>
+                <a:spcPct val="100000"/>
+              </a:lnSpc>
+              <a:spcAft>
+                <a:spcPts val="0"/>
+              </a:spcAft>
+            </a:pPr>
+            <a:r>
+              <a:rPr sz="2000" b="1">
+                <a:solidFill>
+                  <a:srgbClr val="3FB0C6"/>
+                </a:solidFill>
+                <a:latin typeface="Calibri"/>
+              </a:rPr>
+              <a:t>→</a:t>
+            </a:r>
+          </a:p>
+        </p:txBody>
+      </p:sp>
+      <p:sp>
+        <p:nvSpPr>
+          <p:cNvPr id="11" name="Rounded Rectangle 10"/>
+          <p:cNvSpPr/>
+          <p:nvPr/>
+        </p:nvSpPr>
+        <p:spPr>
+          <a:xfrm>
+            <a:off x="4709159" y="2560320"/>
+            <a:ext cx="1234440" cy="960120"/>
+          </a:xfrm>
+          <a:prstGeom prst="roundRect">
+            <a:avLst>
+              <a:gd name="adj" fmla="val 6000"/>
+            </a:avLst>
+          </a:prstGeom>
+          <a:solidFill>
+            <a:srgbClr val="141D21"/>
+          </a:solidFill>
+          <a:ln w="12700">
+            <a:solidFill>
+              <a:srgbClr val="25333A"/>
+            </a:solidFill>
+          </a:ln>
+          <a:effectLst/>
+        </p:spPr>
+        <p:style>
+          <a:lnRef idx="1">
+            <a:schemeClr val="accent1"/>
+          </a:lnRef>
+          <a:fillRef idx="3">
+            <a:schemeClr val="accent1"/>
+          </a:fillRef>
+          <a:effectRef idx="2">
+            <a:schemeClr val="accent1"/>
+          </a:effectRef>
+          <a:fontRef idx="minor">
+            <a:schemeClr val="lt1"/>
+          </a:fontRef>
+        </p:style>
+        <p:txBody>
+          <a:bodyPr rtlCol="0" anchor="ctr"/>
+          <a:lstStyle/>
+          <a:p>
+            <a:pPr algn="ctr"/>
+          </a:p>
+        </p:txBody>
+      </p:sp>
+      <p:sp>
+        <p:nvSpPr>
+          <p:cNvPr id="12" name="TextBox 11"/>
+          <p:cNvSpPr txBox="1"/>
+          <p:nvPr/>
+        </p:nvSpPr>
+        <p:spPr>
+          <a:xfrm>
+            <a:off x="4709159" y="2560320"/>
+            <a:ext cx="1234440" cy="960120"/>
+          </a:xfrm>
+          <a:prstGeom prst="rect">
+            <a:avLst/>
+          </a:prstGeom>
+          <a:noFill/>
+        </p:spPr>
+        <p:txBody>
+          <a:bodyPr wrap="square" anchor="ctr">
+            <a:spAutoFit/>
+          </a:bodyPr>
+          <a:lstStyle/>
+          <a:p>
+            <a:pPr algn="ctr">
+              <a:lnSpc>
+                <a:spcPct val="100000"/>
+              </a:lnSpc>
+              <a:spcAft>
+                <a:spcPts val="0"/>
+              </a:spcAft>
+            </a:pPr>
+            <a:r>
+              <a:rPr sz="1400" b="1">
+                <a:solidFill>
+                  <a:srgbClr val="FFFFFF"/>
+                </a:solidFill>
+                <a:latin typeface="Calibri"/>
+              </a:rPr>
+              <a:t>Serve</a:t>
+            </a:r>
+          </a:p>
+        </p:txBody>
+      </p:sp>
+      <p:sp>
+        <p:nvSpPr>
+          <p:cNvPr id="13" name="TextBox 12"/>
+          <p:cNvSpPr txBox="1"/>
+          <p:nvPr/>
+        </p:nvSpPr>
+        <p:spPr>
+          <a:xfrm>
+            <a:off x="5943600" y="2560320"/>
+            <a:ext cx="502920" cy="960120"/>
+          </a:xfrm>
+          <a:prstGeom prst="rect">
+            <a:avLst/>
+          </a:prstGeom>
+          <a:noFill/>
+        </p:spPr>
+        <p:txBody>
+          <a:bodyPr wrap="square" anchor="ctr">
+            <a:spAutoFit/>
+          </a:bodyPr>
+          <a:lstStyle/>
+          <a:p>
+            <a:pPr algn="ctr">
+              <a:lnSpc>
+                <a:spcPct val="100000"/>
+              </a:lnSpc>
+              <a:spcAft>
+                <a:spcPts val="0"/>
+              </a:spcAft>
+            </a:pPr>
+            <a:r>
+              <a:rPr sz="2000" b="1">
+                <a:solidFill>
+                  <a:srgbClr val="3FB0C6"/>
+                </a:solidFill>
+                <a:latin typeface="Calibri"/>
+              </a:rPr>
+              <a:t>→</a:t>
+            </a:r>
+          </a:p>
+        </p:txBody>
+      </p:sp>
+      <p:sp>
+        <p:nvSpPr>
+          <p:cNvPr id="14" name="Rounded Rectangle 13"/>
+          <p:cNvSpPr/>
+          <p:nvPr/>
+        </p:nvSpPr>
+        <p:spPr>
+          <a:xfrm>
+            <a:off x="6446520" y="2560320"/>
+            <a:ext cx="1554480" cy="960120"/>
+          </a:xfrm>
+          <a:prstGeom prst="roundRect">
+            <a:avLst>
+              <a:gd name="adj" fmla="val 6000"/>
+            </a:avLst>
+          </a:prstGeom>
+          <a:solidFill>
+            <a:srgbClr val="141D21"/>
+          </a:solidFill>
+          <a:ln w="12700">
+            <a:solidFill>
+              <a:srgbClr val="25333A"/>
+            </a:solidFill>
+          </a:ln>
+          <a:effectLst/>
+        </p:spPr>
+        <p:style>
+          <a:lnRef idx="1">
+            <a:schemeClr val="accent1"/>
+          </a:lnRef>
+          <a:fillRef idx="3">
+            <a:schemeClr val="accent1"/>
+          </a:fillRef>
+          <a:effectRef idx="2">
+            <a:schemeClr val="accent1"/>
+          </a:effectRef>
+          <a:fontRef idx="minor">
+            <a:schemeClr val="lt1"/>
+          </a:fontRef>
+        </p:style>
+        <p:txBody>
+          <a:bodyPr rtlCol="0" anchor="ctr"/>
+          <a:lstStyle/>
+          <a:p>
+            <a:pPr algn="ctr"/>
+          </a:p>
+        </p:txBody>
+      </p:sp>
+      <p:sp>
+        <p:nvSpPr>
+          <p:cNvPr id="15" name="TextBox 14"/>
+          <p:cNvSpPr txBox="1"/>
+          <p:nvPr/>
+        </p:nvSpPr>
+        <p:spPr>
+          <a:xfrm>
+            <a:off x="6446520" y="2560320"/>
+            <a:ext cx="1554480" cy="960120"/>
+          </a:xfrm>
+          <a:prstGeom prst="rect">
+            <a:avLst/>
+          </a:prstGeom>
+          <a:noFill/>
+        </p:spPr>
+        <p:txBody>
+          <a:bodyPr wrap="square" anchor="ctr">
+            <a:spAutoFit/>
+          </a:bodyPr>
+          <a:lstStyle/>
+          <a:p>
+            <a:pPr algn="ctr">
+              <a:lnSpc>
+                <a:spcPct val="100000"/>
+              </a:lnSpc>
+              <a:spcAft>
+                <a:spcPts val="0"/>
+              </a:spcAft>
+            </a:pPr>
+            <a:r>
+              <a:rPr sz="1400" b="1">
+                <a:solidFill>
+                  <a:srgbClr val="FFFFFF"/>
+                </a:solidFill>
+                <a:latin typeface="Calibri"/>
+              </a:rPr>
+              <a:t>Evaluate</a:t>
+            </a:r>
+          </a:p>
+        </p:txBody>
+      </p:sp>
+      <p:sp>
+        <p:nvSpPr>
+          <p:cNvPr id="16" name="TextBox 15"/>
+          <p:cNvSpPr txBox="1"/>
+          <p:nvPr/>
+        </p:nvSpPr>
+        <p:spPr>
+          <a:xfrm>
+            <a:off x="8001000" y="2560320"/>
+            <a:ext cx="502920" cy="960120"/>
+          </a:xfrm>
+          <a:prstGeom prst="rect">
+            <a:avLst/>
+          </a:prstGeom>
+          <a:noFill/>
+        </p:spPr>
+        <p:txBody>
+          <a:bodyPr wrap="square" anchor="ctr">
+            <a:spAutoFit/>
+          </a:bodyPr>
+          <a:lstStyle/>
+          <a:p>
+            <a:pPr algn="ctr">
+              <a:lnSpc>
+                <a:spcPct val="100000"/>
+              </a:lnSpc>
+              <a:spcAft>
+                <a:spcPts val="0"/>
+              </a:spcAft>
+            </a:pPr>
+            <a:r>
+              <a:rPr sz="2000" b="1">
+                <a:solidFill>
+                  <a:srgbClr val="3FB0C6"/>
+                </a:solidFill>
+                <a:latin typeface="Calibri"/>
+              </a:rPr>
+              <a:t>→</a:t>
+            </a:r>
+          </a:p>
+        </p:txBody>
+      </p:sp>
+      <p:sp>
+        <p:nvSpPr>
+          <p:cNvPr id="17" name="Rounded Rectangle 16"/>
+          <p:cNvSpPr/>
+          <p:nvPr/>
+        </p:nvSpPr>
+        <p:spPr>
+          <a:xfrm>
+            <a:off x="8503920" y="2560320"/>
+            <a:ext cx="1371600" cy="960120"/>
+          </a:xfrm>
+          <a:prstGeom prst="roundRect">
+            <a:avLst>
+              <a:gd name="adj" fmla="val 6000"/>
+            </a:avLst>
+          </a:prstGeom>
+          <a:solidFill>
+            <a:srgbClr val="141D21"/>
+          </a:solidFill>
+          <a:ln w="12700">
+            <a:solidFill>
+              <a:srgbClr val="25333A"/>
+            </a:solidFill>
+          </a:ln>
+          <a:effectLst/>
+        </p:spPr>
+        <p:style>
+          <a:lnRef idx="1">
+            <a:schemeClr val="accent1"/>
+          </a:lnRef>
+          <a:fillRef idx="3">
+            <a:schemeClr val="accent1"/>
+          </a:fillRef>
+          <a:effectRef idx="2">
+            <a:schemeClr val="accent1"/>
+          </a:effectRef>
+          <a:fontRef idx="minor">
+            <a:schemeClr val="lt1"/>
+          </a:fontRef>
+        </p:style>
+        <p:txBody>
+          <a:bodyPr rtlCol="0" anchor="ctr"/>
+          <a:lstStyle/>
+          <a:p>
+            <a:pPr algn="ctr"/>
+          </a:p>
+        </p:txBody>
+      </p:sp>
+      <p:sp>
+        <p:nvSpPr>
+          <p:cNvPr id="18" name="TextBox 17"/>
+          <p:cNvSpPr txBox="1"/>
+          <p:nvPr/>
+        </p:nvSpPr>
+        <p:spPr>
+          <a:xfrm>
+            <a:off x="8503920" y="2560320"/>
+            <a:ext cx="1371600" cy="960120"/>
+          </a:xfrm>
+          <a:prstGeom prst="rect">
+            <a:avLst/>
+          </a:prstGeom>
+          <a:noFill/>
+        </p:spPr>
+        <p:txBody>
+          <a:bodyPr wrap="square" anchor="ctr">
+            <a:spAutoFit/>
+          </a:bodyPr>
+          <a:lstStyle/>
+          <a:p>
+            <a:pPr algn="ctr">
+              <a:lnSpc>
+                <a:spcPct val="100000"/>
+              </a:lnSpc>
+              <a:spcAft>
+                <a:spcPts val="0"/>
+              </a:spcAft>
+            </a:pPr>
+            <a:r>
+              <a:rPr sz="1400" b="1">
+                <a:solidFill>
+                  <a:srgbClr val="FFFFFF"/>
+                </a:solidFill>
+                <a:latin typeface="Calibri"/>
+              </a:rPr>
+              <a:t>Destroy</a:t>
+            </a:r>
+          </a:p>
+        </p:txBody>
+      </p:sp>
+      <p:sp>
+        <p:nvSpPr>
+          <p:cNvPr id="19" name="TextBox 18"/>
+          <p:cNvSpPr txBox="1"/>
+          <p:nvPr/>
+        </p:nvSpPr>
+        <p:spPr>
+          <a:xfrm>
+            <a:off x="9875520" y="2560320"/>
+            <a:ext cx="502920" cy="960120"/>
+          </a:xfrm>
+          <a:prstGeom prst="rect">
+            <a:avLst/>
+          </a:prstGeom>
+          <a:noFill/>
+        </p:spPr>
+        <p:txBody>
+          <a:bodyPr wrap="square" anchor="ctr">
+            <a:spAutoFit/>
+          </a:bodyPr>
+          <a:lstStyle/>
+          <a:p>
+            <a:pPr algn="ctr">
+              <a:lnSpc>
+                <a:spcPct val="100000"/>
+              </a:lnSpc>
+              <a:spcAft>
+                <a:spcPts val="0"/>
+              </a:spcAft>
+            </a:pPr>
+            <a:r>
+              <a:rPr sz="2000" b="1">
+                <a:solidFill>
+                  <a:srgbClr val="E08A4C"/>
+                </a:solidFill>
+                <a:latin typeface="Calibri"/>
+              </a:rPr>
+              <a:t>↺</a:t>
+            </a:r>
+          </a:p>
+        </p:txBody>
+      </p:sp>
+      <p:sp>
+        <p:nvSpPr>
+          <p:cNvPr id="20" name="Rounded Rectangle 19"/>
+          <p:cNvSpPr/>
+          <p:nvPr/>
+        </p:nvSpPr>
+        <p:spPr>
+          <a:xfrm>
+            <a:off x="10378440" y="2560320"/>
+            <a:ext cx="1554480" cy="960120"/>
+          </a:xfrm>
+          <a:prstGeom prst="roundRect">
+            <a:avLst>
+              <a:gd name="adj" fmla="val 6000"/>
+            </a:avLst>
+          </a:prstGeom>
+          <a:noFill/>
+          <a:ln w="12700">
+            <a:solidFill>
+              <a:srgbClr val="3A4A51"/>
+            </a:solidFill>
+          </a:ln>
+          <a:effectLst/>
+        </p:spPr>
+        <p:style>
+          <a:lnRef idx="1">
+            <a:schemeClr val="accent1"/>
+          </a:lnRef>
+          <a:fillRef idx="3">
+            <a:schemeClr val="accent1"/>
+          </a:fillRef>
+          <a:effectRef idx="2">
+            <a:schemeClr val="accent1"/>
+          </a:effectRef>
+          <a:fontRef idx="minor">
+            <a:schemeClr val="lt1"/>
+          </a:fontRef>
+        </p:style>
+        <p:txBody>
+          <a:bodyPr rtlCol="0" anchor="ctr"/>
+          <a:lstStyle/>
+          <a:p>
+            <a:pPr algn="ctr"/>
+          </a:p>
+        </p:txBody>
+      </p:sp>
+      <p:sp>
+        <p:nvSpPr>
+          <p:cNvPr id="21" name="TextBox 20"/>
+          <p:cNvSpPr txBox="1"/>
+          <p:nvPr/>
+        </p:nvSpPr>
+        <p:spPr>
+          <a:xfrm>
+            <a:off x="10378440" y="2560320"/>
+            <a:ext cx="1554480" cy="960120"/>
+          </a:xfrm>
+          <a:prstGeom prst="rect">
+            <a:avLst/>
+          </a:prstGeom>
+          <a:noFill/>
+        </p:spPr>
+        <p:txBody>
+          <a:bodyPr wrap="square" anchor="ctr">
+            <a:spAutoFit/>
+          </a:bodyPr>
+          <a:lstStyle/>
+          <a:p>
+            <a:pPr algn="ctr">
+              <a:lnSpc>
+                <a:spcPct val="100000"/>
+              </a:lnSpc>
+              <a:spcAft>
+                <a:spcPts val="0"/>
+              </a:spcAft>
+            </a:pPr>
+            <a:r>
+              <a:rPr sz="1300" b="0">
+                <a:solidFill>
+                  <a:srgbClr val="9FB2B6"/>
+                </a:solidFill>
+                <a:latin typeface="Calibri"/>
+              </a:rPr>
+              <a:t>next recipe</a:t>
+            </a:r>
+          </a:p>
+        </p:txBody>
+      </p:sp>
+      <p:sp>
+        <p:nvSpPr>
+          <p:cNvPr id="22" name="Rounded Rectangle 21"/>
+          <p:cNvSpPr/>
+          <p:nvPr/>
+        </p:nvSpPr>
+        <p:spPr>
+          <a:xfrm>
+            <a:off x="640080" y="3977639"/>
+            <a:ext cx="10881360" cy="868680"/>
+          </a:xfrm>
+          <a:prstGeom prst="roundRect">
+            <a:avLst>
+              <a:gd name="adj" fmla="val 6000"/>
+            </a:avLst>
+          </a:prstGeom>
+          <a:solidFill>
+            <a:srgbClr val="221A11"/>
+          </a:solidFill>
+          <a:ln w="12700">
+            <a:solidFill>
+              <a:srgbClr val="5A4A2A"/>
+            </a:solidFill>
+          </a:ln>
+          <a:effectLst/>
+        </p:spPr>
+        <p:style>
+          <a:lnRef idx="1">
+            <a:schemeClr val="accent1"/>
+          </a:lnRef>
+          <a:fillRef idx="3">
+            <a:schemeClr val="accent1"/>
+          </a:fillRef>
+          <a:effectRef idx="2">
+            <a:schemeClr val="accent1"/>
+          </a:effectRef>
+          <a:fontRef idx="minor">
+            <a:schemeClr val="lt1"/>
+          </a:fontRef>
+        </p:style>
+        <p:txBody>
+          <a:bodyPr rtlCol="0" anchor="ctr"/>
+          <a:lstStyle/>
+          <a:p>
+            <a:pPr algn="ctr"/>
+          </a:p>
+        </p:txBody>
+      </p:sp>
+      <p:sp>
+        <p:nvSpPr>
+          <p:cNvPr id="23" name="TextBox 22"/>
+          <p:cNvSpPr txBox="1"/>
+          <p:nvPr/>
+        </p:nvSpPr>
+        <p:spPr>
+          <a:xfrm>
+            <a:off x="868680" y="3977639"/>
+            <a:ext cx="10424160" cy="868680"/>
+          </a:xfrm>
+          <a:prstGeom prst="rect">
+            <a:avLst/>
+          </a:prstGeom>
+          <a:noFill/>
+        </p:spPr>
+        <p:txBody>
+          <a:bodyPr wrap="square" anchor="ctr">
+            <a:spAutoFit/>
+          </a:bodyPr>
+          <a:lstStyle/>
+          <a:p>
+            <a:pPr algn="l">
+              <a:lnSpc>
+                <a:spcPct val="100000"/>
+              </a:lnSpc>
+              <a:spcAft>
+                <a:spcPts val="0"/>
+              </a:spcAft>
+            </a:pPr>
+            <a:r>
+              <a:rPr sz="1300" b="0">
+                <a:solidFill>
+                  <a:srgbClr val="E08A4C"/>
+                </a:solidFill>
+                <a:latin typeface="Consolas"/>
+              </a:rPr>
+              <a:t>SPEND-SAFETY · structural  —  idle watchdog · ledger at creation · sync-before-destroy · global deadline</a:t>
+            </a:r>
+          </a:p>
+        </p:txBody>
+      </p:sp>
+      <p:sp>
+        <p:nvSpPr>
+          <p:cNvPr id="24" name="TextBox 23"/>
+          <p:cNvSpPr txBox="1"/>
+          <p:nvPr/>
+        </p:nvSpPr>
+        <p:spPr>
+          <a:xfrm>
+            <a:off x="640080" y="5120640"/>
+            <a:ext cx="10881360" cy="731520"/>
           </a:xfrm>
           <a:prstGeom prst="rect">
             <a:avLst/>
@@ -3854,55 +4620,17 @@
                 <a:spcPct val="120000"/>
               </a:lnSpc>
               <a:spcAft>
-                <a:spcPts val="1200"/>
-              </a:spcAft>
-            </a:pPr>
-            <a:r>
-              <a:rPr sz="1550" b="0">
-                <a:solidFill>
-                  <a:srgbClr val="EEF3F3"/>
-                </a:solidFill>
-                <a:latin typeface="Calibri"/>
-              </a:rPr>
-              <a:t>An unattended, cost-guarded loop: provision a GPU → train → serve → evaluate → destroy, then the next recipe.</a:t>
-            </a:r>
-          </a:p>
-          <a:p>
-            <a:pPr algn="l">
-              <a:lnSpc>
-                <a:spcPct val="115000"/>
-              </a:lnSpc>
-              <a:spcAft>
-                <a:spcPts val="800"/>
-              </a:spcAft>
-            </a:pPr>
-            <a:r>
-              <a:rPr sz="1400" b="0">
-                <a:solidFill>
-                  <a:srgbClr val="EEF3F3"/>
-                </a:solidFill>
-                <a:latin typeface="Calibri"/>
-              </a:rPr>
-              <a:t>▪  Spend-safety is structural: idle watchdog, ledger, sync-before-destroy, global deadline.</a:t>
-            </a:r>
-          </a:p>
-          <a:p>
-            <a:pPr algn="l">
-              <a:lnSpc>
-                <a:spcPct val="115000"/>
-              </a:lnSpc>
-              <a:spcAft>
                 <a:spcPts val="0"/>
               </a:spcAft>
             </a:pPr>
             <a:r>
               <a:rPr sz="1400" b="0">
                 <a:solidFill>
-                  <a:srgbClr val="EEF3F3"/>
+                  <a:srgbClr val="9FB2B6"/>
                 </a:solidFill>
                 <a:latin typeface="Calibri"/>
               </a:rPr>
-              <a:t>▪  Makes the next model cheap to try — the capability outlasts this study.</a:t>
+              <a:t>One detached controller drives every recipe end to end, unattended. Makes the next model cheap to try — the capability outlasts this study.</a:t>
             </a:r>
           </a:p>
         </p:txBody>
@@ -6387,27 +7115,23 @@
       </p:sp>
       <p:sp>
         <p:nvSpPr>
-          <p:cNvPr id="5" name="Rounded Rectangle 4"/>
+          <p:cNvPr id="5" name="Rectangle 4"/>
           <p:cNvSpPr/>
           <p:nvPr/>
         </p:nvSpPr>
         <p:spPr>
           <a:xfrm>
-            <a:off x="530352" y="1856231"/>
-            <a:ext cx="6803136" cy="2465652"/>
-          </a:xfrm>
-          <a:prstGeom prst="roundRect">
-            <a:avLst>
-              <a:gd name="adj" fmla="val 6000"/>
-            </a:avLst>
+            <a:off x="640080" y="2286000"/>
+            <a:ext cx="8460028" cy="1051560"/>
+          </a:xfrm>
+          <a:prstGeom prst="rect">
+            <a:avLst/>
           </a:prstGeom>
           <a:solidFill>
-            <a:srgbClr val="FFFFFF"/>
+            <a:srgbClr val="1F5F6E"/>
           </a:solidFill>
-          <a:ln w="12700">
-            <a:solidFill>
-              <a:srgbClr val="25333A"/>
-            </a:solidFill>
+          <a:ln>
+            <a:noFill/>
           </a:ln>
           <a:effectLst/>
         </p:spPr>
@@ -6433,51 +7157,46 @@
           </a:p>
         </p:txBody>
       </p:sp>
-      <p:pic>
-        <p:nvPicPr>
-          <p:cNvPr id="6" name="Picture 5" descr="fig_span.png"/>
-          <p:cNvPicPr>
-            <a:picLocks noChangeAspect="1"/>
-          </p:cNvPicPr>
-          <p:nvPr/>
-        </p:nvPicPr>
-        <p:blipFill>
-          <a:blip r:embed="rId2"/>
-          <a:stretch>
-            <a:fillRect/>
-          </a:stretch>
-        </p:blipFill>
-        <p:spPr>
-          <a:xfrm>
-            <a:off x="640080" y="1965960"/>
-            <a:ext cx="6583680" cy="2246197"/>
+      <p:sp>
+        <p:nvSpPr>
+          <p:cNvPr id="6" name="TextBox 5"/>
+          <p:cNvSpPr txBox="1"/>
+          <p:nvPr/>
+        </p:nvSpPr>
+        <p:spPr>
+          <a:xfrm>
+            <a:off x="804671" y="2286000"/>
+            <a:ext cx="8158276" cy="1051560"/>
           </a:xfrm>
           <a:prstGeom prst="rect">
             <a:avLst/>
           </a:prstGeom>
-        </p:spPr>
-      </p:pic>
-      <p:sp>
-        <p:nvSpPr>
-          <p:cNvPr id="7" name="TextBox 6"/>
-          <p:cNvSpPr txBox="1"/>
-          <p:nvPr/>
-        </p:nvSpPr>
-        <p:spPr>
-          <a:xfrm>
-            <a:off x="7680960" y="1965960"/>
-            <a:ext cx="3840480" cy="640080"/>
-          </a:xfrm>
-          <a:prstGeom prst="rect">
-            <a:avLst/>
-          </a:prstGeom>
           <a:noFill/>
         </p:spPr>
         <p:txBody>
-          <a:bodyPr wrap="square" anchor="t">
+          <a:bodyPr wrap="square" anchor="ctr">
             <a:spAutoFit/>
           </a:bodyPr>
           <a:lstStyle/>
+          <a:p>
+            <a:pPr algn="l">
+              <a:lnSpc>
+                <a:spcPct val="100000"/>
+              </a:lnSpc>
+              <a:spcAft>
+                <a:spcPts val="200"/>
+              </a:spcAft>
+            </a:pPr>
+            <a:r>
+              <a:rPr sz="1400" b="1">
+                <a:solidFill>
+                  <a:srgbClr val="FFFFFF"/>
+                </a:solidFill>
+                <a:latin typeface="Calibri"/>
+              </a:rPr>
+              <a:t>Tool schemas</a:t>
+            </a:r>
+          </a:p>
           <a:p>
             <a:pPr algn="l">
               <a:lnSpc>
@@ -6488,14 +7207,58 @@
               </a:spcAft>
             </a:pPr>
             <a:r>
-              <a:rPr sz="3000" b="1">
-                <a:solidFill>
-                  <a:srgbClr val="E08A4C"/>
-                </a:solidFill>
-                <a:latin typeface="Consolas"/>
+              <a:rPr sz="1000" b="0">
+                <a:solidFill>
+                  <a:srgbClr val="FFFFFF"/>
+                </a:solidFill>
+                <a:latin typeface="Calibri"/>
               </a:rPr>
-              <a:t>17.5–21k</a:t>
-            </a:r>
+              <a:t>~16,000 tokens  ·  &gt;90% of the block</a:t>
+            </a:r>
+          </a:p>
+        </p:txBody>
+      </p:sp>
+      <p:sp>
+        <p:nvSpPr>
+          <p:cNvPr id="7" name="Rectangle 6"/>
+          <p:cNvSpPr/>
+          <p:nvPr/>
+        </p:nvSpPr>
+        <p:spPr>
+          <a:xfrm>
+            <a:off x="9127540" y="2286000"/>
+            <a:ext cx="951890" cy="1051560"/>
+          </a:xfrm>
+          <a:prstGeom prst="rect">
+            <a:avLst/>
+          </a:prstGeom>
+          <a:solidFill>
+            <a:srgbClr val="E08A4C"/>
+          </a:solidFill>
+          <a:ln>
+            <a:noFill/>
+          </a:ln>
+          <a:effectLst/>
+        </p:spPr>
+        <p:style>
+          <a:lnRef idx="1">
+            <a:schemeClr val="accent1"/>
+          </a:lnRef>
+          <a:fillRef idx="3">
+            <a:schemeClr val="accent1"/>
+          </a:fillRef>
+          <a:effectRef idx="2">
+            <a:schemeClr val="accent1"/>
+          </a:effectRef>
+          <a:fontRef idx="minor">
+            <a:schemeClr val="lt1"/>
+          </a:fontRef>
+        </p:style>
+        <p:txBody>
+          <a:bodyPr rtlCol="0" anchor="ctr"/>
+          <a:lstStyle/>
+          <a:p>
+            <a:pPr algn="ctr"/>
           </a:p>
         </p:txBody>
       </p:sp>
@@ -6507,8 +7270,8 @@
         </p:nvSpPr>
         <p:spPr>
           <a:xfrm>
-            <a:off x="7680960" y="2532888"/>
-            <a:ext cx="3840480" cy="457200"/>
+            <a:off x="9292132" y="2286000"/>
+            <a:ext cx="650138" cy="1051560"/>
           </a:xfrm>
           <a:prstGeom prst="rect">
             <a:avLst/>
@@ -6516,10 +7279,29 @@
           <a:noFill/>
         </p:spPr>
         <p:txBody>
-          <a:bodyPr wrap="square" anchor="t">
+          <a:bodyPr wrap="square" anchor="ctr">
             <a:spAutoFit/>
           </a:bodyPr>
           <a:lstStyle/>
+          <a:p>
+            <a:pPr algn="l">
+              <a:lnSpc>
+                <a:spcPct val="100000"/>
+              </a:lnSpc>
+              <a:spcAft>
+                <a:spcPts val="200"/>
+              </a:spcAft>
+            </a:pPr>
+            <a:r>
+              <a:rPr sz="1100" b="1">
+                <a:solidFill>
+                  <a:srgbClr val="FFFFFF"/>
+                </a:solidFill>
+                <a:latin typeface="Calibri"/>
+              </a:rPr>
+              <a:t>Rules</a:t>
+            </a:r>
+          </a:p>
           <a:p>
             <a:pPr algn="l">
               <a:lnSpc>
@@ -6530,38 +7312,101 @@
               </a:spcAft>
             </a:pPr>
             <a:r>
-              <a:rPr sz="1200" b="0">
-                <a:solidFill>
-                  <a:srgbClr val="9FB2B6"/>
-                </a:solidFill>
-                <a:latin typeface="Consolas"/>
+              <a:rPr sz="850" b="0">
+                <a:solidFill>
+                  <a:srgbClr val="FFFFFF"/>
+                </a:solidFill>
+                <a:latin typeface="Calibri"/>
               </a:rPr>
-              <a:t>fixed tokens per turn</a:t>
-            </a:r>
-          </a:p>
-        </p:txBody>
-      </p:sp>
-      <p:sp>
-        <p:nvSpPr>
-          <p:cNvPr id="9" name="TextBox 8"/>
-          <p:cNvSpPr txBox="1"/>
-          <p:nvPr/>
-        </p:nvSpPr>
-        <p:spPr>
-          <a:xfrm>
-            <a:off x="7680960" y="3063240"/>
-            <a:ext cx="3840480" cy="640080"/>
+              <a:t>~1.3k</a:t>
+            </a:r>
+          </a:p>
+        </p:txBody>
+      </p:sp>
+      <p:sp>
+        <p:nvSpPr>
+          <p:cNvPr id="9" name="Rectangle 8"/>
+          <p:cNvSpPr/>
+          <p:nvPr/>
+        </p:nvSpPr>
+        <p:spPr>
+          <a:xfrm>
+            <a:off x="10106863" y="2286000"/>
+            <a:ext cx="1387144" cy="1051560"/>
           </a:xfrm>
           <a:prstGeom prst="rect">
             <a:avLst/>
           </a:prstGeom>
+          <a:solidFill>
+            <a:srgbClr val="2B3A41"/>
+          </a:solidFill>
+          <a:ln>
+            <a:noFill/>
+          </a:ln>
+          <a:effectLst/>
+        </p:spPr>
+        <p:style>
+          <a:lnRef idx="1">
+            <a:schemeClr val="accent1"/>
+          </a:lnRef>
+          <a:fillRef idx="3">
+            <a:schemeClr val="accent1"/>
+          </a:fillRef>
+          <a:effectRef idx="2">
+            <a:schemeClr val="accent1"/>
+          </a:effectRef>
+          <a:fontRef idx="minor">
+            <a:schemeClr val="lt1"/>
+          </a:fontRef>
+        </p:style>
+        <p:txBody>
+          <a:bodyPr rtlCol="0" anchor="ctr"/>
+          <a:lstStyle/>
+          <a:p>
+            <a:pPr algn="ctr"/>
+          </a:p>
+        </p:txBody>
+      </p:sp>
+      <p:sp>
+        <p:nvSpPr>
+          <p:cNvPr id="10" name="TextBox 9"/>
+          <p:cNvSpPr txBox="1"/>
+          <p:nvPr/>
+        </p:nvSpPr>
+        <p:spPr>
+          <a:xfrm>
+            <a:off x="10271455" y="2286000"/>
+            <a:ext cx="1085392" cy="1051560"/>
+          </a:xfrm>
+          <a:prstGeom prst="rect">
+            <a:avLst/>
+          </a:prstGeom>
           <a:noFill/>
         </p:spPr>
         <p:txBody>
-          <a:bodyPr wrap="square" anchor="t">
+          <a:bodyPr wrap="square" anchor="ctr">
             <a:spAutoFit/>
           </a:bodyPr>
           <a:lstStyle/>
+          <a:p>
+            <a:pPr algn="l">
+              <a:lnSpc>
+                <a:spcPct val="100000"/>
+              </a:lnSpc>
+              <a:spcAft>
+                <a:spcPts val="200"/>
+              </a:spcAft>
+            </a:pPr>
+            <a:r>
+              <a:rPr sz="1100" b="1">
+                <a:solidFill>
+                  <a:srgbClr val="FFFFFF"/>
+                </a:solidFill>
+                <a:latin typeface="Calibri"/>
+              </a:rPr>
+              <a:t>Per-session</a:t>
+            </a:r>
+          </a:p>
           <a:p>
             <a:pPr algn="l">
               <a:lnSpc>
@@ -6572,27 +7417,27 @@
               </a:spcAft>
             </a:pPr>
             <a:r>
-              <a:rPr sz="3000" b="1">
-                <a:solidFill>
-                  <a:srgbClr val="E08A4C"/>
-                </a:solidFill>
-                <a:latin typeface="Consolas"/>
+              <a:rPr sz="850" b="0">
+                <a:solidFill>
+                  <a:srgbClr val="FFFFFF"/>
+                </a:solidFill>
+                <a:latin typeface="Calibri"/>
               </a:rPr>
-              <a:t>&gt;90%</a:t>
-            </a:r>
-          </a:p>
-        </p:txBody>
-      </p:sp>
-      <p:sp>
-        <p:nvSpPr>
-          <p:cNvPr id="10" name="TextBox 9"/>
+              <a:t>kept raw</a:t>
+            </a:r>
+          </a:p>
+        </p:txBody>
+      </p:sp>
+      <p:sp>
+        <p:nvSpPr>
+          <p:cNvPr id="11" name="TextBox 10"/>
           <p:cNvSpPr txBox="1"/>
           <p:nvPr/>
         </p:nvSpPr>
         <p:spPr>
           <a:xfrm>
-            <a:off x="7680960" y="3630168"/>
-            <a:ext cx="3840480" cy="457200"/>
+            <a:off x="640080" y="3886200"/>
+            <a:ext cx="3474720" cy="640080"/>
           </a:xfrm>
           <a:prstGeom prst="rect">
             <a:avLst/>
@@ -6614,27 +7459,27 @@
               </a:spcAft>
             </a:pPr>
             <a:r>
-              <a:rPr sz="1200" b="0">
-                <a:solidFill>
-                  <a:srgbClr val="9FB2B6"/>
+              <a:rPr sz="3000" b="1">
+                <a:solidFill>
+                  <a:srgbClr val="E08A4C"/>
                 </a:solidFill>
                 <a:latin typeface="Consolas"/>
               </a:rPr>
-              <a:t>is tool schemas, not rules</a:t>
-            </a:r>
-          </a:p>
-        </p:txBody>
-      </p:sp>
-      <p:sp>
-        <p:nvSpPr>
-          <p:cNvPr id="11" name="TextBox 10"/>
+              <a:t>17.5–21k</a:t>
+            </a:r>
+          </a:p>
+        </p:txBody>
+      </p:sp>
+      <p:sp>
+        <p:nvSpPr>
+          <p:cNvPr id="12" name="TextBox 11"/>
           <p:cNvSpPr txBox="1"/>
           <p:nvPr/>
         </p:nvSpPr>
         <p:spPr>
           <a:xfrm>
-            <a:off x="7680960" y="4160520"/>
-            <a:ext cx="3840480" cy="640080"/>
+            <a:off x="640080" y="4453128"/>
+            <a:ext cx="3474720" cy="457200"/>
           </a:xfrm>
           <a:prstGeom prst="rect">
             <a:avLst/>
@@ -6656,27 +7501,27 @@
               </a:spcAft>
             </a:pPr>
             <a:r>
-              <a:rPr sz="3000" b="1">
-                <a:solidFill>
-                  <a:srgbClr val="3FB0C6"/>
+              <a:rPr sz="1200" b="0">
+                <a:solidFill>
+                  <a:srgbClr val="9FB2B6"/>
                 </a:solidFill>
                 <a:latin typeface="Consolas"/>
               </a:rPr>
-              <a:t>0.72</a:t>
-            </a:r>
-          </a:p>
-        </p:txBody>
-      </p:sp>
-      <p:sp>
-        <p:nvSpPr>
-          <p:cNvPr id="12" name="TextBox 11"/>
+              <a:t>fixed tokens per turn</a:t>
+            </a:r>
+          </a:p>
+        </p:txBody>
+      </p:sp>
+      <p:sp>
+        <p:nvSpPr>
+          <p:cNvPr id="13" name="TextBox 12"/>
           <p:cNvSpPr txBox="1"/>
           <p:nvPr/>
         </p:nvSpPr>
         <p:spPr>
           <a:xfrm>
-            <a:off x="7680960" y="4727448"/>
-            <a:ext cx="3840480" cy="457200"/>
+            <a:off x="4297680" y="3886200"/>
+            <a:ext cx="3474720" cy="640080"/>
           </a:xfrm>
           <a:prstGeom prst="rect">
             <a:avLst/>
@@ -6698,27 +7543,27 @@
               </a:spcAft>
             </a:pPr>
             <a:r>
-              <a:rPr sz="1200" b="0">
-                <a:solidFill>
-                  <a:srgbClr val="9FB2B6"/>
+              <a:rPr sz="3000" b="1">
+                <a:solidFill>
+                  <a:srgbClr val="E08A4C"/>
                 </a:solidFill>
                 <a:latin typeface="Consolas"/>
               </a:rPr>
-              <a:t>of a short session’s input</a:t>
-            </a:r>
-          </a:p>
-        </p:txBody>
-      </p:sp>
-      <p:sp>
-        <p:nvSpPr>
-          <p:cNvPr id="13" name="TextBox 12"/>
+              <a:t>&gt;90%</a:t>
+            </a:r>
+          </a:p>
+        </p:txBody>
+      </p:sp>
+      <p:sp>
+        <p:nvSpPr>
+          <p:cNvPr id="14" name="TextBox 13"/>
           <p:cNvSpPr txBox="1"/>
           <p:nvPr/>
         </p:nvSpPr>
         <p:spPr>
           <a:xfrm>
-            <a:off x="7680960" y="5029200"/>
-            <a:ext cx="3840480" cy="1280160"/>
+            <a:off x="4297680" y="4453128"/>
+            <a:ext cx="3474720" cy="457200"/>
           </a:xfrm>
           <a:prstGeom prst="rect">
             <a:avLst/>
@@ -6733,7 +7578,7 @@
           <a:p>
             <a:pPr algn="l">
               <a:lnSpc>
-                <a:spcPct val="120000"/>
+                <a:spcPct val="100000"/>
               </a:lnSpc>
               <a:spcAft>
                 <a:spcPts val="0"/>
@@ -6744,9 +7589,135 @@
                 <a:solidFill>
                   <a:srgbClr val="9FB2B6"/>
                 </a:solidFill>
+                <a:latin typeface="Consolas"/>
+              </a:rPr>
+              <a:t>is tool schemas, not rules</a:t>
+            </a:r>
+          </a:p>
+        </p:txBody>
+      </p:sp>
+      <p:sp>
+        <p:nvSpPr>
+          <p:cNvPr id="15" name="TextBox 14"/>
+          <p:cNvSpPr txBox="1"/>
+          <p:nvPr/>
+        </p:nvSpPr>
+        <p:spPr>
+          <a:xfrm>
+            <a:off x="7955279" y="3886200"/>
+            <a:ext cx="3474720" cy="640080"/>
+          </a:xfrm>
+          <a:prstGeom prst="rect">
+            <a:avLst/>
+          </a:prstGeom>
+          <a:noFill/>
+        </p:spPr>
+        <p:txBody>
+          <a:bodyPr wrap="square" anchor="t">
+            <a:spAutoFit/>
+          </a:bodyPr>
+          <a:lstStyle/>
+          <a:p>
+            <a:pPr algn="l">
+              <a:lnSpc>
+                <a:spcPct val="100000"/>
+              </a:lnSpc>
+              <a:spcAft>
+                <a:spcPts val="0"/>
+              </a:spcAft>
+            </a:pPr>
+            <a:r>
+              <a:rPr sz="3000" b="1">
+                <a:solidFill>
+                  <a:srgbClr val="3FB0C6"/>
+                </a:solidFill>
+                <a:latin typeface="Consolas"/>
+              </a:rPr>
+              <a:t>0.72</a:t>
+            </a:r>
+          </a:p>
+        </p:txBody>
+      </p:sp>
+      <p:sp>
+        <p:nvSpPr>
+          <p:cNvPr id="16" name="TextBox 15"/>
+          <p:cNvSpPr txBox="1"/>
+          <p:nvPr/>
+        </p:nvSpPr>
+        <p:spPr>
+          <a:xfrm>
+            <a:off x="7955279" y="4453128"/>
+            <a:ext cx="3474720" cy="457200"/>
+          </a:xfrm>
+          <a:prstGeom prst="rect">
+            <a:avLst/>
+          </a:prstGeom>
+          <a:noFill/>
+        </p:spPr>
+        <p:txBody>
+          <a:bodyPr wrap="square" anchor="t">
+            <a:spAutoFit/>
+          </a:bodyPr>
+          <a:lstStyle/>
+          <a:p>
+            <a:pPr algn="l">
+              <a:lnSpc>
+                <a:spcPct val="100000"/>
+              </a:lnSpc>
+              <a:spcAft>
+                <a:spcPts val="0"/>
+              </a:spcAft>
+            </a:pPr>
+            <a:r>
+              <a:rPr sz="1200" b="0">
+                <a:solidFill>
+                  <a:srgbClr val="9FB2B6"/>
+                </a:solidFill>
+                <a:latin typeface="Consolas"/>
+              </a:rPr>
+              <a:t>of a short session’s input</a:t>
+            </a:r>
+          </a:p>
+        </p:txBody>
+      </p:sp>
+      <p:sp>
+        <p:nvSpPr>
+          <p:cNvPr id="17" name="TextBox 16"/>
+          <p:cNvSpPr txBox="1"/>
+          <p:nvPr/>
+        </p:nvSpPr>
+        <p:spPr>
+          <a:xfrm>
+            <a:off x="640080" y="5212080"/>
+            <a:ext cx="10881360" cy="548640"/>
+          </a:xfrm>
+          <a:prstGeom prst="rect">
+            <a:avLst/>
+          </a:prstGeom>
+          <a:noFill/>
+        </p:spPr>
+        <p:txBody>
+          <a:bodyPr wrap="square" anchor="t">
+            <a:spAutoFit/>
+          </a:bodyPr>
+          <a:lstStyle/>
+          <a:p>
+            <a:pPr algn="l">
+              <a:lnSpc>
+                <a:spcPct val="100000"/>
+              </a:lnSpc>
+              <a:spcAft>
+                <a:spcPts val="0"/>
+              </a:spcAft>
+            </a:pPr>
+            <a:r>
+              <a:rPr sz="1300" b="0">
+                <a:solidFill>
+                  <a:srgbClr val="9FB2B6"/>
+                </a:solidFill>
                 <a:latin typeface="Calibri"/>
               </a:rPr>
-              <a:t>Recovered from real logged sessions: the span that is byte-identical across sessions, split from per-session values (paths, git status, date) that stay raw.</a:t>
+              <a:t>The same block, byte-for-byte, on every turn. Per-session values (paths, git status, date) are split out and kept raw.</a:t>
             </a:r>
           </a:p>
         </p:txBody>
@@ -6905,8 +7876,8 @@
         </p:nvSpPr>
         <p:spPr>
           <a:xfrm>
-            <a:off x="530352" y="1856231"/>
-            <a:ext cx="6986016" cy="3106521"/>
+            <a:off x="640080" y="2468880"/>
+            <a:ext cx="3383280" cy="2926080"/>
           </a:xfrm>
           <a:prstGeom prst="roundRect">
             <a:avLst>
@@ -6914,7 +7885,7 @@
             </a:avLst>
           </a:prstGeom>
           <a:solidFill>
-            <a:srgbClr val="FFFFFF"/>
+            <a:srgbClr val="141D21"/>
           </a:solidFill>
           <a:ln w="12700">
             <a:solidFill>
@@ -6945,40 +7916,16 @@
           </a:p>
         </p:txBody>
       </p:sp>
-      <p:pic>
-        <p:nvPicPr>
-          <p:cNvPr id="6" name="Picture 5" descr="fig2_method.png"/>
-          <p:cNvPicPr>
-            <a:picLocks noChangeAspect="1"/>
-          </p:cNvPicPr>
-          <p:nvPr/>
-        </p:nvPicPr>
-        <p:blipFill>
-          <a:blip r:embed="rId2"/>
-          <a:stretch>
-            <a:fillRect/>
-          </a:stretch>
-        </p:blipFill>
-        <p:spPr>
-          <a:xfrm>
-            <a:off x="640080" y="1965960"/>
-            <a:ext cx="6766560" cy="2887066"/>
-          </a:xfrm>
-          <a:prstGeom prst="rect">
-            <a:avLst/>
-          </a:prstGeom>
-        </p:spPr>
-      </p:pic>
-      <p:sp>
-        <p:nvSpPr>
-          <p:cNvPr id="7" name="TextBox 6"/>
+      <p:sp>
+        <p:nvSpPr>
+          <p:cNvPr id="6" name="TextBox 5"/>
           <p:cNvSpPr txBox="1"/>
           <p:nvPr/>
         </p:nvSpPr>
         <p:spPr>
           <a:xfrm>
-            <a:off x="7863840" y="2011680"/>
-            <a:ext cx="3657600" cy="4206240"/>
+            <a:off x="932688" y="2761488"/>
+            <a:ext cx="2798064" cy="2340864"/>
           </a:xfrm>
           <a:prstGeom prst="rect">
             <a:avLst/>
@@ -6993,77 +7940,39 @@
           <a:p>
             <a:pPr algn="l">
               <a:lnSpc>
-                <a:spcPct val="115000"/>
+                <a:spcPct val="100000"/>
+              </a:lnSpc>
+              <a:spcAft>
+                <a:spcPts val="600"/>
+              </a:spcAft>
+            </a:pPr>
+            <a:r>
+              <a:rPr sz="1200" b="1">
+                <a:solidFill>
+                  <a:srgbClr val="3FB0C6"/>
+                </a:solidFill>
+                <a:latin typeface="Consolas"/>
+              </a:rPr>
+              <a:t>01</a:t>
+            </a:r>
+          </a:p>
+          <a:p>
+            <a:pPr algn="l">
+              <a:lnSpc>
+                <a:spcPct val="100000"/>
               </a:lnSpc>
               <a:spcAft>
                 <a:spcPts val="1000"/>
               </a:spcAft>
             </a:pPr>
             <a:r>
-              <a:rPr sz="1500" b="0">
-                <a:solidFill>
-                  <a:srgbClr val="EEF3F3"/>
-                </a:solidFill>
-                <a:latin typeface="Calibri"/>
+              <a:rPr sz="2000" b="1">
+                <a:solidFill>
+                  <a:srgbClr val="FFFFFF"/>
+                </a:solidFill>
+                <a:latin typeface="Georgia"/>
               </a:rPr>
-              <a:t>▪  Grow the vocabulary with gist tokens, seeded from the block they replace.</a:t>
-            </a:r>
-          </a:p>
-          <a:p>
-            <a:pPr algn="l">
-              <a:lnSpc>
-                <a:spcPct val="115000"/>
-              </a:lnSpc>
-              <a:spcAft>
-                <a:spcPts val="1000"/>
-              </a:spcAft>
-            </a:pPr>
-            <a:r>
-              <a:rPr sz="1500" b="0">
-                <a:solidFill>
-                  <a:srgbClr val="EEF3F3"/>
-                </a:solidFill>
-                <a:latin typeface="Calibri"/>
-              </a:rPr>
-              <a:t>▪  Self-distillation: the model matches its own behaviour, short gist vs. full block.</a:t>
-            </a:r>
-          </a:p>
-          <a:p>
-            <a:pPr algn="l">
-              <a:lnSpc>
-                <a:spcPct val="115000"/>
-              </a:lnSpc>
-              <a:spcAft>
-                <a:spcPts val="1000"/>
-              </a:spcAft>
-            </a:pPr>
-            <a:r>
-              <a:rPr sz="1500" b="0">
-                <a:solidFill>
-                  <a:srgbClr val="EEF3F3"/>
-                </a:solidFill>
-                <a:latin typeface="Calibri"/>
-              </a:rPr>
-              <a:t>▪  All base weights frozen — only the new embedding rows are trained.</a:t>
-            </a:r>
-          </a:p>
-          <a:p>
-            <a:pPr algn="l">
-              <a:lnSpc>
-                <a:spcPct val="115000"/>
-              </a:lnSpc>
-              <a:spcAft>
-                <a:spcPts val="1000"/>
-              </a:spcAft>
-            </a:pPr>
-            <a:r>
-              <a:rPr sz="1500" b="0">
-                <a:solidFill>
-                  <a:srgbClr val="EEF3F3"/>
-                </a:solidFill>
-                <a:latin typeface="Calibri"/>
-              </a:rPr>
-              <a:t>▪  Proxy-only deployment: no change to the client or the inference engine.</a:t>
+              <a:t>Grow the vocabulary</a:t>
             </a:r>
           </a:p>
           <a:p>
@@ -7076,13 +7985,395 @@
               </a:spcAft>
             </a:pPr>
             <a:r>
-              <a:rPr sz="1250" b="0">
+              <a:rPr sz="1400" b="0">
                 <a:solidFill>
                   <a:srgbClr val="9FB2B6"/>
                 </a:solidFill>
                 <a:latin typeface="Calibri"/>
               </a:rPr>
-              <a:t>The only trained object is a small embedding tensor. Cheap to produce, cheap to serve.</a:t>
+              <a:t>Add a few thousand new “gist” tokens, seeded from the block they replace.</a:t>
+            </a:r>
+          </a:p>
+        </p:txBody>
+      </p:sp>
+      <p:sp>
+        <p:nvSpPr>
+          <p:cNvPr id="7" name="TextBox 6"/>
+          <p:cNvSpPr txBox="1"/>
+          <p:nvPr/>
+        </p:nvSpPr>
+        <p:spPr>
+          <a:xfrm>
+            <a:off x="4005072" y="3611880"/>
+            <a:ext cx="411479" cy="640080"/>
+          </a:xfrm>
+          <a:prstGeom prst="rect">
+            <a:avLst/>
+          </a:prstGeom>
+          <a:noFill/>
+        </p:spPr>
+        <p:txBody>
+          <a:bodyPr wrap="square" anchor="ctr">
+            <a:spAutoFit/>
+          </a:bodyPr>
+          <a:lstStyle/>
+          <a:p>
+            <a:pPr algn="ctr">
+              <a:lnSpc>
+                <a:spcPct val="100000"/>
+              </a:lnSpc>
+              <a:spcAft>
+                <a:spcPts val="0"/>
+              </a:spcAft>
+            </a:pPr>
+            <a:r>
+              <a:rPr sz="2600" b="1">
+                <a:solidFill>
+                  <a:srgbClr val="3FB0C6"/>
+                </a:solidFill>
+                <a:latin typeface="Calibri"/>
+              </a:rPr>
+              <a:t>→</a:t>
+            </a:r>
+          </a:p>
+        </p:txBody>
+      </p:sp>
+      <p:sp>
+        <p:nvSpPr>
+          <p:cNvPr id="8" name="Rounded Rectangle 7"/>
+          <p:cNvSpPr/>
+          <p:nvPr/>
+        </p:nvSpPr>
+        <p:spPr>
+          <a:xfrm>
+            <a:off x="4343400" y="2468880"/>
+            <a:ext cx="3383280" cy="2926080"/>
+          </a:xfrm>
+          <a:prstGeom prst="roundRect">
+            <a:avLst>
+              <a:gd name="adj" fmla="val 6000"/>
+            </a:avLst>
+          </a:prstGeom>
+          <a:solidFill>
+            <a:srgbClr val="141D21"/>
+          </a:solidFill>
+          <a:ln w="12700">
+            <a:solidFill>
+              <a:srgbClr val="25333A"/>
+            </a:solidFill>
+          </a:ln>
+          <a:effectLst/>
+        </p:spPr>
+        <p:style>
+          <a:lnRef idx="1">
+            <a:schemeClr val="accent1"/>
+          </a:lnRef>
+          <a:fillRef idx="3">
+            <a:schemeClr val="accent1"/>
+          </a:fillRef>
+          <a:effectRef idx="2">
+            <a:schemeClr val="accent1"/>
+          </a:effectRef>
+          <a:fontRef idx="minor">
+            <a:schemeClr val="lt1"/>
+          </a:fontRef>
+        </p:style>
+        <p:txBody>
+          <a:bodyPr rtlCol="0" anchor="ctr"/>
+          <a:lstStyle/>
+          <a:p>
+            <a:pPr algn="ctr"/>
+          </a:p>
+        </p:txBody>
+      </p:sp>
+      <p:sp>
+        <p:nvSpPr>
+          <p:cNvPr id="9" name="TextBox 8"/>
+          <p:cNvSpPr txBox="1"/>
+          <p:nvPr/>
+        </p:nvSpPr>
+        <p:spPr>
+          <a:xfrm>
+            <a:off x="4636008" y="2761488"/>
+            <a:ext cx="2798064" cy="2340864"/>
+          </a:xfrm>
+          <a:prstGeom prst="rect">
+            <a:avLst/>
+          </a:prstGeom>
+          <a:noFill/>
+        </p:spPr>
+        <p:txBody>
+          <a:bodyPr wrap="square" anchor="t">
+            <a:spAutoFit/>
+          </a:bodyPr>
+          <a:lstStyle/>
+          <a:p>
+            <a:pPr algn="l">
+              <a:lnSpc>
+                <a:spcPct val="100000"/>
+              </a:lnSpc>
+              <a:spcAft>
+                <a:spcPts val="600"/>
+              </a:spcAft>
+            </a:pPr>
+            <a:r>
+              <a:rPr sz="1200" b="1">
+                <a:solidFill>
+                  <a:srgbClr val="3FB0C6"/>
+                </a:solidFill>
+                <a:latin typeface="Consolas"/>
+              </a:rPr>
+              <a:t>02</a:t>
+            </a:r>
+          </a:p>
+          <a:p>
+            <a:pPr algn="l">
+              <a:lnSpc>
+                <a:spcPct val="100000"/>
+              </a:lnSpc>
+              <a:spcAft>
+                <a:spcPts val="1000"/>
+              </a:spcAft>
+            </a:pPr>
+            <a:r>
+              <a:rPr sz="2000" b="1">
+                <a:solidFill>
+                  <a:srgbClr val="FFFFFF"/>
+                </a:solidFill>
+                <a:latin typeface="Georgia"/>
+              </a:rPr>
+              <a:t>Self-distil</a:t>
+            </a:r>
+          </a:p>
+          <a:p>
+            <a:pPr algn="l">
+              <a:lnSpc>
+                <a:spcPct val="120000"/>
+              </a:lnSpc>
+              <a:spcAft>
+                <a:spcPts val="0"/>
+              </a:spcAft>
+            </a:pPr>
+            <a:r>
+              <a:rPr sz="1400" b="0">
+                <a:solidFill>
+                  <a:srgbClr val="9FB2B6"/>
+                </a:solidFill>
+                <a:latin typeface="Calibri"/>
+              </a:rPr>
+              <a:t>The model matches its own behaviour — short gist vs. full block. All base weights frozen; only the new rows train.</a:t>
+            </a:r>
+          </a:p>
+        </p:txBody>
+      </p:sp>
+      <p:sp>
+        <p:nvSpPr>
+          <p:cNvPr id="10" name="TextBox 9"/>
+          <p:cNvSpPr txBox="1"/>
+          <p:nvPr/>
+        </p:nvSpPr>
+        <p:spPr>
+          <a:xfrm>
+            <a:off x="7708392" y="3611880"/>
+            <a:ext cx="411479" cy="640080"/>
+          </a:xfrm>
+          <a:prstGeom prst="rect">
+            <a:avLst/>
+          </a:prstGeom>
+          <a:noFill/>
+        </p:spPr>
+        <p:txBody>
+          <a:bodyPr wrap="square" anchor="ctr">
+            <a:spAutoFit/>
+          </a:bodyPr>
+          <a:lstStyle/>
+          <a:p>
+            <a:pPr algn="ctr">
+              <a:lnSpc>
+                <a:spcPct val="100000"/>
+              </a:lnSpc>
+              <a:spcAft>
+                <a:spcPts val="0"/>
+              </a:spcAft>
+            </a:pPr>
+            <a:r>
+              <a:rPr sz="2600" b="1">
+                <a:solidFill>
+                  <a:srgbClr val="3FB0C6"/>
+                </a:solidFill>
+                <a:latin typeface="Calibri"/>
+              </a:rPr>
+              <a:t>→</a:t>
+            </a:r>
+          </a:p>
+        </p:txBody>
+      </p:sp>
+      <p:sp>
+        <p:nvSpPr>
+          <p:cNvPr id="11" name="Rounded Rectangle 10"/>
+          <p:cNvSpPr/>
+          <p:nvPr/>
+        </p:nvSpPr>
+        <p:spPr>
+          <a:xfrm>
+            <a:off x="8046719" y="2468880"/>
+            <a:ext cx="3383280" cy="2926080"/>
+          </a:xfrm>
+          <a:prstGeom prst="roundRect">
+            <a:avLst>
+              <a:gd name="adj" fmla="val 6000"/>
+            </a:avLst>
+          </a:prstGeom>
+          <a:solidFill>
+            <a:srgbClr val="141D21"/>
+          </a:solidFill>
+          <a:ln w="12700">
+            <a:solidFill>
+              <a:srgbClr val="25333A"/>
+            </a:solidFill>
+          </a:ln>
+          <a:effectLst/>
+        </p:spPr>
+        <p:style>
+          <a:lnRef idx="1">
+            <a:schemeClr val="accent1"/>
+          </a:lnRef>
+          <a:fillRef idx="3">
+            <a:schemeClr val="accent1"/>
+          </a:fillRef>
+          <a:effectRef idx="2">
+            <a:schemeClr val="accent1"/>
+          </a:effectRef>
+          <a:fontRef idx="minor">
+            <a:schemeClr val="lt1"/>
+          </a:fontRef>
+        </p:style>
+        <p:txBody>
+          <a:bodyPr rtlCol="0" anchor="ctr"/>
+          <a:lstStyle/>
+          <a:p>
+            <a:pPr algn="ctr"/>
+          </a:p>
+        </p:txBody>
+      </p:sp>
+      <p:sp>
+        <p:nvSpPr>
+          <p:cNvPr id="12" name="TextBox 11"/>
+          <p:cNvSpPr txBox="1"/>
+          <p:nvPr/>
+        </p:nvSpPr>
+        <p:spPr>
+          <a:xfrm>
+            <a:off x="8339327" y="2761488"/>
+            <a:ext cx="2798064" cy="2340864"/>
+          </a:xfrm>
+          <a:prstGeom prst="rect">
+            <a:avLst/>
+          </a:prstGeom>
+          <a:noFill/>
+        </p:spPr>
+        <p:txBody>
+          <a:bodyPr wrap="square" anchor="t">
+            <a:spAutoFit/>
+          </a:bodyPr>
+          <a:lstStyle/>
+          <a:p>
+            <a:pPr algn="l">
+              <a:lnSpc>
+                <a:spcPct val="100000"/>
+              </a:lnSpc>
+              <a:spcAft>
+                <a:spcPts val="600"/>
+              </a:spcAft>
+            </a:pPr>
+            <a:r>
+              <a:rPr sz="1200" b="1">
+                <a:solidFill>
+                  <a:srgbClr val="3FB0C6"/>
+                </a:solidFill>
+                <a:latin typeface="Consolas"/>
+              </a:rPr>
+              <a:t>03</a:t>
+            </a:r>
+          </a:p>
+          <a:p>
+            <a:pPr algn="l">
+              <a:lnSpc>
+                <a:spcPct val="100000"/>
+              </a:lnSpc>
+              <a:spcAft>
+                <a:spcPts val="1000"/>
+              </a:spcAft>
+            </a:pPr>
+            <a:r>
+              <a:rPr sz="2000" b="1">
+                <a:solidFill>
+                  <a:srgbClr val="FFFFFF"/>
+                </a:solidFill>
+                <a:latin typeface="Georgia"/>
+              </a:rPr>
+              <a:t>Serve via a proxy</a:t>
+            </a:r>
+          </a:p>
+          <a:p>
+            <a:pPr algn="l">
+              <a:lnSpc>
+                <a:spcPct val="120000"/>
+              </a:lnSpc>
+              <a:spcAft>
+                <a:spcPts val="0"/>
+              </a:spcAft>
+            </a:pPr>
+            <a:r>
+              <a:rPr sz="1400" b="0">
+                <a:solidFill>
+                  <a:srgbClr val="9FB2B6"/>
+                </a:solidFill>
+                <a:latin typeface="Calibri"/>
+              </a:rPr>
+              <a:t>The proxy swaps the span for gist tokens. No change to the client or the engine.</a:t>
+            </a:r>
+          </a:p>
+        </p:txBody>
+      </p:sp>
+      <p:sp>
+        <p:nvSpPr>
+          <p:cNvPr id="13" name="TextBox 12"/>
+          <p:cNvSpPr txBox="1"/>
+          <p:nvPr/>
+        </p:nvSpPr>
+        <p:spPr>
+          <a:xfrm>
+            <a:off x="640080" y="5623560"/>
+            <a:ext cx="10881360" cy="548640"/>
+          </a:xfrm>
+          <a:prstGeom prst="rect">
+            <a:avLst/>
+          </a:prstGeom>
+          <a:noFill/>
+        </p:spPr>
+        <p:txBody>
+          <a:bodyPr wrap="square" anchor="t">
+            <a:spAutoFit/>
+          </a:bodyPr>
+          <a:lstStyle/>
+          <a:p>
+            <a:pPr algn="l">
+              <a:lnSpc>
+                <a:spcPct val="100000"/>
+              </a:lnSpc>
+              <a:spcAft>
+                <a:spcPts val="0"/>
+              </a:spcAft>
+            </a:pPr>
+            <a:r>
+              <a:rPr sz="1300" b="0">
+                <a:solidFill>
+                  <a:srgbClr val="9FB2B6"/>
+                </a:solidFill>
+                <a:latin typeface="Calibri"/>
+              </a:rPr>
+              <a:t>The only trained object is a small embedding tensor — cheap to produce, cheap to serve.</a:t>
             </a:r>
           </a:p>
         </p:txBody>
@@ -7947,14 +9238,56 @@
       </p:sp>
       <p:sp>
         <p:nvSpPr>
-          <p:cNvPr id="5" name="Rounded Rectangle 4"/>
+          <p:cNvPr id="5" name="TextBox 4"/>
+          <p:cNvSpPr txBox="1"/>
+          <p:nvPr/>
+        </p:nvSpPr>
+        <p:spPr>
+          <a:xfrm>
+            <a:off x="640080" y="2331720"/>
+            <a:ext cx="1280160" cy="457200"/>
+          </a:xfrm>
+          <a:prstGeom prst="rect">
+            <a:avLst/>
+          </a:prstGeom>
+          <a:noFill/>
+        </p:spPr>
+        <p:txBody>
+          <a:bodyPr wrap="square" anchor="t">
+            <a:spAutoFit/>
+          </a:bodyPr>
+          <a:lstStyle/>
+          <a:p>
+            <a:pPr algn="l">
+              <a:lnSpc>
+                <a:spcPct val="100000"/>
+              </a:lnSpc>
+              <a:spcAft>
+                <a:spcPts val="0"/>
+              </a:spcAft>
+            </a:pPr>
+            <a:r>
+              <a:rPr sz="1300" b="1">
+                <a:solidFill>
+                  <a:srgbClr val="E3B24C"/>
+                </a:solidFill>
+                <a:latin typeface="Consolas"/>
+              </a:rPr>
+              <a:t>BEFORE</a:t>
+            </a:r>
+          </a:p>
+        </p:txBody>
+      </p:sp>
+      <p:sp>
+        <p:nvSpPr>
+          <p:cNvPr id="6" name="Rounded Rectangle 5"/>
           <p:cNvSpPr/>
           <p:nvPr/>
         </p:nvSpPr>
         <p:spPr>
           <a:xfrm>
-            <a:off x="530352" y="1856231"/>
-            <a:ext cx="6803136" cy="2203000"/>
+            <a:off x="2011680" y="2194560"/>
+            <a:ext cx="3931920" cy="749808"/>
           </a:xfrm>
           <a:prstGeom prst="roundRect">
             <a:avLst>
@@ -7962,7 +9295,403 @@
             </a:avLst>
           </a:prstGeom>
           <a:solidFill>
-            <a:srgbClr val="FFFFFF"/>
+            <a:srgbClr val="141D21"/>
+          </a:solidFill>
+          <a:ln w="12700">
+            <a:solidFill>
+              <a:srgbClr val="5A3F6E"/>
+            </a:solidFill>
+          </a:ln>
+          <a:effectLst/>
+        </p:spPr>
+        <p:style>
+          <a:lnRef idx="1">
+            <a:schemeClr val="accent1"/>
+          </a:lnRef>
+          <a:fillRef idx="3">
+            <a:schemeClr val="accent1"/>
+          </a:fillRef>
+          <a:effectRef idx="2">
+            <a:schemeClr val="accent1"/>
+          </a:effectRef>
+          <a:fontRef idx="minor">
+            <a:schemeClr val="lt1"/>
+          </a:fontRef>
+        </p:style>
+        <p:txBody>
+          <a:bodyPr rtlCol="0" anchor="ctr"/>
+          <a:lstStyle/>
+          <a:p>
+            <a:pPr algn="ctr"/>
+          </a:p>
+        </p:txBody>
+      </p:sp>
+      <p:sp>
+        <p:nvSpPr>
+          <p:cNvPr id="7" name="TextBox 6"/>
+          <p:cNvSpPr txBox="1"/>
+          <p:nvPr/>
+        </p:nvSpPr>
+        <p:spPr>
+          <a:xfrm>
+            <a:off x="2194560" y="2194560"/>
+            <a:ext cx="3566160" cy="749808"/>
+          </a:xfrm>
+          <a:prstGeom prst="rect">
+            <a:avLst/>
+          </a:prstGeom>
+          <a:noFill/>
+        </p:spPr>
+        <p:txBody>
+          <a:bodyPr wrap="square" anchor="ctr">
+            <a:spAutoFit/>
+          </a:bodyPr>
+          <a:lstStyle/>
+          <a:p>
+            <a:pPr algn="l">
+              <a:lnSpc>
+                <a:spcPct val="105000"/>
+              </a:lnSpc>
+              <a:spcAft>
+                <a:spcPts val="0"/>
+              </a:spcAft>
+            </a:pPr>
+            <a:r>
+              <a:rPr sz="1300" b="0">
+                <a:solidFill>
+                  <a:srgbClr val="C39BE0"/>
+                </a:solidFill>
+                <a:latin typeface="Consolas"/>
+              </a:rPr>
+              <a:t>gist: rules + …/&lt;session-id&gt;/</a:t>
+            </a:r>
+          </a:p>
+        </p:txBody>
+      </p:sp>
+      <p:sp>
+        <p:nvSpPr>
+          <p:cNvPr id="8" name="TextBox 7"/>
+          <p:cNvSpPr txBox="1"/>
+          <p:nvPr/>
+        </p:nvSpPr>
+        <p:spPr>
+          <a:xfrm>
+            <a:off x="6035040" y="2194560"/>
+            <a:ext cx="457200" cy="749808"/>
+          </a:xfrm>
+          <a:prstGeom prst="rect">
+            <a:avLst/>
+          </a:prstGeom>
+          <a:noFill/>
+        </p:spPr>
+        <p:txBody>
+          <a:bodyPr wrap="square" anchor="ctr">
+            <a:spAutoFit/>
+          </a:bodyPr>
+          <a:lstStyle/>
+          <a:p>
+            <a:pPr algn="ctr">
+              <a:lnSpc>
+                <a:spcPct val="100000"/>
+              </a:lnSpc>
+              <a:spcAft>
+                <a:spcPts val="0"/>
+              </a:spcAft>
+            </a:pPr>
+            <a:r>
+              <a:rPr sz="2000" b="1">
+                <a:solidFill>
+                  <a:srgbClr val="3FB0C6"/>
+                </a:solidFill>
+                <a:latin typeface="Calibri"/>
+              </a:rPr>
+              <a:t>→</a:t>
+            </a:r>
+          </a:p>
+        </p:txBody>
+      </p:sp>
+      <p:sp>
+        <p:nvSpPr>
+          <p:cNvPr id="9" name="Rounded Rectangle 8"/>
+          <p:cNvSpPr/>
+          <p:nvPr/>
+        </p:nvSpPr>
+        <p:spPr>
+          <a:xfrm>
+            <a:off x="6583680" y="2194560"/>
+            <a:ext cx="4663440" cy="749808"/>
+          </a:xfrm>
+          <a:prstGeom prst="roundRect">
+            <a:avLst>
+              <a:gd name="adj" fmla="val 6000"/>
+            </a:avLst>
+          </a:prstGeom>
+          <a:solidFill>
+            <a:srgbClr val="141D21"/>
+          </a:solidFill>
+          <a:ln w="12700">
+            <a:solidFill>
+              <a:srgbClr val="6E3A3A"/>
+            </a:solidFill>
+          </a:ln>
+          <a:effectLst/>
+        </p:spPr>
+        <p:style>
+          <a:lnRef idx="1">
+            <a:schemeClr val="accent1"/>
+          </a:lnRef>
+          <a:fillRef idx="3">
+            <a:schemeClr val="accent1"/>
+          </a:fillRef>
+          <a:effectRef idx="2">
+            <a:schemeClr val="accent1"/>
+          </a:effectRef>
+          <a:fontRef idx="minor">
+            <a:schemeClr val="lt1"/>
+          </a:fontRef>
+        </p:style>
+        <p:txBody>
+          <a:bodyPr rtlCol="0" anchor="ctr"/>
+          <a:lstStyle/>
+          <a:p>
+            <a:pPr algn="ctr"/>
+          </a:p>
+        </p:txBody>
+      </p:sp>
+      <p:sp>
+        <p:nvSpPr>
+          <p:cNvPr id="10" name="TextBox 9"/>
+          <p:cNvSpPr txBox="1"/>
+          <p:nvPr/>
+        </p:nvSpPr>
+        <p:spPr>
+          <a:xfrm>
+            <a:off x="6766560" y="2194560"/>
+            <a:ext cx="4297679" cy="749808"/>
+          </a:xfrm>
+          <a:prstGeom prst="rect">
+            <a:avLst/>
+          </a:prstGeom>
+          <a:noFill/>
+        </p:spPr>
+        <p:txBody>
+          <a:bodyPr wrap="square" anchor="ctr">
+            <a:spAutoFit/>
+          </a:bodyPr>
+          <a:lstStyle/>
+          <a:p>
+            <a:pPr algn="l">
+              <a:lnSpc>
+                <a:spcPct val="105000"/>
+              </a:lnSpc>
+              <a:spcAft>
+                <a:spcPts val="0"/>
+              </a:spcAft>
+            </a:pPr>
+            <a:r>
+              <a:rPr sz="1300" b="0">
+                <a:solidFill>
+                  <a:srgbClr val="E79191"/>
+                </a:solidFill>
+                <a:latin typeface="Consolas"/>
+              </a:rPr>
+              <a:t>writes to an invented directory   ×</a:t>
+            </a:r>
+          </a:p>
+        </p:txBody>
+      </p:sp>
+      <p:sp>
+        <p:nvSpPr>
+          <p:cNvPr id="11" name="TextBox 10"/>
+          <p:cNvSpPr txBox="1"/>
+          <p:nvPr/>
+        </p:nvSpPr>
+        <p:spPr>
+          <a:xfrm>
+            <a:off x="640080" y="3429000"/>
+            <a:ext cx="1280160" cy="457200"/>
+          </a:xfrm>
+          <a:prstGeom prst="rect">
+            <a:avLst/>
+          </a:prstGeom>
+          <a:noFill/>
+        </p:spPr>
+        <p:txBody>
+          <a:bodyPr wrap="square" anchor="t">
+            <a:spAutoFit/>
+          </a:bodyPr>
+          <a:lstStyle/>
+          <a:p>
+            <a:pPr algn="l">
+              <a:lnSpc>
+                <a:spcPct val="100000"/>
+              </a:lnSpc>
+              <a:spcAft>
+                <a:spcPts val="0"/>
+              </a:spcAft>
+            </a:pPr>
+            <a:r>
+              <a:rPr sz="1300" b="1">
+                <a:solidFill>
+                  <a:srgbClr val="57C08A"/>
+                </a:solidFill>
+                <a:latin typeface="Consolas"/>
+              </a:rPr>
+              <a:t>AFTER</a:t>
+            </a:r>
+          </a:p>
+        </p:txBody>
+      </p:sp>
+      <p:sp>
+        <p:nvSpPr>
+          <p:cNvPr id="12" name="Rounded Rectangle 11"/>
+          <p:cNvSpPr/>
+          <p:nvPr/>
+        </p:nvSpPr>
+        <p:spPr>
+          <a:xfrm>
+            <a:off x="2011680" y="3291840"/>
+            <a:ext cx="2103120" cy="749808"/>
+          </a:xfrm>
+          <a:prstGeom prst="roundRect">
+            <a:avLst>
+              <a:gd name="adj" fmla="val 6000"/>
+            </a:avLst>
+          </a:prstGeom>
+          <a:solidFill>
+            <a:srgbClr val="141D21"/>
+          </a:solidFill>
+          <a:ln w="12700">
+            <a:solidFill>
+              <a:srgbClr val="5A3F6E"/>
+            </a:solidFill>
+          </a:ln>
+          <a:effectLst/>
+        </p:spPr>
+        <p:style>
+          <a:lnRef idx="1">
+            <a:schemeClr val="accent1"/>
+          </a:lnRef>
+          <a:fillRef idx="3">
+            <a:schemeClr val="accent1"/>
+          </a:fillRef>
+          <a:effectRef idx="2">
+            <a:schemeClr val="accent1"/>
+          </a:effectRef>
+          <a:fontRef idx="minor">
+            <a:schemeClr val="lt1"/>
+          </a:fontRef>
+        </p:style>
+        <p:txBody>
+          <a:bodyPr rtlCol="0" anchor="ctr"/>
+          <a:lstStyle/>
+          <a:p>
+            <a:pPr algn="ctr"/>
+          </a:p>
+        </p:txBody>
+      </p:sp>
+      <p:sp>
+        <p:nvSpPr>
+          <p:cNvPr id="13" name="TextBox 12"/>
+          <p:cNvSpPr txBox="1"/>
+          <p:nvPr/>
+        </p:nvSpPr>
+        <p:spPr>
+          <a:xfrm>
+            <a:off x="2194560" y="3291840"/>
+            <a:ext cx="1737360" cy="749808"/>
+          </a:xfrm>
+          <a:prstGeom prst="rect">
+            <a:avLst/>
+          </a:prstGeom>
+          <a:noFill/>
+        </p:spPr>
+        <p:txBody>
+          <a:bodyPr wrap="square" anchor="ctr">
+            <a:spAutoFit/>
+          </a:bodyPr>
+          <a:lstStyle/>
+          <a:p>
+            <a:pPr algn="l">
+              <a:lnSpc>
+                <a:spcPct val="105000"/>
+              </a:lnSpc>
+              <a:spcAft>
+                <a:spcPts val="0"/>
+              </a:spcAft>
+            </a:pPr>
+            <a:r>
+              <a:rPr sz="1300" b="0">
+                <a:solidFill>
+                  <a:srgbClr val="C39BE0"/>
+                </a:solidFill>
+                <a:latin typeface="Consolas"/>
+              </a:rPr>
+              <a:t>gist: rules</a:t>
+            </a:r>
+          </a:p>
+        </p:txBody>
+      </p:sp>
+      <p:sp>
+        <p:nvSpPr>
+          <p:cNvPr id="14" name="TextBox 13"/>
+          <p:cNvSpPr txBox="1"/>
+          <p:nvPr/>
+        </p:nvSpPr>
+        <p:spPr>
+          <a:xfrm>
+            <a:off x="4160520" y="3291840"/>
+            <a:ext cx="365760" cy="749808"/>
+          </a:xfrm>
+          <a:prstGeom prst="rect">
+            <a:avLst/>
+          </a:prstGeom>
+          <a:noFill/>
+        </p:spPr>
+        <p:txBody>
+          <a:bodyPr wrap="square" anchor="ctr">
+            <a:spAutoFit/>
+          </a:bodyPr>
+          <a:lstStyle/>
+          <a:p>
+            <a:pPr algn="ctr">
+              <a:lnSpc>
+                <a:spcPct val="100000"/>
+              </a:lnSpc>
+              <a:spcAft>
+                <a:spcPts val="0"/>
+              </a:spcAft>
+            </a:pPr>
+            <a:r>
+              <a:rPr sz="2000" b="1">
+                <a:solidFill>
+                  <a:srgbClr val="9FB2B6"/>
+                </a:solidFill>
+                <a:latin typeface="Calibri"/>
+              </a:rPr>
+              <a:t>+</a:t>
+            </a:r>
+          </a:p>
+        </p:txBody>
+      </p:sp>
+      <p:sp>
+        <p:nvSpPr>
+          <p:cNvPr id="15" name="Rounded Rectangle 14"/>
+          <p:cNvSpPr/>
+          <p:nvPr/>
+        </p:nvSpPr>
+        <p:spPr>
+          <a:xfrm>
+            <a:off x="4572000" y="3291840"/>
+            <a:ext cx="3108960" cy="749808"/>
+          </a:xfrm>
+          <a:prstGeom prst="roundRect">
+            <a:avLst>
+              <a:gd name="adj" fmla="val 6000"/>
+            </a:avLst>
+          </a:prstGeom>
+          <a:solidFill>
+            <a:srgbClr val="141D21"/>
           </a:solidFill>
           <a:ln w="12700">
             <a:solidFill>
@@ -7993,40 +9722,190 @@
           </a:p>
         </p:txBody>
       </p:sp>
-      <p:pic>
-        <p:nvPicPr>
-          <p:cNvPr id="6" name="Picture 5" descr="fig5_defect.png"/>
-          <p:cNvPicPr>
-            <a:picLocks noChangeAspect="1"/>
-          </p:cNvPicPr>
-          <p:nvPr/>
-        </p:nvPicPr>
-        <p:blipFill>
-          <a:blip r:embed="rId2"/>
-          <a:stretch>
-            <a:fillRect/>
-          </a:stretch>
-        </p:blipFill>
-        <p:spPr>
-          <a:xfrm>
-            <a:off x="640080" y="1965960"/>
-            <a:ext cx="6583680" cy="1983545"/>
+      <p:sp>
+        <p:nvSpPr>
+          <p:cNvPr id="16" name="TextBox 15"/>
+          <p:cNvSpPr txBox="1"/>
+          <p:nvPr/>
+        </p:nvSpPr>
+        <p:spPr>
+          <a:xfrm>
+            <a:off x="4754880" y="3291840"/>
+            <a:ext cx="2743200" cy="749808"/>
           </a:xfrm>
           <a:prstGeom prst="rect">
             <a:avLst/>
           </a:prstGeom>
-        </p:spPr>
-      </p:pic>
-      <p:sp>
-        <p:nvSpPr>
-          <p:cNvPr id="7" name="TextBox 6"/>
+          <a:noFill/>
+        </p:spPr>
+        <p:txBody>
+          <a:bodyPr wrap="square" anchor="ctr">
+            <a:spAutoFit/>
+          </a:bodyPr>
+          <a:lstStyle/>
+          <a:p>
+            <a:pPr algn="l">
+              <a:lnSpc>
+                <a:spcPct val="105000"/>
+              </a:lnSpc>
+              <a:spcAft>
+                <a:spcPts val="0"/>
+              </a:spcAft>
+            </a:pPr>
+            <a:r>
+              <a:rPr sz="1300" b="0">
+                <a:solidFill>
+                  <a:srgbClr val="EEF3F3"/>
+                </a:solidFill>
+                <a:latin typeface="Consolas"/>
+              </a:rPr>
+              <a:t>raw: session path, date, model</a:t>
+            </a:r>
+          </a:p>
+        </p:txBody>
+      </p:sp>
+      <p:sp>
+        <p:nvSpPr>
+          <p:cNvPr id="17" name="TextBox 16"/>
           <p:cNvSpPr txBox="1"/>
           <p:nvPr/>
         </p:nvSpPr>
         <p:spPr>
           <a:xfrm>
-            <a:off x="7680960" y="2011680"/>
-            <a:ext cx="3840480" cy="4206240"/>
+            <a:off x="7772400" y="3291840"/>
+            <a:ext cx="457200" cy="749808"/>
+          </a:xfrm>
+          <a:prstGeom prst="rect">
+            <a:avLst/>
+          </a:prstGeom>
+          <a:noFill/>
+        </p:spPr>
+        <p:txBody>
+          <a:bodyPr wrap="square" anchor="ctr">
+            <a:spAutoFit/>
+          </a:bodyPr>
+          <a:lstStyle/>
+          <a:p>
+            <a:pPr algn="ctr">
+              <a:lnSpc>
+                <a:spcPct val="100000"/>
+              </a:lnSpc>
+              <a:spcAft>
+                <a:spcPts val="0"/>
+              </a:spcAft>
+            </a:pPr>
+            <a:r>
+              <a:rPr sz="2000" b="1">
+                <a:solidFill>
+                  <a:srgbClr val="3FB0C6"/>
+                </a:solidFill>
+                <a:latin typeface="Calibri"/>
+              </a:rPr>
+              <a:t>→</a:t>
+            </a:r>
+          </a:p>
+        </p:txBody>
+      </p:sp>
+      <p:sp>
+        <p:nvSpPr>
+          <p:cNvPr id="18" name="Rounded Rectangle 17"/>
+          <p:cNvSpPr/>
+          <p:nvPr/>
+        </p:nvSpPr>
+        <p:spPr>
+          <a:xfrm>
+            <a:off x="8321040" y="3291840"/>
+            <a:ext cx="2926080" cy="749808"/>
+          </a:xfrm>
+          <a:prstGeom prst="roundRect">
+            <a:avLst>
+              <a:gd name="adj" fmla="val 6000"/>
+            </a:avLst>
+          </a:prstGeom>
+          <a:solidFill>
+            <a:srgbClr val="141D21"/>
+          </a:solidFill>
+          <a:ln w="12700">
+            <a:solidFill>
+              <a:srgbClr val="2C5040"/>
+            </a:solidFill>
+          </a:ln>
+          <a:effectLst/>
+        </p:spPr>
+        <p:style>
+          <a:lnRef idx="1">
+            <a:schemeClr val="accent1"/>
+          </a:lnRef>
+          <a:fillRef idx="3">
+            <a:schemeClr val="accent1"/>
+          </a:fillRef>
+          <a:effectRef idx="2">
+            <a:schemeClr val="accent1"/>
+          </a:effectRef>
+          <a:fontRef idx="minor">
+            <a:schemeClr val="lt1"/>
+          </a:fontRef>
+        </p:style>
+        <p:txBody>
+          <a:bodyPr rtlCol="0" anchor="ctr"/>
+          <a:lstStyle/>
+          <a:p>
+            <a:pPr algn="ctr"/>
+          </a:p>
+        </p:txBody>
+      </p:sp>
+      <p:sp>
+        <p:nvSpPr>
+          <p:cNvPr id="19" name="TextBox 18"/>
+          <p:cNvSpPr txBox="1"/>
+          <p:nvPr/>
+        </p:nvSpPr>
+        <p:spPr>
+          <a:xfrm>
+            <a:off x="8503919" y="3291840"/>
+            <a:ext cx="2560320" cy="749808"/>
+          </a:xfrm>
+          <a:prstGeom prst="rect">
+            <a:avLst/>
+          </a:prstGeom>
+          <a:noFill/>
+        </p:spPr>
+        <p:txBody>
+          <a:bodyPr wrap="square" anchor="ctr">
+            <a:spAutoFit/>
+          </a:bodyPr>
+          <a:lstStyle/>
+          <a:p>
+            <a:pPr algn="l">
+              <a:lnSpc>
+                <a:spcPct val="105000"/>
+              </a:lnSpc>
+              <a:spcAft>
+                <a:spcPts val="0"/>
+              </a:spcAft>
+            </a:pPr>
+            <a:r>
+              <a:rPr sz="1300" b="0">
+                <a:solidFill>
+                  <a:srgbClr val="57C08A"/>
+                </a:solidFill>
+                <a:latin typeface="Consolas"/>
+              </a:rPr>
+              <a:t>writes correctly   ✓</a:t>
+            </a:r>
+          </a:p>
+        </p:txBody>
+      </p:sp>
+      <p:sp>
+        <p:nvSpPr>
+          <p:cNvPr id="20" name="TextBox 19"/>
+          <p:cNvSpPr txBox="1"/>
+          <p:nvPr/>
+        </p:nvSpPr>
+        <p:spPr>
+          <a:xfrm>
+            <a:off x="640080" y="4526280"/>
+            <a:ext cx="10881360" cy="731520"/>
           </a:xfrm>
           <a:prstGeom prst="rect">
             <a:avLst/>
@@ -8038,63 +9917,6 @@
             <a:spAutoFit/>
           </a:bodyPr>
           <a:lstStyle/>
-          <a:p>
-            <a:pPr algn="l">
-              <a:lnSpc>
-                <a:spcPct val="120000"/>
-              </a:lnSpc>
-              <a:spcAft>
-                <a:spcPts val="1200"/>
-              </a:spcAft>
-            </a:pPr>
-            <a:r>
-              <a:rPr sz="1550" b="0">
-                <a:solidFill>
-                  <a:srgbClr val="EEF3F3"/>
-                </a:solidFill>
-                <a:latin typeface="Calibri"/>
-              </a:rPr>
-              <a:t>A working-directory path with a session id was mistaken for fixed text and folded into the gist — so the model wrote results to invented directories.</a:t>
-            </a:r>
-          </a:p>
-          <a:p>
-            <a:pPr algn="l">
-              <a:lnSpc>
-                <a:spcPct val="115000"/>
-              </a:lnSpc>
-              <a:spcAft>
-                <a:spcPts val="600"/>
-              </a:spcAft>
-            </a:pPr>
-            <a:r>
-              <a:rPr sz="1450" b="0">
-                <a:solidFill>
-                  <a:srgbClr val="EEF3F3"/>
-                </a:solidFill>
-                <a:latin typeface="Calibri"/>
-              </a:rPr>
-              <a:t>▪  Keep session-specific values raw by pattern.</a:t>
-            </a:r>
-          </a:p>
-          <a:p>
-            <a:pPr algn="l">
-              <a:lnSpc>
-                <a:spcPct val="115000"/>
-              </a:lnSpc>
-              <a:spcAft>
-                <a:spcPts val="1200"/>
-              </a:spcAft>
-            </a:pPr>
-            <a:r>
-              <a:rPr sz="1450" b="0">
-                <a:solidFill>
-                  <a:srgbClr val="EEF3F3"/>
-                </a:solidFill>
-                <a:latin typeface="Calibri"/>
-              </a:rPr>
-              <a:t>▪  Score recovers 11/16 → 16/16 at 8:1 (11/15 → 15/15 excluding one defective probe).</a:t>
-            </a:r>
-          </a:p>
           <a:p>
             <a:pPr algn="l">
               <a:lnSpc>
@@ -8105,7 +9927,49 @@
               </a:spcAft>
             </a:pPr>
             <a:r>
-              <a:rPr sz="1200" b="0">
+              <a:rPr sz="1800" b="0">
+                <a:solidFill>
+                  <a:srgbClr val="EEF3F3"/>
+                </a:solidFill>
+                <a:latin typeface="Calibri"/>
+              </a:rPr>
+              <a:t>Keeping session-specific values raw restored the score 11/16 → 16/16 at 8:1.</a:t>
+            </a:r>
+          </a:p>
+        </p:txBody>
+      </p:sp>
+      <p:sp>
+        <p:nvSpPr>
+          <p:cNvPr id="21" name="TextBox 20"/>
+          <p:cNvSpPr txBox="1"/>
+          <p:nvPr/>
+        </p:nvSpPr>
+        <p:spPr>
+          <a:xfrm>
+            <a:off x="640080" y="5440680"/>
+            <a:ext cx="10881360" cy="548640"/>
+          </a:xfrm>
+          <a:prstGeom prst="rect">
+            <a:avLst/>
+          </a:prstGeom>
+          <a:noFill/>
+        </p:spPr>
+        <p:txBody>
+          <a:bodyPr wrap="square" anchor="t">
+            <a:spAutoFit/>
+          </a:bodyPr>
+          <a:lstStyle/>
+          <a:p>
+            <a:pPr algn="l">
+              <a:lnSpc>
+                <a:spcPct val="100000"/>
+              </a:lnSpc>
+              <a:spcAft>
+                <a:spcPts val="0"/>
+              </a:spcAft>
+            </a:pPr>
+            <a:r>
+              <a:rPr sz="1300" b="0">
                 <a:solidFill>
                   <a:srgbClr val="9FB2B6"/>
                 </a:solidFill>

</xml_diff>

<commit_message>
Clarify the tax: the coding agent re-sends the preamble to the model on every step
</commit_message>
<xml_diff>
--- a/Gisting-CTO-deck.pptx
+++ b/Gisting-CTO-deck.pptx
@@ -6135,7 +6135,7 @@
                 </a:solidFill>
                 <a:latin typeface="Calibri"/>
               </a:rPr>
-              <a:t>Every turn re-sends ~17.5–21k fixed tokens, over 90% tool schemas — about 0.72 of a short session.</a:t>
+              <a:t>At every step, the coding agent (Claude Code) re-sends the same fixed preamble to the model — ~17.5–21k tokens, over 90% tool schemas, about 0.72 of a short session.</a:t>
             </a:r>
           </a:p>
         </p:txBody>
@@ -7717,7 +7717,7 @@
                 </a:solidFill>
                 <a:latin typeface="Calibri"/>
               </a:rPr>
-              <a:t>The same block, byte-for-byte, on every turn. Per-session values (paths, git status, date) are split out and kept raw.</a:t>
+              <a:t>The coding-agent harness prepends the same block, byte-for-byte, on every model call. Per-session values (paths, git status, date) are split out and kept raw.</a:t>
             </a:r>
           </a:p>
         </p:txBody>

</xml_diff>

<commit_message>
QA: remove em-dashes from deck/pptx/email (house style); email anchors deck + whitepaper
</commit_message>
<xml_diff>
--- a/Gisting-CTO-deck.pptx
+++ b/Gisting-CTO-deck.pptx
@@ -3543,7 +3543,7 @@
                 </a:solidFill>
                 <a:latin typeface="Calibri"/>
               </a:rPr>
-              <a:t>Compressing a coding agent’s fixed preamble into a handful of learned “gist” tokens — what it buys, what it costs, and what to fund next.</a:t>
+              <a:t>Compressing a coding agent’s fixed preamble into a handful of learned “gist” tokens: what it buys, what it costs, and what to fund next.</a:t>
             </a:r>
           </a:p>
         </p:txBody>
@@ -4601,7 +4601,7 @@
                 </a:solidFill>
                 <a:latin typeface="Calibri"/>
               </a:rPr>
-              <a:t>Bounded effort: a single GPU over days, not a new research program — the loop and serving path already exist.</a:t>
+              <a:t>Bounded effort: a single GPU over days, not a new research program; the loop and serving path already exist.</a:t>
             </a:r>
           </a:p>
         </p:txBody>
@@ -4789,7 +4789,7 @@
                 </a:solidFill>
                 <a:latin typeface="Georgia"/>
               </a:rPr>
-              <a:t>Fund a short validation — eval + saturation — before any production commitment.</a:t>
+              <a:t>Fund a short validation (eval + saturation) before any production commitment.</a:t>
             </a:r>
           </a:p>
         </p:txBody>
@@ -5019,7 +5019,7 @@
                 </a:solidFill>
                 <a:latin typeface="Georgia"/>
               </a:rPr>
-              <a:t>The failure that mattered — and the fix</a:t>
+              <a:t>The failure that mattered, and the fix</a:t>
             </a:r>
           </a:p>
         </p:txBody>
@@ -5763,7 +5763,7 @@
                 </a:solidFill>
                 <a:latin typeface="Calibri"/>
               </a:rPr>
-              <a:t>The productionization gotcha every deployment will hit — and evidence we were looking hard, not cherry-picking.</a:t>
+              <a:t>The productionization gotcha every deployment will hit, and evidence we were looking hard, not cherry-picking.</a:t>
             </a:r>
           </a:p>
         </p:txBody>
@@ -5999,7 +5999,7 @@
                 </a:solidFill>
                 <a:latin typeface="Calibri"/>
               </a:rPr>
-              <a:t>At every step, the coding agent (Claude Code) re-sends the same fixed preamble to the model — ~17.5–21k tokens, over 90% tool schemas, about 0.72 of a short session.</a:t>
+              <a:t>At every step, the coding agent (Claude Code) re-sends the same fixed preamble to the model: ~17.5–21k tokens, over 90% tool schemas, about 0.72 of a short session.</a:t>
             </a:r>
           </a:p>
         </p:txBody>
@@ -6179,7 +6179,7 @@
                 </a:solidFill>
                 <a:latin typeface="Calibri"/>
               </a:rPr>
-              <a:t>~16% more throughput at eight concurrent sessions — capacity per GPU, not faster single replies.</a:t>
+              <a:t>~16% more throughput at eight concurrent sessions: capacity per GPU, not faster single replies.</a:t>
             </a:r>
           </a:p>
         </p:txBody>
@@ -6499,7 +6499,7 @@
                 </a:solidFill>
                 <a:latin typeface="Calibri"/>
               </a:rPr>
-              <a:t>For a self-hosted agent, serving cost is driven by how many tokens the model reads per turn, which caps how many sessions a GPU can carry. Three cost drivers — gisting acts on the first.</a:t>
+              <a:t>For a self-hosted agent, serving cost is driven by how many tokens the model reads per turn, which caps how many sessions a GPU can carry. Three cost drivers; gisting acts on the first.</a:t>
             </a:r>
           </a:p>
         </p:txBody>
@@ -8025,7 +8025,7 @@
                 </a:solidFill>
                 <a:latin typeface="Calibri"/>
               </a:rPr>
-              <a:t>The model matches its own behaviour — short gist vs. full block. All base weights frozen; only the new rows train.</a:t>
+              <a:t>The model matches its own behaviour (short gist vs. full block). All base weights frozen; only the new rows train.</a:t>
             </a:r>
           </a:p>
         </p:txBody>
@@ -8237,7 +8237,7 @@
                 </a:solidFill>
                 <a:latin typeface="Calibri"/>
               </a:rPr>
-              <a:t>The only trained object is a small embedding tensor — cheap to produce, cheap to serve.</a:t>
+              <a:t>The only trained object is a small embedding tensor: cheap to produce, cheap to serve.</a:t>
             </a:r>
           </a:p>
         </p:txBody>
@@ -9155,7 +9155,7 @@
                 </a:solidFill>
                 <a:latin typeface="Calibri"/>
               </a:rPr>
-              <a:t>Throughput rises with concurrency — and the gain grows as the service gets busier. A single reply is barely faster.</a:t>
+              <a:t>Throughput rises with concurrency, and the gain grows as the service gets busier. A single reply is barely faster.</a:t>
             </a:r>
           </a:p>
           <a:p>
@@ -9174,7 +9174,7 @@
                 </a:solidFill>
                 <a:latin typeface="Calibri"/>
               </a:rPr>
-              <a:t>For a shared internal agent service, this is sessions per GPU — the number that sets cost.</a:t>
+              <a:t>For a shared internal agent service, this is sessions per GPU, the number that sets cost.</a:t>
             </a:r>
           </a:p>
           <a:p>
@@ -9381,7 +9381,7 @@
                 </a:solidFill>
                 <a:latin typeface="Calibri"/>
               </a:rPr>
-              <a:t>This model uses full attention in only 16 of its 64 layers. A shorter prompt saves decode work only there — so the win is more sessions in parallel, not a faster individual answer.</a:t>
+              <a:t>This model uses full attention in only 16 of its 64 layers. A shorter prompt saves decode work only there, so the win is more sessions in parallel, not a faster individual answer.</a:t>
             </a:r>
           </a:p>
         </p:txBody>
@@ -13351,7 +13351,7 @@
                 </a:solidFill>
                 <a:latin typeface="Consolas"/>
               </a:rPr>
-              <a:t>SPEND-SAFETY · structural  —  idle watchdog · ledger at creation · sync-before-destroy · global deadline</a:t>
+              <a:t>SPEND-SAFETY · structural  ·  idle watchdog · ledger at creation · sync-before-destroy · global deadline</a:t>
             </a:r>
           </a:p>
         </p:txBody>
@@ -13393,7 +13393,7 @@
                 </a:solidFill>
                 <a:latin typeface="Calibri"/>
               </a:rPr>
-              <a:t>One detached controller drives every recipe end to end, unattended. Makes the next model cheap to try — the capability outlasts this study.</a:t>
+              <a:t>One detached controller drives every recipe end to end, unattended. Makes the next model cheap to try: the capability outlasts this study.</a:t>
             </a:r>
           </a:p>
         </p:txBody>

</xml_diff>

<commit_message>
J10 write-up: paper 5.6 rewritten with tuned repeated serving benchmark (2x at SLO, +44% peak, cache ablation, ceiling mechanism, cost-lever framing); deck + cost-lever slide; email, README, journey entry
</commit_message>
<xml_diff>
--- a/Gisting-CTO-deck.pptx
+++ b/Gisting-CTO-deck.pptx
@@ -18,6 +18,7 @@
     <p:sldId id="266" r:id="rId17"/>
     <p:sldId id="267" r:id="rId18"/>
     <p:sldId id="268" r:id="rId19"/>
+    <p:sldId id="269" r:id="rId20"/>
   </p:sldIdLst>
   <p:sldSz cx="12191695" cy="6858000" type="screen4x3"/>
   <p:notesSz cx="6858000" cy="9144000"/>
@@ -136,7 +137,7 @@
                 </a:solidFill>
                 <a:latin typeface="Consolas"/>
               </a:rPr>
-              <a:t>requests / minute  (higher is better)</a:t>
+              <a:t>requests / minute vs concurrent sessions  (H100 NVL, tuned server, 3 repeats)</a:t>
             </a:r>
           </a:p>
         </c:rich>
@@ -146,9 +147,9 @@
     </c:title>
     <c:autoTitleDeleted val="0"/>
     <c:plotArea>
-      <c:barChart>
-        <c:barDir val="col"/>
-        <c:grouping val="clustered"/>
+      <c:lineChart>
+        <c:grouping val="standard"/>
+        <c:varyColors val="0"/>
         <c:ser>
           <c:idx val="0"/>
           <c:order val="0"/>
@@ -164,45 +165,78 @@
             </c:strRef>
           </c:tx>
           <c:spPr>
-            <a:solidFill>
-              <a:srgbClr val="4A5A60"/>
-            </a:solidFill>
+            <a:ln w="38100">
+              <a:solidFill>
+                <a:srgbClr val="4A5A60"/>
+              </a:solidFill>
+            </a:ln>
           </c:spPr>
           <c:cat>
             <c:strRef>
-              <c:f>Sheet1!$A$2:$A$4</c:f>
+              <c:f>Sheet1!$A$2:$A$9</c:f>
               <c:strCache>
-                <c:ptCount val="3"/>
+                <c:ptCount val="8"/>
                 <c:pt idx="0">
-                  <c:v>c=1</c:v>
+                  <c:v>1</c:v>
                 </c:pt>
                 <c:pt idx="1">
-                  <c:v>c=4</c:v>
+                  <c:v>2</c:v>
                 </c:pt>
                 <c:pt idx="2">
-                  <c:v>c=8</c:v>
+                  <c:v>4</c:v>
+                </c:pt>
+                <c:pt idx="3">
+                  <c:v>8</c:v>
+                </c:pt>
+                <c:pt idx="4">
+                  <c:v>16</c:v>
+                </c:pt>
+                <c:pt idx="5">
+                  <c:v>32</c:v>
+                </c:pt>
+                <c:pt idx="6">
+                  <c:v>48</c:v>
+                </c:pt>
+                <c:pt idx="7">
+                  <c:v>64</c:v>
                 </c:pt>
               </c:strCache>
             </c:strRef>
           </c:cat>
           <c:val>
             <c:numRef>
-              <c:f>Sheet1!$B$2:$B$4</c:f>
+              <c:f>Sheet1!$B$2:$B$9</c:f>
               <c:numCache>
                 <c:formatCode>General</c:formatCode>
-                <c:ptCount val="3"/>
+                <c:ptCount val="8"/>
                 <c:pt idx="0">
-                  <c:v>6.9</c:v>
+                  <c:v>13.1</c:v>
                 </c:pt>
                 <c:pt idx="1">
-                  <c:v>16.4</c:v>
+                  <c:v>22.7</c:v>
                 </c:pt>
                 <c:pt idx="2">
-                  <c:v>20.0</c:v>
+                  <c:v>36.9</c:v>
+                </c:pt>
+                <c:pt idx="3">
+                  <c:v>34.7</c:v>
+                </c:pt>
+                <c:pt idx="4">
+                  <c:v>42.7</c:v>
+                </c:pt>
+                <c:pt idx="5">
+                  <c:v>42.7</c:v>
+                </c:pt>
+                <c:pt idx="6">
+                  <c:v>32.0</c:v>
+                </c:pt>
+                <c:pt idx="7">
+                  <c:v>29.3</c:v>
                 </c:pt>
               </c:numCache>
             </c:numRef>
           </c:val>
+          <c:smooth val="0"/>
         </c:ser>
         <c:ser>
           <c:idx val="1"/>
@@ -213,79 +247,92 @@
               <c:strCache>
                 <c:ptCount val="1"/>
                 <c:pt idx="0">
-                  <c:v>gist</c:v>
+                  <c:v>gist 8:1</c:v>
                 </c:pt>
               </c:strCache>
             </c:strRef>
           </c:tx>
           <c:spPr>
-            <a:solidFill>
-              <a:srgbClr val="3FB0C6"/>
-            </a:solidFill>
+            <a:ln w="38100">
+              <a:solidFill>
+                <a:srgbClr val="C39BE0"/>
+              </a:solidFill>
+            </a:ln>
           </c:spPr>
           <c:cat>
             <c:strRef>
-              <c:f>Sheet1!$A$2:$A$4</c:f>
+              <c:f>Sheet1!$A$2:$A$9</c:f>
               <c:strCache>
-                <c:ptCount val="3"/>
+                <c:ptCount val="8"/>
                 <c:pt idx="0">
-                  <c:v>c=1</c:v>
+                  <c:v>1</c:v>
                 </c:pt>
                 <c:pt idx="1">
-                  <c:v>c=4</c:v>
+                  <c:v>2</c:v>
                 </c:pt>
                 <c:pt idx="2">
-                  <c:v>c=8</c:v>
+                  <c:v>4</c:v>
+                </c:pt>
+                <c:pt idx="3">
+                  <c:v>8</c:v>
+                </c:pt>
+                <c:pt idx="4">
+                  <c:v>16</c:v>
+                </c:pt>
+                <c:pt idx="5">
+                  <c:v>32</c:v>
+                </c:pt>
+                <c:pt idx="6">
+                  <c:v>48</c:v>
+                </c:pt>
+                <c:pt idx="7">
+                  <c:v>64</c:v>
                 </c:pt>
               </c:strCache>
             </c:strRef>
           </c:cat>
           <c:val>
             <c:numRef>
-              <c:f>Sheet1!$C$2:$C$4</c:f>
+              <c:f>Sheet1!$C$2:$C$9</c:f>
               <c:numCache>
                 <c:formatCode>General</c:formatCode>
-                <c:ptCount val="3"/>
+                <c:ptCount val="8"/>
                 <c:pt idx="0">
-                  <c:v>7.2</c:v>
+                  <c:v>14.7</c:v>
                 </c:pt>
                 <c:pt idx="1">
-                  <c:v>18.9</c:v>
+                  <c:v>25.3</c:v>
                 </c:pt>
                 <c:pt idx="2">
-                  <c:v>23.2</c:v>
+                  <c:v>42.7</c:v>
+                </c:pt>
+                <c:pt idx="3">
+                  <c:v>48.0</c:v>
+                </c:pt>
+                <c:pt idx="4">
+                  <c:v>59.3</c:v>
+                </c:pt>
+                <c:pt idx="5">
+                  <c:v>61.3</c:v>
+                </c:pt>
+                <c:pt idx="6">
+                  <c:v>52.7</c:v>
+                </c:pt>
+                <c:pt idx="7">
+                  <c:v>41.3</c:v>
                 </c:pt>
               </c:numCache>
             </c:numRef>
           </c:val>
+          <c:smooth val="0"/>
         </c:ser>
-        <c:dLbls>
-          <c:txPr>
-            <a:bodyPr/>
-            <a:lstStyle/>
-            <a:p>
-              <a:pPr>
-                <a:defRPr sz="1100">
-                  <a:solidFill>
-                    <a:srgbClr val="EEF3F3"/>
-                  </a:solidFill>
-                </a:defRPr>
-              </a:pPr>
-            </a:p>
-          </c:txPr>
-          <c:showLegendKey val="0"/>
-          <c:showVal val="1"/>
-          <c:showCatName val="0"/>
-          <c:showSerName val="0"/>
-          <c:showPercent val="0"/>
-          <c:showBubbleSize val="0"/>
-          <c:showLeaderLines val="1"/>
-        </c:dLbls>
-        <c:axId val="-2068027336"/>
-        <c:axId val="-2113994440"/>
-      </c:barChart>
+        <c:marker val="1"/>
+        <c:smooth val="0"/>
+        <c:axId val="2118791784"/>
+        <c:axId val="2140495176"/>
+      </c:lineChart>
       <c:catAx>
-        <c:axId val="-2068027336"/>
+        <c:axId val="2118791784"/>
         <c:scaling>
           <c:orientation val="minMax"/>
         </c:scaling>
@@ -314,7 +361,7 @@
             </a:pPr>
           </a:p>
         </c:txPr>
-        <c:crossAx val="-2113994440"/>
+        <c:crossAx val="2140495176"/>
         <c:crosses val="autoZero"/>
         <c:auto val="1"/>
         <c:lblAlgn val="ctr"/>
@@ -322,7 +369,7 @@
         <c:noMultiLvlLbl val="0"/>
       </c:catAx>
       <c:valAx>
-        <c:axId val="-2113994440"/>
+        <c:axId val="2140495176"/>
         <c:scaling/>
         <c:delete val="0"/>
         <c:axPos val="l"/>
@@ -358,12 +405,13 @@
             </a:pPr>
           </a:p>
         </c:txPr>
-        <c:crossAx val="-2068027336"/>
+        <c:crossAx val="2118791784"/>
         <c:crosses val="autoZero"/>
       </c:valAx>
     </c:plotArea>
     <c:legend>
       <c:legendPos val="t"/>
+      <c:layout/>
       <c:overlay val="0"/>
       <c:txPr>
         <a:bodyPr/>
@@ -379,7 +427,9 @@
         </a:p>
       </c:txPr>
     </c:legend>
+    <c:plotVisOnly val="1"/>
     <c:dispBlanksAs val="gap"/>
+    <c:showDLblsOverMax val="0"/>
   </c:chart>
   <c:txPr>
     <a:bodyPr/>
@@ -3708,7 +3758,7 @@
                 </a:solidFill>
                 <a:latin typeface="Consolas"/>
               </a:rPr>
-              <a:t>HONEST LEDGER</a:t>
+              <a:t>THE CAPABILITY</a:t>
             </a:r>
           </a:p>
         </p:txBody>
@@ -3750,7 +3800,7 @@
                 </a:solidFill>
                 <a:latin typeface="Georgia"/>
               </a:rPr>
-              <a:t>What’s proven, what isn’t</a:t>
+              <a:t>We built the lab, not just the result</a:t>
             </a:r>
           </a:p>
         </p:txBody>
@@ -3763,8 +3813,8 @@
         </p:nvSpPr>
         <p:spPr>
           <a:xfrm>
-            <a:off x="640080" y="1965960"/>
-            <a:ext cx="5257800" cy="3977639"/>
+            <a:off x="640080" y="2560320"/>
+            <a:ext cx="1828800" cy="960120"/>
           </a:xfrm>
           <a:prstGeom prst="roundRect">
             <a:avLst>
@@ -3776,7 +3826,7 @@
           </a:solidFill>
           <a:ln w="12700">
             <a:solidFill>
-              <a:srgbClr val="2C5040"/>
+              <a:srgbClr val="25333A"/>
             </a:solidFill>
           </a:ln>
           <a:effectLst/>
@@ -3811,8 +3861,8 @@
         </p:nvSpPr>
         <p:spPr>
           <a:xfrm>
-            <a:off x="914400" y="2194560"/>
-            <a:ext cx="4709160" cy="3566160"/>
+            <a:off x="640080" y="2560320"/>
+            <a:ext cx="1828800" cy="960120"/>
           </a:xfrm>
           <a:prstGeom prst="rect">
             <a:avLst/>
@@ -3820,117 +3870,83 @@
           <a:noFill/>
         </p:spPr>
         <p:txBody>
-          <a:bodyPr wrap="square" anchor="t">
+          <a:bodyPr wrap="square" anchor="ctr">
             <a:spAutoFit/>
           </a:bodyPr>
           <a:lstStyle/>
           <a:p>
-            <a:pPr algn="l">
+            <a:pPr algn="ctr">
               <a:lnSpc>
                 <a:spcPct val="100000"/>
               </a:lnSpc>
               <a:spcAft>
-                <a:spcPts val="1000"/>
+                <a:spcPts val="0"/>
               </a:spcAft>
             </a:pPr>
             <a:r>
-              <a:rPr sz="1200" b="1">
-                <a:solidFill>
-                  <a:srgbClr val="57C08A"/>
-                </a:solidFill>
-                <a:latin typeface="Consolas"/>
+              <a:rPr sz="1400" b="1">
+                <a:solidFill>
+                  <a:srgbClr val="FFFFFF"/>
+                </a:solidFill>
+                <a:latin typeface="Calibri"/>
               </a:rPr>
-              <a:t>ESTABLISHED HERE</a:t>
-            </a:r>
-          </a:p>
-          <a:p>
-            <a:pPr algn="l">
+              <a:t>Provision GPU</a:t>
+            </a:r>
+          </a:p>
+        </p:txBody>
+      </p:sp>
+      <p:sp>
+        <p:nvSpPr>
+          <p:cNvPr id="7" name="TextBox 6"/>
+          <p:cNvSpPr txBox="1"/>
+          <p:nvPr/>
+        </p:nvSpPr>
+        <p:spPr>
+          <a:xfrm>
+            <a:off x="2468880" y="2560320"/>
+            <a:ext cx="502920" cy="960120"/>
+          </a:xfrm>
+          <a:prstGeom prst="rect">
+            <a:avLst/>
+          </a:prstGeom>
+          <a:noFill/>
+        </p:spPr>
+        <p:txBody>
+          <a:bodyPr wrap="square" anchor="ctr">
+            <a:spAutoFit/>
+          </a:bodyPr>
+          <a:lstStyle/>
+          <a:p>
+            <a:pPr algn="ctr">
               <a:lnSpc>
-                <a:spcPct val="112000"/>
+                <a:spcPct val="100000"/>
               </a:lnSpc>
               <a:spcAft>
-                <a:spcPts val="700"/>
+                <a:spcPts val="0"/>
               </a:spcAft>
             </a:pPr>
             <a:r>
-              <a:rPr sz="1400" b="0">
-                <a:solidFill>
-                  <a:srgbClr val="EEF3F3"/>
+              <a:rPr sz="2000" b="1">
+                <a:solidFill>
+                  <a:srgbClr val="3FB0C6"/>
                 </a:solidFill>
                 <a:latin typeface="Calibri"/>
               </a:rPr>
-              <a:t>▪  Equal task scores on our suites, every ratio.</a:t>
-            </a:r>
-          </a:p>
-          <a:p>
-            <a:pPr algn="l">
-              <a:lnSpc>
-                <a:spcPct val="112000"/>
-              </a:lnSpc>
-              <a:spcAft>
-                <a:spcPts val="700"/>
-              </a:spcAft>
-            </a:pPr>
-            <a:r>
-              <a:rPr sz="1400" b="0">
-                <a:solidFill>
-                  <a:srgbClr val="EEF3F3"/>
-                </a:solidFill>
-                <a:latin typeface="Calibri"/>
-              </a:rPr>
-              <a:t>▪  Half-to-two-thirds fewer tokens read per turn.</a:t>
-            </a:r>
-          </a:p>
-          <a:p>
-            <a:pPr algn="l">
-              <a:lnSpc>
-                <a:spcPct val="112000"/>
-              </a:lnSpc>
-              <a:spcAft>
-                <a:spcPts val="700"/>
-              </a:spcAft>
-            </a:pPr>
-            <a:r>
-              <a:rPr sz="1400" b="0">
-                <a:solidFill>
-                  <a:srgbClr val="EEF3F3"/>
-                </a:solidFill>
-                <a:latin typeface="Calibri"/>
-              </a:rPr>
-              <a:t>▪  Throughput rises under load; the fix removes the path failure.</a:t>
-            </a:r>
-          </a:p>
-          <a:p>
-            <a:pPr algn="l">
-              <a:lnSpc>
-                <a:spcPct val="112000"/>
-              </a:lnSpc>
-              <a:spcAft>
-                <a:spcPts val="700"/>
-              </a:spcAft>
-            </a:pPr>
-            <a:r>
-              <a:rPr sz="1400" b="0">
-                <a:solidFill>
-                  <a:srgbClr val="EEF3F3"/>
-                </a:solidFill>
-                <a:latin typeface="Calibri"/>
-              </a:rPr>
-              <a:t>▪  The tooling works end to end.</a:t>
-            </a:r>
-          </a:p>
-        </p:txBody>
-      </p:sp>
-      <p:sp>
-        <p:nvSpPr>
-          <p:cNvPr id="7" name="Rounded Rectangle 6"/>
+              <a:t>→</a:t>
+            </a:r>
+          </a:p>
+        </p:txBody>
+      </p:sp>
+      <p:sp>
+        <p:nvSpPr>
+          <p:cNvPr id="8" name="Rounded Rectangle 7"/>
           <p:cNvSpPr/>
           <p:nvPr/>
         </p:nvSpPr>
         <p:spPr>
           <a:xfrm>
-            <a:off x="6263640" y="1965960"/>
-            <a:ext cx="5257800" cy="3977639"/>
+            <a:off x="2971800" y="2560320"/>
+            <a:ext cx="1234440" cy="960120"/>
           </a:xfrm>
           <a:prstGeom prst="roundRect">
             <a:avLst>
@@ -3942,7 +3958,7 @@
           </a:solidFill>
           <a:ln w="12700">
             <a:solidFill>
-              <a:srgbClr val="5A4A24"/>
+              <a:srgbClr val="25333A"/>
             </a:solidFill>
           </a:ln>
           <a:effectLst/>
@@ -3971,14 +3987,14 @@
       </p:sp>
       <p:sp>
         <p:nvSpPr>
-          <p:cNvPr id="8" name="TextBox 7"/>
+          <p:cNvPr id="9" name="TextBox 8"/>
           <p:cNvSpPr txBox="1"/>
           <p:nvPr/>
         </p:nvSpPr>
         <p:spPr>
           <a:xfrm>
-            <a:off x="6537959" y="2194560"/>
-            <a:ext cx="4709160" cy="3566160"/>
+            <a:off x="2971800" y="2560320"/>
+            <a:ext cx="1234440" cy="960120"/>
           </a:xfrm>
           <a:prstGeom prst="rect">
             <a:avLst/>
@@ -3986,136 +4002,395 @@
           <a:noFill/>
         </p:spPr>
         <p:txBody>
-          <a:bodyPr wrap="square" anchor="t">
+          <a:bodyPr wrap="square" anchor="ctr">
             <a:spAutoFit/>
           </a:bodyPr>
           <a:lstStyle/>
           <a:p>
-            <a:pPr algn="l">
+            <a:pPr algn="ctr">
               <a:lnSpc>
                 <a:spcPct val="100000"/>
               </a:lnSpc>
               <a:spcAft>
-                <a:spcPts val="1000"/>
+                <a:spcPts val="0"/>
               </a:spcAft>
             </a:pPr>
             <a:r>
-              <a:rPr sz="1200" b="1">
-                <a:solidFill>
-                  <a:srgbClr val="E3B24C"/>
-                </a:solidFill>
-                <a:latin typeface="Consolas"/>
+              <a:rPr sz="1400" b="1">
+                <a:solidFill>
+                  <a:srgbClr val="FFFFFF"/>
+                </a:solidFill>
+                <a:latin typeface="Calibri"/>
               </a:rPr>
-              <a:t>NOT YET</a:t>
-            </a:r>
-          </a:p>
-          <a:p>
-            <a:pPr algn="l">
+              <a:t>Train</a:t>
+            </a:r>
+          </a:p>
+        </p:txBody>
+      </p:sp>
+      <p:sp>
+        <p:nvSpPr>
+          <p:cNvPr id="10" name="TextBox 9"/>
+          <p:cNvSpPr txBox="1"/>
+          <p:nvPr/>
+        </p:nvSpPr>
+        <p:spPr>
+          <a:xfrm>
+            <a:off x="4206240" y="2560320"/>
+            <a:ext cx="502920" cy="960120"/>
+          </a:xfrm>
+          <a:prstGeom prst="rect">
+            <a:avLst/>
+          </a:prstGeom>
+          <a:noFill/>
+        </p:spPr>
+        <p:txBody>
+          <a:bodyPr wrap="square" anchor="ctr">
+            <a:spAutoFit/>
+          </a:bodyPr>
+          <a:lstStyle/>
+          <a:p>
+            <a:pPr algn="ctr">
               <a:lnSpc>
-                <a:spcPct val="112000"/>
+                <a:spcPct val="100000"/>
               </a:lnSpc>
               <a:spcAft>
-                <a:spcPts val="700"/>
+                <a:spcPts val="0"/>
               </a:spcAft>
             </a:pPr>
             <a:r>
-              <a:rPr sz="1400" b="0">
-                <a:solidFill>
-                  <a:srgbClr val="EEF3F3"/>
+              <a:rPr sz="2000" b="1">
+                <a:solidFill>
+                  <a:srgbClr val="3FB0C6"/>
                 </a:solidFill>
                 <a:latin typeface="Calibri"/>
               </a:rPr>
-              <a:t>▪  Generalisation on unseen, held-out work.</a:t>
-            </a:r>
-          </a:p>
-          <a:p>
-            <a:pPr algn="l">
+              <a:t>→</a:t>
+            </a:r>
+          </a:p>
+        </p:txBody>
+      </p:sp>
+      <p:sp>
+        <p:nvSpPr>
+          <p:cNvPr id="11" name="Rounded Rectangle 10"/>
+          <p:cNvSpPr/>
+          <p:nvPr/>
+        </p:nvSpPr>
+        <p:spPr>
+          <a:xfrm>
+            <a:off x="4709159" y="2560320"/>
+            <a:ext cx="1234440" cy="960120"/>
+          </a:xfrm>
+          <a:prstGeom prst="roundRect">
+            <a:avLst>
+              <a:gd name="adj" fmla="val 6000"/>
+            </a:avLst>
+          </a:prstGeom>
+          <a:solidFill>
+            <a:srgbClr val="141D21"/>
+          </a:solidFill>
+          <a:ln w="12700">
+            <a:solidFill>
+              <a:srgbClr val="25333A"/>
+            </a:solidFill>
+          </a:ln>
+          <a:effectLst/>
+        </p:spPr>
+        <p:style>
+          <a:lnRef idx="1">
+            <a:schemeClr val="accent1"/>
+          </a:lnRef>
+          <a:fillRef idx="3">
+            <a:schemeClr val="accent1"/>
+          </a:fillRef>
+          <a:effectRef idx="2">
+            <a:schemeClr val="accent1"/>
+          </a:effectRef>
+          <a:fontRef idx="minor">
+            <a:schemeClr val="lt1"/>
+          </a:fontRef>
+        </p:style>
+        <p:txBody>
+          <a:bodyPr rtlCol="0" anchor="ctr"/>
+          <a:lstStyle/>
+          <a:p>
+            <a:pPr algn="ctr"/>
+          </a:p>
+        </p:txBody>
+      </p:sp>
+      <p:sp>
+        <p:nvSpPr>
+          <p:cNvPr id="12" name="TextBox 11"/>
+          <p:cNvSpPr txBox="1"/>
+          <p:nvPr/>
+        </p:nvSpPr>
+        <p:spPr>
+          <a:xfrm>
+            <a:off x="4709159" y="2560320"/>
+            <a:ext cx="1234440" cy="960120"/>
+          </a:xfrm>
+          <a:prstGeom prst="rect">
+            <a:avLst/>
+          </a:prstGeom>
+          <a:noFill/>
+        </p:spPr>
+        <p:txBody>
+          <a:bodyPr wrap="square" anchor="ctr">
+            <a:spAutoFit/>
+          </a:bodyPr>
+          <a:lstStyle/>
+          <a:p>
+            <a:pPr algn="ctr">
               <a:lnSpc>
-                <a:spcPct val="112000"/>
+                <a:spcPct val="100000"/>
               </a:lnSpc>
               <a:spcAft>
-                <a:spcPts val="700"/>
+                <a:spcPts val="0"/>
               </a:spcAft>
             </a:pPr>
             <a:r>
-              <a:rPr sz="1400" b="0">
-                <a:solidFill>
-                  <a:srgbClr val="EEF3F3"/>
+              <a:rPr sz="1400" b="1">
+                <a:solidFill>
+                  <a:srgbClr val="FFFFFF"/>
                 </a:solidFill>
                 <a:latin typeface="Calibri"/>
               </a:rPr>
-              <a:t>▪  A saturation test → a real sessions-per-GPU / $ number.</a:t>
-            </a:r>
-          </a:p>
-          <a:p>
-            <a:pPr algn="l">
+              <a:t>Serve</a:t>
+            </a:r>
+          </a:p>
+        </p:txBody>
+      </p:sp>
+      <p:sp>
+        <p:nvSpPr>
+          <p:cNvPr id="13" name="TextBox 12"/>
+          <p:cNvSpPr txBox="1"/>
+          <p:nvPr/>
+        </p:nvSpPr>
+        <p:spPr>
+          <a:xfrm>
+            <a:off x="5943600" y="2560320"/>
+            <a:ext cx="502920" cy="960120"/>
+          </a:xfrm>
+          <a:prstGeom prst="rect">
+            <a:avLst/>
+          </a:prstGeom>
+          <a:noFill/>
+        </p:spPr>
+        <p:txBody>
+          <a:bodyPr wrap="square" anchor="ctr">
+            <a:spAutoFit/>
+          </a:bodyPr>
+          <a:lstStyle/>
+          <a:p>
+            <a:pPr algn="ctr">
               <a:lnSpc>
-                <a:spcPct val="112000"/>
+                <a:spcPct val="100000"/>
               </a:lnSpc>
               <a:spcAft>
-                <a:spcPts val="700"/>
+                <a:spcPts val="0"/>
               </a:spcAft>
             </a:pPr>
             <a:r>
-              <a:rPr sz="1400" b="0">
-                <a:solidFill>
-                  <a:srgbClr val="EEF3F3"/>
+              <a:rPr sz="2000" b="1">
+                <a:solidFill>
+                  <a:srgbClr val="3FB0C6"/>
                 </a:solidFill>
                 <a:latin typeface="Calibri"/>
               </a:rPr>
-              <a:t>▪  The cause of the serving gain (a hypothesis).</a:t>
-            </a:r>
-          </a:p>
-          <a:p>
-            <a:pPr algn="l">
+              <a:t>→</a:t>
+            </a:r>
+          </a:p>
+        </p:txBody>
+      </p:sp>
+      <p:sp>
+        <p:nvSpPr>
+          <p:cNvPr id="14" name="Rounded Rectangle 13"/>
+          <p:cNvSpPr/>
+          <p:nvPr/>
+        </p:nvSpPr>
+        <p:spPr>
+          <a:xfrm>
+            <a:off x="6446520" y="2560320"/>
+            <a:ext cx="1554480" cy="960120"/>
+          </a:xfrm>
+          <a:prstGeom prst="roundRect">
+            <a:avLst>
+              <a:gd name="adj" fmla="val 6000"/>
+            </a:avLst>
+          </a:prstGeom>
+          <a:solidFill>
+            <a:srgbClr val="141D21"/>
+          </a:solidFill>
+          <a:ln w="12700">
+            <a:solidFill>
+              <a:srgbClr val="25333A"/>
+            </a:solidFill>
+          </a:ln>
+          <a:effectLst/>
+        </p:spPr>
+        <p:style>
+          <a:lnRef idx="1">
+            <a:schemeClr val="accent1"/>
+          </a:lnRef>
+          <a:fillRef idx="3">
+            <a:schemeClr val="accent1"/>
+          </a:fillRef>
+          <a:effectRef idx="2">
+            <a:schemeClr val="accent1"/>
+          </a:effectRef>
+          <a:fontRef idx="minor">
+            <a:schemeClr val="lt1"/>
+          </a:fontRef>
+        </p:style>
+        <p:txBody>
+          <a:bodyPr rtlCol="0" anchor="ctr"/>
+          <a:lstStyle/>
+          <a:p>
+            <a:pPr algn="ctr"/>
+          </a:p>
+        </p:txBody>
+      </p:sp>
+      <p:sp>
+        <p:nvSpPr>
+          <p:cNvPr id="15" name="TextBox 14"/>
+          <p:cNvSpPr txBox="1"/>
+          <p:nvPr/>
+        </p:nvSpPr>
+        <p:spPr>
+          <a:xfrm>
+            <a:off x="6446520" y="2560320"/>
+            <a:ext cx="1554480" cy="960120"/>
+          </a:xfrm>
+          <a:prstGeom prst="rect">
+            <a:avLst/>
+          </a:prstGeom>
+          <a:noFill/>
+        </p:spPr>
+        <p:txBody>
+          <a:bodyPr wrap="square" anchor="ctr">
+            <a:spAutoFit/>
+          </a:bodyPr>
+          <a:lstStyle/>
+          <a:p>
+            <a:pPr algn="ctr">
               <a:lnSpc>
-                <a:spcPct val="112000"/>
+                <a:spcPct val="100000"/>
               </a:lnSpc>
               <a:spcAft>
-                <a:spcPts val="700"/>
+                <a:spcPts val="0"/>
               </a:spcAft>
             </a:pPr>
             <a:r>
-              <a:rPr sz="1400" b="0">
-                <a:solidFill>
-                  <a:srgbClr val="EEF3F3"/>
+              <a:rPr sz="1400" b="1">
+                <a:solidFill>
+                  <a:srgbClr val="FFFFFF"/>
                 </a:solidFill>
                 <a:latin typeface="Calibri"/>
               </a:rPr>
-              <a:t>▪  Rare-tool reach (left unscored by harness faults).</a:t>
-            </a:r>
-          </a:p>
-          <a:p>
-            <a:pPr algn="l">
+              <a:t>Evaluate</a:t>
+            </a:r>
+          </a:p>
+        </p:txBody>
+      </p:sp>
+      <p:sp>
+        <p:nvSpPr>
+          <p:cNvPr id="16" name="TextBox 15"/>
+          <p:cNvSpPr txBox="1"/>
+          <p:nvPr/>
+        </p:nvSpPr>
+        <p:spPr>
+          <a:xfrm>
+            <a:off x="8001000" y="2560320"/>
+            <a:ext cx="502920" cy="960120"/>
+          </a:xfrm>
+          <a:prstGeom prst="rect">
+            <a:avLst/>
+          </a:prstGeom>
+          <a:noFill/>
+        </p:spPr>
+        <p:txBody>
+          <a:bodyPr wrap="square" anchor="ctr">
+            <a:spAutoFit/>
+          </a:bodyPr>
+          <a:lstStyle/>
+          <a:p>
+            <a:pPr algn="ctr">
               <a:lnSpc>
-                <a:spcPct val="112000"/>
+                <a:spcPct val="100000"/>
               </a:lnSpc>
               <a:spcAft>
-                <a:spcPts val="700"/>
+                <a:spcPts val="0"/>
               </a:spcAft>
             </a:pPr>
             <a:r>
-              <a:rPr sz="1400" b="0">
-                <a:solidFill>
-                  <a:srgbClr val="EEF3F3"/>
+              <a:rPr sz="2000" b="1">
+                <a:solidFill>
+                  <a:srgbClr val="3FB0C6"/>
                 </a:solidFill>
                 <a:latin typeface="Calibri"/>
               </a:rPr>
-              <a:t>▪  Audit guarantees that compressed rules still bind.</a:t>
-            </a:r>
-          </a:p>
-        </p:txBody>
-      </p:sp>
-      <p:sp>
-        <p:nvSpPr>
-          <p:cNvPr id="9" name="TextBox 8"/>
+              <a:t>→</a:t>
+            </a:r>
+          </a:p>
+        </p:txBody>
+      </p:sp>
+      <p:sp>
+        <p:nvSpPr>
+          <p:cNvPr id="17" name="Rounded Rectangle 16"/>
+          <p:cNvSpPr/>
+          <p:nvPr/>
+        </p:nvSpPr>
+        <p:spPr>
+          <a:xfrm>
+            <a:off x="8503920" y="2560320"/>
+            <a:ext cx="1371600" cy="960120"/>
+          </a:xfrm>
+          <a:prstGeom prst="roundRect">
+            <a:avLst>
+              <a:gd name="adj" fmla="val 6000"/>
+            </a:avLst>
+          </a:prstGeom>
+          <a:solidFill>
+            <a:srgbClr val="141D21"/>
+          </a:solidFill>
+          <a:ln w="12700">
+            <a:solidFill>
+              <a:srgbClr val="25333A"/>
+            </a:solidFill>
+          </a:ln>
+          <a:effectLst/>
+        </p:spPr>
+        <p:style>
+          <a:lnRef idx="1">
+            <a:schemeClr val="accent1"/>
+          </a:lnRef>
+          <a:fillRef idx="3">
+            <a:schemeClr val="accent1"/>
+          </a:fillRef>
+          <a:effectRef idx="2">
+            <a:schemeClr val="accent1"/>
+          </a:effectRef>
+          <a:fontRef idx="minor">
+            <a:schemeClr val="lt1"/>
+          </a:fontRef>
+        </p:style>
+        <p:txBody>
+          <a:bodyPr rtlCol="0" anchor="ctr"/>
+          <a:lstStyle/>
+          <a:p>
+            <a:pPr algn="ctr"/>
+          </a:p>
+        </p:txBody>
+      </p:sp>
+      <p:sp>
+        <p:nvSpPr>
+          <p:cNvPr id="18" name="TextBox 17"/>
           <p:cNvSpPr txBox="1"/>
           <p:nvPr/>
         </p:nvSpPr>
         <p:spPr>
           <a:xfrm>
-            <a:off x="640080" y="6080760"/>
-            <a:ext cx="10881360" cy="457200"/>
+            <a:off x="8503920" y="2560320"/>
+            <a:ext cx="1371600" cy="960120"/>
           </a:xfrm>
           <a:prstGeom prst="rect">
             <a:avLst/>
@@ -4123,7 +4398,227 @@
           <a:noFill/>
         </p:spPr>
         <p:txBody>
-          <a:bodyPr wrap="square" anchor="t">
+          <a:bodyPr wrap="square" anchor="ctr">
+            <a:spAutoFit/>
+          </a:bodyPr>
+          <a:lstStyle/>
+          <a:p>
+            <a:pPr algn="ctr">
+              <a:lnSpc>
+                <a:spcPct val="100000"/>
+              </a:lnSpc>
+              <a:spcAft>
+                <a:spcPts val="0"/>
+              </a:spcAft>
+            </a:pPr>
+            <a:r>
+              <a:rPr sz="1400" b="1">
+                <a:solidFill>
+                  <a:srgbClr val="FFFFFF"/>
+                </a:solidFill>
+                <a:latin typeface="Calibri"/>
+              </a:rPr>
+              <a:t>Destroy</a:t>
+            </a:r>
+          </a:p>
+        </p:txBody>
+      </p:sp>
+      <p:sp>
+        <p:nvSpPr>
+          <p:cNvPr id="19" name="TextBox 18"/>
+          <p:cNvSpPr txBox="1"/>
+          <p:nvPr/>
+        </p:nvSpPr>
+        <p:spPr>
+          <a:xfrm>
+            <a:off x="9875520" y="2560320"/>
+            <a:ext cx="502920" cy="960120"/>
+          </a:xfrm>
+          <a:prstGeom prst="rect">
+            <a:avLst/>
+          </a:prstGeom>
+          <a:noFill/>
+        </p:spPr>
+        <p:txBody>
+          <a:bodyPr wrap="square" anchor="ctr">
+            <a:spAutoFit/>
+          </a:bodyPr>
+          <a:lstStyle/>
+          <a:p>
+            <a:pPr algn="ctr">
+              <a:lnSpc>
+                <a:spcPct val="100000"/>
+              </a:lnSpc>
+              <a:spcAft>
+                <a:spcPts val="0"/>
+              </a:spcAft>
+            </a:pPr>
+            <a:r>
+              <a:rPr sz="2000" b="1">
+                <a:solidFill>
+                  <a:srgbClr val="E08A4C"/>
+                </a:solidFill>
+                <a:latin typeface="Calibri"/>
+              </a:rPr>
+              <a:t>↺</a:t>
+            </a:r>
+          </a:p>
+        </p:txBody>
+      </p:sp>
+      <p:sp>
+        <p:nvSpPr>
+          <p:cNvPr id="20" name="Rounded Rectangle 19"/>
+          <p:cNvSpPr/>
+          <p:nvPr/>
+        </p:nvSpPr>
+        <p:spPr>
+          <a:xfrm>
+            <a:off x="10378440" y="2560320"/>
+            <a:ext cx="1554480" cy="960120"/>
+          </a:xfrm>
+          <a:prstGeom prst="roundRect">
+            <a:avLst>
+              <a:gd name="adj" fmla="val 6000"/>
+            </a:avLst>
+          </a:prstGeom>
+          <a:noFill/>
+          <a:ln w="12700">
+            <a:solidFill>
+              <a:srgbClr val="3A4A51"/>
+            </a:solidFill>
+          </a:ln>
+          <a:effectLst/>
+        </p:spPr>
+        <p:style>
+          <a:lnRef idx="1">
+            <a:schemeClr val="accent1"/>
+          </a:lnRef>
+          <a:fillRef idx="3">
+            <a:schemeClr val="accent1"/>
+          </a:fillRef>
+          <a:effectRef idx="2">
+            <a:schemeClr val="accent1"/>
+          </a:effectRef>
+          <a:fontRef idx="minor">
+            <a:schemeClr val="lt1"/>
+          </a:fontRef>
+        </p:style>
+        <p:txBody>
+          <a:bodyPr rtlCol="0" anchor="ctr"/>
+          <a:lstStyle/>
+          <a:p>
+            <a:pPr algn="ctr"/>
+          </a:p>
+        </p:txBody>
+      </p:sp>
+      <p:sp>
+        <p:nvSpPr>
+          <p:cNvPr id="21" name="TextBox 20"/>
+          <p:cNvSpPr txBox="1"/>
+          <p:nvPr/>
+        </p:nvSpPr>
+        <p:spPr>
+          <a:xfrm>
+            <a:off x="10378440" y="2560320"/>
+            <a:ext cx="1554480" cy="960120"/>
+          </a:xfrm>
+          <a:prstGeom prst="rect">
+            <a:avLst/>
+          </a:prstGeom>
+          <a:noFill/>
+        </p:spPr>
+        <p:txBody>
+          <a:bodyPr wrap="square" anchor="ctr">
+            <a:spAutoFit/>
+          </a:bodyPr>
+          <a:lstStyle/>
+          <a:p>
+            <a:pPr algn="ctr">
+              <a:lnSpc>
+                <a:spcPct val="100000"/>
+              </a:lnSpc>
+              <a:spcAft>
+                <a:spcPts val="0"/>
+              </a:spcAft>
+            </a:pPr>
+            <a:r>
+              <a:rPr sz="1300" b="0">
+                <a:solidFill>
+                  <a:srgbClr val="9FB2B6"/>
+                </a:solidFill>
+                <a:latin typeface="Calibri"/>
+              </a:rPr>
+              <a:t>next recipe</a:t>
+            </a:r>
+          </a:p>
+        </p:txBody>
+      </p:sp>
+      <p:sp>
+        <p:nvSpPr>
+          <p:cNvPr id="22" name="Rounded Rectangle 21"/>
+          <p:cNvSpPr/>
+          <p:nvPr/>
+        </p:nvSpPr>
+        <p:spPr>
+          <a:xfrm>
+            <a:off x="640080" y="3977639"/>
+            <a:ext cx="10881360" cy="868680"/>
+          </a:xfrm>
+          <a:prstGeom prst="roundRect">
+            <a:avLst>
+              <a:gd name="adj" fmla="val 6000"/>
+            </a:avLst>
+          </a:prstGeom>
+          <a:solidFill>
+            <a:srgbClr val="221A11"/>
+          </a:solidFill>
+          <a:ln w="12700">
+            <a:solidFill>
+              <a:srgbClr val="5A4A2A"/>
+            </a:solidFill>
+          </a:ln>
+          <a:effectLst/>
+        </p:spPr>
+        <p:style>
+          <a:lnRef idx="1">
+            <a:schemeClr val="accent1"/>
+          </a:lnRef>
+          <a:fillRef idx="3">
+            <a:schemeClr val="accent1"/>
+          </a:fillRef>
+          <a:effectRef idx="2">
+            <a:schemeClr val="accent1"/>
+          </a:effectRef>
+          <a:fontRef idx="minor">
+            <a:schemeClr val="lt1"/>
+          </a:fontRef>
+        </p:style>
+        <p:txBody>
+          <a:bodyPr rtlCol="0" anchor="ctr"/>
+          <a:lstStyle/>
+          <a:p>
+            <a:pPr algn="ctr"/>
+          </a:p>
+        </p:txBody>
+      </p:sp>
+      <p:sp>
+        <p:nvSpPr>
+          <p:cNvPr id="23" name="TextBox 22"/>
+          <p:cNvSpPr txBox="1"/>
+          <p:nvPr/>
+        </p:nvSpPr>
+        <p:spPr>
+          <a:xfrm>
+            <a:off x="868680" y="3977639"/>
+            <a:ext cx="10424160" cy="868680"/>
+          </a:xfrm>
+          <a:prstGeom prst="rect">
+            <a:avLst/>
+          </a:prstGeom>
+          <a:noFill/>
+        </p:spPr>
+        <p:txBody>
+          <a:bodyPr wrap="square" anchor="ctr">
             <a:spAutoFit/>
           </a:bodyPr>
           <a:lstStyle/>
@@ -4137,13 +4632,55 @@
               </a:spcAft>
             </a:pPr>
             <a:r>
-              <a:rPr sz="1200" b="0">
+              <a:rPr sz="1300" b="0">
+                <a:solidFill>
+                  <a:srgbClr val="E08A4C"/>
+                </a:solidFill>
+                <a:latin typeface="Consolas"/>
+              </a:rPr>
+              <a:t>SPEND-SAFETY · structural  ·  idle watchdog · ledger at creation · sync-before-destroy · global deadline</a:t>
+            </a:r>
+          </a:p>
+        </p:txBody>
+      </p:sp>
+      <p:sp>
+        <p:nvSpPr>
+          <p:cNvPr id="24" name="TextBox 23"/>
+          <p:cNvSpPr txBox="1"/>
+          <p:nvPr/>
+        </p:nvSpPr>
+        <p:spPr>
+          <a:xfrm>
+            <a:off x="640080" y="5120640"/>
+            <a:ext cx="10881360" cy="731520"/>
+          </a:xfrm>
+          <a:prstGeom prst="rect">
+            <a:avLst/>
+          </a:prstGeom>
+          <a:noFill/>
+        </p:spPr>
+        <p:txBody>
+          <a:bodyPr wrap="square" anchor="t">
+            <a:spAutoFit/>
+          </a:bodyPr>
+          <a:lstStyle/>
+          <a:p>
+            <a:pPr algn="l">
+              <a:lnSpc>
+                <a:spcPct val="120000"/>
+              </a:lnSpc>
+              <a:spcAft>
+                <a:spcPts val="0"/>
+              </a:spcAft>
+            </a:pPr>
+            <a:r>
+              <a:rPr sz="1400" b="0">
                 <a:solidFill>
                   <a:srgbClr val="9FB2B6"/>
                 </a:solidFill>
                 <a:latin typeface="Calibri"/>
               </a:rPr>
-              <a:t>An independent adversarial review of the whole program was run and folded into the writeup.</a:t>
+              <a:t>One detached controller drives every recipe end to end, unattended. Makes the next model cheap to try: the capability outlasts this study.</a:t>
             </a:r>
           </a:p>
         </p:txBody>
@@ -4247,7 +4784,7 @@
                 </a:solidFill>
                 <a:latin typeface="Consolas"/>
               </a:rPr>
-              <a:t>THE ASK</a:t>
+              <a:t>HONEST LEDGER</a:t>
             </a:r>
           </a:p>
         </p:txBody>
@@ -4289,7 +4826,7 @@
                 </a:solidFill>
                 <a:latin typeface="Georgia"/>
               </a:rPr>
-              <a:t>From “real lever” to a number you can budget</a:t>
+              <a:t>What’s proven, what isn’t</a:t>
             </a:r>
           </a:p>
         </p:txBody>
@@ -4302,8 +4839,8 @@
         </p:nvSpPr>
         <p:spPr>
           <a:xfrm>
-            <a:off x="640080" y="2011680"/>
-            <a:ext cx="3429000" cy="3108960"/>
+            <a:off x="640080" y="1965960"/>
+            <a:ext cx="5257800" cy="3977639"/>
           </a:xfrm>
           <a:prstGeom prst="roundRect">
             <a:avLst>
@@ -4315,7 +4852,7 @@
           </a:solidFill>
           <a:ln w="12700">
             <a:solidFill>
-              <a:srgbClr val="25333A"/>
+              <a:srgbClr val="2C5040"/>
             </a:solidFill>
           </a:ln>
           <a:effectLst/>
@@ -4350,8 +4887,8 @@
         </p:nvSpPr>
         <p:spPr>
           <a:xfrm>
-            <a:off x="896112" y="2231136"/>
-            <a:ext cx="2916936" cy="2670048"/>
+            <a:off x="914400" y="2194560"/>
+            <a:ext cx="4709160" cy="3566160"/>
           </a:xfrm>
           <a:prstGeom prst="rect">
             <a:avLst/>
@@ -4366,20 +4903,115 @@
           <a:p>
             <a:pPr algn="l">
               <a:lnSpc>
-                <a:spcPct val="120000"/>
+                <a:spcPct val="100000"/>
               </a:lnSpc>
               <a:spcAft>
-                <a:spcPts val="0"/>
+                <a:spcPts val="1000"/>
               </a:spcAft>
             </a:pPr>
             <a:r>
-              <a:rPr sz="1500" b="0">
+              <a:rPr sz="1200" b="1">
+                <a:solidFill>
+                  <a:srgbClr val="57C08A"/>
+                </a:solidFill>
+                <a:latin typeface="Consolas"/>
+              </a:rPr>
+              <a:t>ESTABLISHED HERE</a:t>
+            </a:r>
+          </a:p>
+          <a:p>
+            <a:pPr algn="l">
+              <a:lnSpc>
+                <a:spcPct val="112000"/>
+              </a:lnSpc>
+              <a:spcAft>
+                <a:spcPts val="700"/>
+              </a:spcAft>
+            </a:pPr>
+            <a:r>
+              <a:rPr sz="1400" b="0">
                 <a:solidFill>
                   <a:srgbClr val="EEF3F3"/>
                 </a:solidFill>
                 <a:latin typeface="Calibri"/>
               </a:rPr>
-              <a:t>A held-out eval with paired, repeated runs. Is the parity real beyond our own tasks?</a:t>
+              <a:t>▪  Equal task scores on our suites, every ratio.</a:t>
+            </a:r>
+          </a:p>
+          <a:p>
+            <a:pPr algn="l">
+              <a:lnSpc>
+                <a:spcPct val="112000"/>
+              </a:lnSpc>
+              <a:spcAft>
+                <a:spcPts val="700"/>
+              </a:spcAft>
+            </a:pPr>
+            <a:r>
+              <a:rPr sz="1400" b="0">
+                <a:solidFill>
+                  <a:srgbClr val="EEF3F3"/>
+                </a:solidFill>
+                <a:latin typeface="Calibri"/>
+              </a:rPr>
+              <a:t>▪  Half-to-two-thirds fewer tokens read per turn.</a:t>
+            </a:r>
+          </a:p>
+          <a:p>
+            <a:pPr algn="l">
+              <a:lnSpc>
+                <a:spcPct val="112000"/>
+              </a:lnSpc>
+              <a:spcAft>
+                <a:spcPts val="700"/>
+              </a:spcAft>
+            </a:pPr>
+            <a:r>
+              <a:rPr sz="1400" b="0">
+                <a:solidFill>
+                  <a:srgbClr val="EEF3F3"/>
+                </a:solidFill>
+                <a:latin typeface="Calibri"/>
+              </a:rPr>
+              <a:t>▪  2x load within SLO, +44% peak on a tuned server, 3 repeats, 0 failures.</a:t>
+            </a:r>
+          </a:p>
+          <a:p>
+            <a:pPr algn="l">
+              <a:lnSpc>
+                <a:spcPct val="112000"/>
+              </a:lnSpc>
+              <a:spcAft>
+                <a:spcPts val="700"/>
+              </a:spcAft>
+            </a:pPr>
+            <a:r>
+              <a:rPr sz="1400" b="0">
+                <a:solidFill>
+                  <a:srgbClr val="EEF3F3"/>
+                </a:solidFill>
+                <a:latin typeface="Calibri"/>
+              </a:rPr>
+              <a:t>▪  Incremental over prefix caching (2–4x without it); mechanism measured.</a:t>
+            </a:r>
+          </a:p>
+          <a:p>
+            <a:pPr algn="l">
+              <a:lnSpc>
+                <a:spcPct val="112000"/>
+              </a:lnSpc>
+              <a:spcAft>
+                <a:spcPts val="700"/>
+              </a:spcAft>
+            </a:pPr>
+            <a:r>
+              <a:rPr sz="1400" b="0">
+                <a:solidFill>
+                  <a:srgbClr val="EEF3F3"/>
+                </a:solidFill>
+                <a:latin typeface="Calibri"/>
+              </a:rPr>
+              <a:t>▪  Throughput per dollar on two GPU classes; the fix removes the path failure.</a:t>
             </a:r>
           </a:p>
         </p:txBody>
@@ -4392,8 +5024,8 @@
         </p:nvSpPr>
         <p:spPr>
           <a:xfrm>
-            <a:off x="4251960" y="2011680"/>
-            <a:ext cx="3429000" cy="3108960"/>
+            <a:off x="6263640" y="1965960"/>
+            <a:ext cx="5257800" cy="3977639"/>
           </a:xfrm>
           <a:prstGeom prst="roundRect">
             <a:avLst>
@@ -4405,7 +5037,7 @@
           </a:solidFill>
           <a:ln w="12700">
             <a:solidFill>
-              <a:srgbClr val="25333A"/>
+              <a:srgbClr val="5A4A24"/>
             </a:solidFill>
           </a:ln>
           <a:effectLst/>
@@ -4440,8 +5072,8 @@
         </p:nvSpPr>
         <p:spPr>
           <a:xfrm>
-            <a:off x="4507992" y="2231136"/>
-            <a:ext cx="2916936" cy="2670048"/>
+            <a:off x="6537959" y="2194560"/>
+            <a:ext cx="4709160" cy="3566160"/>
           </a:xfrm>
           <a:prstGeom prst="rect">
             <a:avLst/>
@@ -4456,124 +5088,110 @@
           <a:p>
             <a:pPr algn="l">
               <a:lnSpc>
-                <a:spcPct val="120000"/>
+                <a:spcPct val="100000"/>
               </a:lnSpc>
               <a:spcAft>
-                <a:spcPts val="0"/>
+                <a:spcPts val="1000"/>
               </a:spcAft>
             </a:pPr>
             <a:r>
-              <a:rPr sz="1500" b="0">
+              <a:rPr sz="1200" b="1">
+                <a:solidFill>
+                  <a:srgbClr val="E3B24C"/>
+                </a:solidFill>
+                <a:latin typeface="Consolas"/>
+              </a:rPr>
+              <a:t>NOT YET</a:t>
+            </a:r>
+          </a:p>
+          <a:p>
+            <a:pPr algn="l">
+              <a:lnSpc>
+                <a:spcPct val="112000"/>
+              </a:lnSpc>
+              <a:spcAft>
+                <a:spcPts val="700"/>
+              </a:spcAft>
+            </a:pPr>
+            <a:r>
+              <a:rPr sz="1400" b="0">
                 <a:solidFill>
                   <a:srgbClr val="EEF3F3"/>
                 </a:solidFill>
                 <a:latin typeface="Calibri"/>
               </a:rPr>
-              <a:t>A saturation test under sustained load. Converts “throughput direction” into sessions per GPU and a cost per session.</a:t>
-            </a:r>
-          </a:p>
-        </p:txBody>
-      </p:sp>
-      <p:sp>
-        <p:nvSpPr>
-          <p:cNvPr id="9" name="Rounded Rectangle 8"/>
-          <p:cNvSpPr/>
-          <p:nvPr/>
-        </p:nvSpPr>
-        <p:spPr>
-          <a:xfrm>
-            <a:off x="7863840" y="2011680"/>
-            <a:ext cx="3429000" cy="3108960"/>
-          </a:xfrm>
-          <a:prstGeom prst="roundRect">
-            <a:avLst>
-              <a:gd name="adj" fmla="val 6000"/>
-            </a:avLst>
-          </a:prstGeom>
-          <a:solidFill>
-            <a:srgbClr val="141D21"/>
-          </a:solidFill>
-          <a:ln w="12700">
-            <a:solidFill>
-              <a:srgbClr val="25333A"/>
-            </a:solidFill>
-          </a:ln>
-          <a:effectLst/>
-        </p:spPr>
-        <p:style>
-          <a:lnRef idx="1">
-            <a:schemeClr val="accent1"/>
-          </a:lnRef>
-          <a:fillRef idx="3">
-            <a:schemeClr val="accent1"/>
-          </a:fillRef>
-          <a:effectRef idx="2">
-            <a:schemeClr val="accent1"/>
-          </a:effectRef>
-          <a:fontRef idx="minor">
-            <a:schemeClr val="lt1"/>
-          </a:fontRef>
-        </p:style>
-        <p:txBody>
-          <a:bodyPr rtlCol="0" anchor="ctr"/>
-          <a:lstStyle/>
-          <a:p>
-            <a:pPr algn="ctr"/>
-          </a:p>
-        </p:txBody>
-      </p:sp>
-      <p:sp>
-        <p:nvSpPr>
-          <p:cNvPr id="10" name="TextBox 9"/>
-          <p:cNvSpPr txBox="1"/>
-          <p:nvPr/>
-        </p:nvSpPr>
-        <p:spPr>
-          <a:xfrm>
-            <a:off x="8119871" y="2231136"/>
-            <a:ext cx="2916936" cy="2670048"/>
-          </a:xfrm>
-          <a:prstGeom prst="rect">
-            <a:avLst/>
-          </a:prstGeom>
-          <a:noFill/>
-        </p:spPr>
-        <p:txBody>
-          <a:bodyPr wrap="square" anchor="t">
-            <a:spAutoFit/>
-          </a:bodyPr>
-          <a:lstStyle/>
+              <a:t>▪  Generalisation on unseen, held-out work.</a:t>
+            </a:r>
+          </a:p>
           <a:p>
             <a:pPr algn="l">
               <a:lnSpc>
-                <a:spcPct val="120000"/>
+                <a:spcPct val="112000"/>
               </a:lnSpc>
               <a:spcAft>
-                <a:spcPts val="0"/>
+                <a:spcPts val="700"/>
               </a:spcAft>
             </a:pPr>
             <a:r>
-              <a:rPr sz="1500" b="0">
+              <a:rPr sz="1400" b="0">
                 <a:solidFill>
                   <a:srgbClr val="EEF3F3"/>
                 </a:solidFill>
                 <a:latin typeface="Calibri"/>
               </a:rPr>
-              <a:t>A guarded rollout with explicit rule-audit and write-target checks at the serving boundary.</a:t>
-            </a:r>
-          </a:p>
-        </p:txBody>
-      </p:sp>
-      <p:sp>
-        <p:nvSpPr>
-          <p:cNvPr id="11" name="TextBox 10"/>
+              <a:t>▪  Per-hardware tuning (the H200 ran an H100-tuned config; one regression at 16 sessions).</a:t>
+            </a:r>
+          </a:p>
+          <a:p>
+            <a:pPr algn="l">
+              <a:lnSpc>
+                <a:spcPct val="112000"/>
+              </a:lnSpc>
+              <a:spcAft>
+                <a:spcPts val="700"/>
+              </a:spcAft>
+            </a:pPr>
+            <a:r>
+              <a:rPr sz="1400" b="0">
+                <a:solidFill>
+                  <a:srgbClr val="EEF3F3"/>
+                </a:solidFill>
+                <a:latin typeface="Calibri"/>
+              </a:rPr>
+              <a:t>▪  Rare-tool reach (left unscored by harness faults).</a:t>
+            </a:r>
+          </a:p>
+          <a:p>
+            <a:pPr algn="l">
+              <a:lnSpc>
+                <a:spcPct val="112000"/>
+              </a:lnSpc>
+              <a:spcAft>
+                <a:spcPts val="700"/>
+              </a:spcAft>
+            </a:pPr>
+            <a:r>
+              <a:rPr sz="1400" b="0">
+                <a:solidFill>
+                  <a:srgbClr val="EEF3F3"/>
+                </a:solidFill>
+                <a:latin typeface="Calibri"/>
+              </a:rPr>
+              <a:t>▪  Audit guarantees that compressed rules still bind.</a:t>
+            </a:r>
+          </a:p>
+        </p:txBody>
+      </p:sp>
+      <p:sp>
+        <p:nvSpPr>
+          <p:cNvPr id="9" name="TextBox 8"/>
           <p:cNvSpPr txBox="1"/>
           <p:nvPr/>
         </p:nvSpPr>
         <p:spPr>
           <a:xfrm>
-            <a:off x="640080" y="5486400"/>
-            <a:ext cx="10881360" cy="640080"/>
+            <a:off x="640080" y="6080760"/>
+            <a:ext cx="10881360" cy="457200"/>
           </a:xfrm>
           <a:prstGeom prst="rect">
             <a:avLst/>
@@ -4595,13 +5213,13 @@
               </a:spcAft>
             </a:pPr>
             <a:r>
-              <a:rPr sz="1300" b="0">
+              <a:rPr sz="1200" b="0">
                 <a:solidFill>
                   <a:srgbClr val="9FB2B6"/>
                 </a:solidFill>
                 <a:latin typeface="Calibri"/>
               </a:rPr>
-              <a:t>Bounded effort: a single GPU over days, not a new research program; the loop and serving path already exist.</a:t>
+              <a:t>An independent adversarial review of the whole program was run and folded into the writeup.</a:t>
             </a:r>
           </a:p>
         </p:txBody>
@@ -4705,7 +5323,7 @@
                 </a:solidFill>
                 <a:latin typeface="Consolas"/>
               </a:rPr>
-              <a:t>DECISION</a:t>
+              <a:t>THE ASK</a:t>
             </a:r>
           </a:p>
         </p:txBody>
@@ -4747,21 +5365,69 @@
                 </a:solidFill>
                 <a:latin typeface="Georgia"/>
               </a:rPr>
-              <a:t>The lever is real and cheap to prototype</a:t>
-            </a:r>
-          </a:p>
-        </p:txBody>
-      </p:sp>
-      <p:sp>
-        <p:nvSpPr>
-          <p:cNvPr id="5" name="TextBox 4"/>
+              <a:t>From “real lever” to a number you can budget</a:t>
+            </a:r>
+          </a:p>
+        </p:txBody>
+      </p:sp>
+      <p:sp>
+        <p:nvSpPr>
+          <p:cNvPr id="5" name="Rounded Rectangle 4"/>
+          <p:cNvSpPr/>
+          <p:nvPr/>
+        </p:nvSpPr>
+        <p:spPr>
+          <a:xfrm>
+            <a:off x="640080" y="2011680"/>
+            <a:ext cx="3429000" cy="3108960"/>
+          </a:xfrm>
+          <a:prstGeom prst="roundRect">
+            <a:avLst>
+              <a:gd name="adj" fmla="val 6000"/>
+            </a:avLst>
+          </a:prstGeom>
+          <a:solidFill>
+            <a:srgbClr val="141D21"/>
+          </a:solidFill>
+          <a:ln w="12700">
+            <a:solidFill>
+              <a:srgbClr val="25333A"/>
+            </a:solidFill>
+          </a:ln>
+          <a:effectLst/>
+        </p:spPr>
+        <p:style>
+          <a:lnRef idx="1">
+            <a:schemeClr val="accent1"/>
+          </a:lnRef>
+          <a:fillRef idx="3">
+            <a:schemeClr val="accent1"/>
+          </a:fillRef>
+          <a:effectRef idx="2">
+            <a:schemeClr val="accent1"/>
+          </a:effectRef>
+          <a:fontRef idx="minor">
+            <a:schemeClr val="lt1"/>
+          </a:fontRef>
+        </p:style>
+        <p:txBody>
+          <a:bodyPr rtlCol="0" anchor="ctr"/>
+          <a:lstStyle/>
+          <a:p>
+            <a:pPr algn="ctr"/>
+          </a:p>
+        </p:txBody>
+      </p:sp>
+      <p:sp>
+        <p:nvSpPr>
+          <p:cNvPr id="6" name="TextBox 5"/>
           <p:cNvSpPr txBox="1"/>
           <p:nvPr/>
         </p:nvSpPr>
         <p:spPr>
           <a:xfrm>
-            <a:off x="640080" y="2103120"/>
-            <a:ext cx="9601200" cy="1463040"/>
+            <a:off x="896112" y="2231136"/>
+            <a:ext cx="2916936" cy="2670048"/>
           </a:xfrm>
           <a:prstGeom prst="rect">
             <a:avLst/>
@@ -4776,34 +5442,82 @@
           <a:p>
             <a:pPr algn="l">
               <a:lnSpc>
-                <a:spcPct val="110000"/>
+                <a:spcPct val="120000"/>
               </a:lnSpc>
               <a:spcAft>
                 <a:spcPts val="0"/>
               </a:spcAft>
             </a:pPr>
             <a:r>
-              <a:rPr sz="3000" b="1">
-                <a:solidFill>
-                  <a:srgbClr val="FFFFFF"/>
-                </a:solidFill>
-                <a:latin typeface="Georgia"/>
+              <a:rPr sz="1500" b="0">
+                <a:solidFill>
+                  <a:srgbClr val="EEF3F3"/>
+                </a:solidFill>
+                <a:latin typeface="Calibri"/>
               </a:rPr>
-              <a:t>Fund a short validation (eval + saturation) before any production commitment.</a:t>
-            </a:r>
-          </a:p>
-        </p:txBody>
-      </p:sp>
-      <p:sp>
-        <p:nvSpPr>
-          <p:cNvPr id="6" name="TextBox 5"/>
+              <a:t>A held-out eval with paired, repeated runs. Is the parity real beyond our own tasks?</a:t>
+            </a:r>
+          </a:p>
+        </p:txBody>
+      </p:sp>
+      <p:sp>
+        <p:nvSpPr>
+          <p:cNvPr id="7" name="Rounded Rectangle 6"/>
+          <p:cNvSpPr/>
+          <p:nvPr/>
+        </p:nvSpPr>
+        <p:spPr>
+          <a:xfrm>
+            <a:off x="4251960" y="2011680"/>
+            <a:ext cx="3429000" cy="3108960"/>
+          </a:xfrm>
+          <a:prstGeom prst="roundRect">
+            <a:avLst>
+              <a:gd name="adj" fmla="val 6000"/>
+            </a:avLst>
+          </a:prstGeom>
+          <a:solidFill>
+            <a:srgbClr val="141D21"/>
+          </a:solidFill>
+          <a:ln w="12700">
+            <a:solidFill>
+              <a:srgbClr val="25333A"/>
+            </a:solidFill>
+          </a:ln>
+          <a:effectLst/>
+        </p:spPr>
+        <p:style>
+          <a:lnRef idx="1">
+            <a:schemeClr val="accent1"/>
+          </a:lnRef>
+          <a:fillRef idx="3">
+            <a:schemeClr val="accent1"/>
+          </a:fillRef>
+          <a:effectRef idx="2">
+            <a:schemeClr val="accent1"/>
+          </a:effectRef>
+          <a:fontRef idx="minor">
+            <a:schemeClr val="lt1"/>
+          </a:fontRef>
+        </p:style>
+        <p:txBody>
+          <a:bodyPr rtlCol="0" anchor="ctr"/>
+          <a:lstStyle/>
+          <a:p>
+            <a:pPr algn="ctr"/>
+          </a:p>
+        </p:txBody>
+      </p:sp>
+      <p:sp>
+        <p:nvSpPr>
+          <p:cNvPr id="8" name="TextBox 7"/>
           <p:cNvSpPr txBox="1"/>
           <p:nvPr/>
         </p:nvSpPr>
         <p:spPr>
           <a:xfrm>
-            <a:off x="640080" y="3840480"/>
-            <a:ext cx="10241280" cy="1280160"/>
+            <a:off x="4507992" y="2231136"/>
+            <a:ext cx="2916936" cy="2670048"/>
           </a:xfrm>
           <a:prstGeom prst="rect">
             <a:avLst/>
@@ -4818,34 +5532,124 @@
           <a:p>
             <a:pPr algn="l">
               <a:lnSpc>
-                <a:spcPct val="125000"/>
+                <a:spcPct val="120000"/>
               </a:lnSpc>
               <a:spcAft>
                 <a:spcPts val="0"/>
               </a:spcAft>
             </a:pPr>
             <a:r>
-              <a:rPr sz="1700" b="0">
-                <a:solidFill>
-                  <a:srgbClr val="9FB2B6"/>
+              <a:rPr sz="1500" b="0">
+                <a:solidFill>
+                  <a:srgbClr val="EEF3F3"/>
                 </a:solidFill>
                 <a:latin typeface="Calibri"/>
               </a:rPr>
-              <a:t>The tooling exists, the risk is contained, and the upside is GPU capacity that compounds under load. What’s missing is a validated number, and that is days of work away, not months.</a:t>
-            </a:r>
-          </a:p>
-        </p:txBody>
-      </p:sp>
-      <p:sp>
-        <p:nvSpPr>
-          <p:cNvPr id="7" name="TextBox 6"/>
+              <a:t>Re-tune the server for each GPU class and re-measure; the capacity number is now measured on the H100, and the H200 showed one regression from an H100-tuned config.</a:t>
+            </a:r>
+          </a:p>
+        </p:txBody>
+      </p:sp>
+      <p:sp>
+        <p:nvSpPr>
+          <p:cNvPr id="9" name="Rounded Rectangle 8"/>
+          <p:cNvSpPr/>
+          <p:nvPr/>
+        </p:nvSpPr>
+        <p:spPr>
+          <a:xfrm>
+            <a:off x="7863840" y="2011680"/>
+            <a:ext cx="3429000" cy="3108960"/>
+          </a:xfrm>
+          <a:prstGeom prst="roundRect">
+            <a:avLst>
+              <a:gd name="adj" fmla="val 6000"/>
+            </a:avLst>
+          </a:prstGeom>
+          <a:solidFill>
+            <a:srgbClr val="141D21"/>
+          </a:solidFill>
+          <a:ln w="12700">
+            <a:solidFill>
+              <a:srgbClr val="25333A"/>
+            </a:solidFill>
+          </a:ln>
+          <a:effectLst/>
+        </p:spPr>
+        <p:style>
+          <a:lnRef idx="1">
+            <a:schemeClr val="accent1"/>
+          </a:lnRef>
+          <a:fillRef idx="3">
+            <a:schemeClr val="accent1"/>
+          </a:fillRef>
+          <a:effectRef idx="2">
+            <a:schemeClr val="accent1"/>
+          </a:effectRef>
+          <a:fontRef idx="minor">
+            <a:schemeClr val="lt1"/>
+          </a:fontRef>
+        </p:style>
+        <p:txBody>
+          <a:bodyPr rtlCol="0" anchor="ctr"/>
+          <a:lstStyle/>
+          <a:p>
+            <a:pPr algn="ctr"/>
+          </a:p>
+        </p:txBody>
+      </p:sp>
+      <p:sp>
+        <p:nvSpPr>
+          <p:cNvPr id="10" name="TextBox 9"/>
           <p:cNvSpPr txBox="1"/>
           <p:nvPr/>
         </p:nvSpPr>
         <p:spPr>
           <a:xfrm>
-            <a:off x="640080" y="5669280"/>
-            <a:ext cx="10881360" cy="457200"/>
+            <a:off x="8119871" y="2231136"/>
+            <a:ext cx="2916936" cy="2670048"/>
+          </a:xfrm>
+          <a:prstGeom prst="rect">
+            <a:avLst/>
+          </a:prstGeom>
+          <a:noFill/>
+        </p:spPr>
+        <p:txBody>
+          <a:bodyPr wrap="square" anchor="t">
+            <a:spAutoFit/>
+          </a:bodyPr>
+          <a:lstStyle/>
+          <a:p>
+            <a:pPr algn="l">
+              <a:lnSpc>
+                <a:spcPct val="120000"/>
+              </a:lnSpc>
+              <a:spcAft>
+                <a:spcPts val="0"/>
+              </a:spcAft>
+            </a:pPr>
+            <a:r>
+              <a:rPr sz="1500" b="0">
+                <a:solidFill>
+                  <a:srgbClr val="EEF3F3"/>
+                </a:solidFill>
+                <a:latin typeface="Calibri"/>
+              </a:rPr>
+              <a:t>A guarded rollout with explicit rule-audit and write-target checks at the serving boundary.</a:t>
+            </a:r>
+          </a:p>
+        </p:txBody>
+      </p:sp>
+      <p:sp>
+        <p:nvSpPr>
+          <p:cNvPr id="11" name="TextBox 10"/>
+          <p:cNvSpPr txBox="1"/>
+          <p:nvPr/>
+        </p:nvSpPr>
+        <p:spPr>
+          <a:xfrm>
+            <a:off x="640080" y="5486400"/>
+            <a:ext cx="10881360" cy="640080"/>
           </a:xfrm>
           <a:prstGeom prst="rect">
             <a:avLst/>
@@ -4867,13 +5671,13 @@
               </a:spcAft>
             </a:pPr>
             <a:r>
-              <a:rPr sz="1200" b="0">
-                <a:solidFill>
-                  <a:srgbClr val="3FB0C6"/>
-                </a:solidFill>
-                <a:latin typeface="Consolas"/>
+              <a:rPr sz="1300" b="0">
+                <a:solidFill>
+                  <a:srgbClr val="9FB2B6"/>
+                </a:solidFill>
+                <a:latin typeface="Calibri"/>
               </a:rPr>
-              <a:t>GitHub: arunmenon/gisting-coding-agent  ·  weights &amp; data on Hugging Face (private)</a:t>
+              <a:t>Bounded effort: a single GPU over days, not a new research program. The capacity number is measured; what remains is proof on work we did not design.</a:t>
             </a:r>
           </a:p>
         </p:txBody>
@@ -4977,6 +5781,278 @@
                 </a:solidFill>
                 <a:latin typeface="Consolas"/>
               </a:rPr>
+              <a:t>DECISION</a:t>
+            </a:r>
+          </a:p>
+        </p:txBody>
+      </p:sp>
+      <p:sp>
+        <p:nvSpPr>
+          <p:cNvPr id="4" name="TextBox 3"/>
+          <p:cNvSpPr txBox="1"/>
+          <p:nvPr/>
+        </p:nvSpPr>
+        <p:spPr>
+          <a:xfrm>
+            <a:off x="640080" y="841248"/>
+            <a:ext cx="10881360" cy="1371600"/>
+          </a:xfrm>
+          <a:prstGeom prst="rect">
+            <a:avLst/>
+          </a:prstGeom>
+          <a:noFill/>
+        </p:spPr>
+        <p:txBody>
+          <a:bodyPr wrap="square" anchor="t">
+            <a:spAutoFit/>
+          </a:bodyPr>
+          <a:lstStyle/>
+          <a:p>
+            <a:pPr algn="l">
+              <a:lnSpc>
+                <a:spcPct val="102000"/>
+              </a:lnSpc>
+              <a:spcAft>
+                <a:spcPts val="0"/>
+              </a:spcAft>
+            </a:pPr>
+            <a:r>
+              <a:rPr sz="3400" b="1">
+                <a:solidFill>
+                  <a:srgbClr val="EEF3F3"/>
+                </a:solidFill>
+                <a:latin typeface="Georgia"/>
+              </a:rPr>
+              <a:t>The lever is real and cheap to prototype</a:t>
+            </a:r>
+          </a:p>
+        </p:txBody>
+      </p:sp>
+      <p:sp>
+        <p:nvSpPr>
+          <p:cNvPr id="5" name="TextBox 4"/>
+          <p:cNvSpPr txBox="1"/>
+          <p:nvPr/>
+        </p:nvSpPr>
+        <p:spPr>
+          <a:xfrm>
+            <a:off x="640080" y="2103120"/>
+            <a:ext cx="9601200" cy="1463040"/>
+          </a:xfrm>
+          <a:prstGeom prst="rect">
+            <a:avLst/>
+          </a:prstGeom>
+          <a:noFill/>
+        </p:spPr>
+        <p:txBody>
+          <a:bodyPr wrap="square" anchor="t">
+            <a:spAutoFit/>
+          </a:bodyPr>
+          <a:lstStyle/>
+          <a:p>
+            <a:pPr algn="l">
+              <a:lnSpc>
+                <a:spcPct val="110000"/>
+              </a:lnSpc>
+              <a:spcAft>
+                <a:spcPts val="0"/>
+              </a:spcAft>
+            </a:pPr>
+            <a:r>
+              <a:rPr sz="3000" b="1">
+                <a:solidFill>
+                  <a:srgbClr val="FFFFFF"/>
+                </a:solidFill>
+                <a:latin typeface="Georgia"/>
+              </a:rPr>
+              <a:t>The capacity number is measured. Fund the held-out validation and a guarded pilot.</a:t>
+            </a:r>
+          </a:p>
+        </p:txBody>
+      </p:sp>
+      <p:sp>
+        <p:nvSpPr>
+          <p:cNvPr id="6" name="TextBox 5"/>
+          <p:cNvSpPr txBox="1"/>
+          <p:nvPr/>
+        </p:nvSpPr>
+        <p:spPr>
+          <a:xfrm>
+            <a:off x="640080" y="3840480"/>
+            <a:ext cx="10241280" cy="1280160"/>
+          </a:xfrm>
+          <a:prstGeom prst="rect">
+            <a:avLst/>
+          </a:prstGeom>
+          <a:noFill/>
+        </p:spPr>
+        <p:txBody>
+          <a:bodyPr wrap="square" anchor="t">
+            <a:spAutoFit/>
+          </a:bodyPr>
+          <a:lstStyle/>
+          <a:p>
+            <a:pPr algn="l">
+              <a:lnSpc>
+                <a:spcPct val="125000"/>
+              </a:lnSpc>
+              <a:spcAft>
+                <a:spcPts val="0"/>
+              </a:spcAft>
+            </a:pPr>
+            <a:r>
+              <a:rPr sz="1700" b="0">
+                <a:solidFill>
+                  <a:srgbClr val="9FB2B6"/>
+                </a:solidFill>
+                <a:latin typeface="Calibri"/>
+              </a:rPr>
+              <a:t>The tooling exists, the risk is contained, and the upside is measured: 2x the load within SLO on the same GPU, or the same throughput per dollar from a cheaper GPU. What’s missing is proof on unseen work, and that is days of work away, not months.</a:t>
+            </a:r>
+          </a:p>
+        </p:txBody>
+      </p:sp>
+      <p:sp>
+        <p:nvSpPr>
+          <p:cNvPr id="7" name="TextBox 6"/>
+          <p:cNvSpPr txBox="1"/>
+          <p:nvPr/>
+        </p:nvSpPr>
+        <p:spPr>
+          <a:xfrm>
+            <a:off x="640080" y="5669280"/>
+            <a:ext cx="10881360" cy="457200"/>
+          </a:xfrm>
+          <a:prstGeom prst="rect">
+            <a:avLst/>
+          </a:prstGeom>
+          <a:noFill/>
+        </p:spPr>
+        <p:txBody>
+          <a:bodyPr wrap="square" anchor="t">
+            <a:spAutoFit/>
+          </a:bodyPr>
+          <a:lstStyle/>
+          <a:p>
+            <a:pPr algn="l">
+              <a:lnSpc>
+                <a:spcPct val="100000"/>
+              </a:lnSpc>
+              <a:spcAft>
+                <a:spcPts val="0"/>
+              </a:spcAft>
+            </a:pPr>
+            <a:r>
+              <a:rPr sz="1200" b="0">
+                <a:solidFill>
+                  <a:srgbClr val="3FB0C6"/>
+                </a:solidFill>
+                <a:latin typeface="Consolas"/>
+              </a:rPr>
+              <a:t>GitHub: arunmenon/gisting-coding-agent  ·  weights &amp; data on Hugging Face (private)</a:t>
+            </a:r>
+          </a:p>
+        </p:txBody>
+      </p:sp>
+    </p:spTree>
+  </p:cSld>
+  <p:clrMapOvr>
+    <a:masterClrMapping/>
+  </p:clrMapOvr>
+</p:sld>
+</file>
+
+<file path=ppt/slides/slide14.xml><?xml version="1.0" encoding="utf-8"?>
+<p:sld xmlns:a="http://schemas.openxmlformats.org/drawingml/2006/main" xmlns:p="http://schemas.openxmlformats.org/presentationml/2006/main" xmlns:r="http://schemas.openxmlformats.org/officeDocument/2006/relationships">
+  <p:cSld>
+    <p:spTree>
+      <p:nvGrpSpPr>
+        <p:cNvPr id="1" name=""/>
+        <p:cNvGrpSpPr/>
+        <p:nvPr/>
+      </p:nvGrpSpPr>
+      <p:grpSpPr/>
+      <p:sp>
+        <p:nvSpPr>
+          <p:cNvPr id="2" name="Rectangle 1"/>
+          <p:cNvSpPr/>
+          <p:nvPr/>
+        </p:nvSpPr>
+        <p:spPr>
+          <a:xfrm>
+            <a:off x="0" y="0"/>
+            <a:ext cx="12191695" cy="6858000"/>
+          </a:xfrm>
+          <a:prstGeom prst="rect">
+            <a:avLst/>
+          </a:prstGeom>
+          <a:solidFill>
+            <a:srgbClr val="0E1417"/>
+          </a:solidFill>
+          <a:ln>
+            <a:noFill/>
+          </a:ln>
+          <a:effectLst/>
+        </p:spPr>
+        <p:style>
+          <a:lnRef idx="1">
+            <a:schemeClr val="accent1"/>
+          </a:lnRef>
+          <a:fillRef idx="3">
+            <a:schemeClr val="accent1"/>
+          </a:fillRef>
+          <a:effectRef idx="2">
+            <a:schemeClr val="accent1"/>
+          </a:effectRef>
+          <a:fontRef idx="minor">
+            <a:schemeClr val="lt1"/>
+          </a:fontRef>
+        </p:style>
+        <p:txBody>
+          <a:bodyPr rtlCol="0" anchor="ctr"/>
+          <a:lstStyle/>
+          <a:p>
+            <a:pPr algn="ctr"/>
+          </a:p>
+        </p:txBody>
+      </p:sp>
+      <p:sp>
+        <p:nvSpPr>
+          <p:cNvPr id="3" name="TextBox 2"/>
+          <p:cNvSpPr txBox="1"/>
+          <p:nvPr/>
+        </p:nvSpPr>
+        <p:spPr>
+          <a:xfrm>
+            <a:off x="640080" y="457200"/>
+            <a:ext cx="10881360" cy="365760"/>
+          </a:xfrm>
+          <a:prstGeom prst="rect">
+            <a:avLst/>
+          </a:prstGeom>
+          <a:noFill/>
+        </p:spPr>
+        <p:txBody>
+          <a:bodyPr wrap="square" anchor="t">
+            <a:spAutoFit/>
+          </a:bodyPr>
+          <a:lstStyle/>
+          <a:p>
+            <a:pPr algn="l">
+              <a:lnSpc>
+                <a:spcPct val="100000"/>
+              </a:lnSpc>
+              <a:spcAft>
+                <a:spcPts val="0"/>
+              </a:spcAft>
+            </a:pPr>
+            <a:r>
+              <a:rPr sz="1300" b="1">
+                <a:solidFill>
+                  <a:srgbClr val="3FB0C6"/>
+                </a:solidFill>
+                <a:latin typeface="Consolas"/>
+              </a:rPr>
               <a:t>APPENDIX · THE FAILURE WE CAUGHT</a:t>
             </a:r>
           </a:p>
@@ -6179,7 +7255,7 @@
                 </a:solidFill>
                 <a:latin typeface="Calibri"/>
               </a:rPr>
-              <a:t>~16% more throughput at eight concurrent sessions: capacity per GPU, not faster single replies.</a:t>
+              <a:t>2x the request rate within the latency SLO and +44% peak throughput on the same GPU (tuned server, 3 repeats). A cost lever: a cheaper GPU with gist matched a pricier one per dollar.</a:t>
             </a:r>
           </a:p>
         </p:txBody>
@@ -6608,7 +7684,7 @@
                 </a:solidFill>
                 <a:latin typeface="Calibri"/>
               </a:rPr>
-              <a:t>Token-bound. Fewer input tokens per turn → more concurrent sessions per GPU before latency degrades.</a:t>
+              <a:t>Token-bound. Fewer input tokens per turn → each session finishes sooner → more load per GPU before latency degrades. Measured: 2x at the SLO.</a:t>
             </a:r>
           </a:p>
         </p:txBody>
@@ -9053,7 +10129,7 @@
                 </a:solidFill>
                 <a:latin typeface="Consolas"/>
               </a:rPr>
-              <a:t>THE PAYOFF</a:t>
+              <a:t>THE PAYOFF (MEASURED)</a:t>
             </a:r>
           </a:p>
         </p:txBody>
@@ -9126,8 +10202,8 @@
         </p:nvSpPr>
         <p:spPr>
           <a:xfrm>
-            <a:off x="7680960" y="2194560"/>
-            <a:ext cx="3840480" cy="3657600"/>
+            <a:off x="7680960" y="2011680"/>
+            <a:ext cx="3931920" cy="4023360"/>
           </a:xfrm>
           <a:prstGeom prst="rect">
             <a:avLst/>
@@ -9139,61 +10215,99 @@
             <a:spAutoFit/>
           </a:bodyPr>
           <a:lstStyle/>
+          <a:p>
+            <a:pPr algn="l">
+              <a:lnSpc>
+                <a:spcPct val="100000"/>
+              </a:lnSpc>
+              <a:spcAft>
+                <a:spcPts val="200"/>
+              </a:spcAft>
+            </a:pPr>
+            <a:r>
+              <a:rPr sz="3000" b="1">
+                <a:solidFill>
+                  <a:srgbClr val="C39BE0"/>
+                </a:solidFill>
+                <a:latin typeface="Consolas"/>
+              </a:rPr>
+              <a:t>2x</a:t>
+            </a:r>
+          </a:p>
+          <a:p>
+            <a:pPr algn="l">
+              <a:lnSpc>
+                <a:spcPct val="100000"/>
+              </a:lnSpc>
+              <a:spcAft>
+                <a:spcPts val="1200"/>
+              </a:spcAft>
+            </a:pPr>
+            <a:r>
+              <a:rPr sz="1200" b="0">
+                <a:solidFill>
+                  <a:srgbClr val="9FB2B6"/>
+                </a:solidFill>
+                <a:latin typeface="Consolas"/>
+              </a:rPr>
+              <a:t>request rate within the latency SLO (18 → 36 req/min, random arrivals)</a:t>
+            </a:r>
+          </a:p>
+          <a:p>
+            <a:pPr algn="l">
+              <a:lnSpc>
+                <a:spcPct val="100000"/>
+              </a:lnSpc>
+              <a:spcAft>
+                <a:spcPts val="200"/>
+              </a:spcAft>
+            </a:pPr>
+            <a:r>
+              <a:rPr sz="3000" b="1">
+                <a:solidFill>
+                  <a:srgbClr val="3FB0C6"/>
+                </a:solidFill>
+                <a:latin typeface="Consolas"/>
+              </a:rPr>
+              <a:t>+44%</a:t>
+            </a:r>
+          </a:p>
+          <a:p>
+            <a:pPr algn="l">
+              <a:lnSpc>
+                <a:spcPct val="100000"/>
+              </a:lnSpc>
+              <a:spcAft>
+                <a:spcPts val="1400"/>
+              </a:spcAft>
+            </a:pPr>
+            <a:r>
+              <a:rPr sz="1200" b="0">
+                <a:solidFill>
+                  <a:srgbClr val="9FB2B6"/>
+                </a:solidFill>
+                <a:latin typeface="Consolas"/>
+              </a:rPr>
+              <a:t>peak throughput, same GPU (42.7 → 61.3 req/min)</a:t>
+            </a:r>
+          </a:p>
           <a:p>
             <a:pPr algn="l">
               <a:lnSpc>
                 <a:spcPct val="120000"/>
               </a:lnSpc>
               <a:spcAft>
-                <a:spcPts val="1400"/>
-              </a:spcAft>
-            </a:pPr>
-            <a:r>
-              <a:rPr sz="1600" b="0">
-                <a:solidFill>
-                  <a:srgbClr val="EEF3F3"/>
-                </a:solidFill>
-                <a:latin typeface="Calibri"/>
-              </a:rPr>
-              <a:t>Throughput rises with concurrency, and the gain grows as the service gets busier. A single reply is barely faster.</a:t>
-            </a:r>
-          </a:p>
-          <a:p>
-            <a:pPr algn="l">
-              <a:lnSpc>
-                <a:spcPct val="120000"/>
-              </a:lnSpc>
-              <a:spcAft>
-                <a:spcPts val="1000"/>
-              </a:spcAft>
-            </a:pPr>
-            <a:r>
-              <a:rPr sz="1400" b="0">
-                <a:solidFill>
-                  <a:srgbClr val="9FB2B6"/>
-                </a:solidFill>
-                <a:latin typeface="Calibri"/>
-              </a:rPr>
-              <a:t>For a shared internal agent service, this is sessions per GPU, the number that sets cost.</a:t>
-            </a:r>
-          </a:p>
-          <a:p>
-            <a:pPr algn="l">
-              <a:lnSpc>
-                <a:spcPct val="100000"/>
-              </a:lnSpc>
-              <a:spcAft>
                 <a:spcPts val="0"/>
               </a:spcAft>
             </a:pPr>
             <a:r>
-              <a:rPr sz="1200" b="0">
-                <a:solidFill>
-                  <a:srgbClr val="9FB2B6"/>
-                </a:solidFill>
-                <a:latin typeface="Consolas"/>
+              <a:rPr sz="1400" b="0">
+                <a:solidFill>
+                  <a:srgbClr val="EEF3F3"/>
+                </a:solidFill>
+                <a:latin typeface="Calibri"/>
               </a:rPr>
-              <a:t>One replay; direction, not precision.</a:t>
+              <a:t>The advantage grows with load (1.12x at 1 session → 1.65x at 48) and is incremental over prefix caching: 2–4x larger when caching can't help. 201 runs, 0 failures.</a:t>
             </a:r>
           </a:p>
         </p:txBody>
@@ -9381,7 +10495,7 @@
                 </a:solidFill>
                 <a:latin typeface="Calibri"/>
               </a:rPr>
-              <a:t>This model uses full attention in only 16 of its 64 layers. A shorter prompt saves decode work only there, so the win is more sessions in parallel, not a faster individual answer.</a:t>
+              <a:t>This model uses full attention in only 16 of its 64 layers, and the number of sessions it can hold at once is set by a fixed per-session state, not by prompt length. A shorter prompt does not fit many more sessions; it makes each session finish sooner. The win is throughput under load, not a faster single answer.</a:t>
             </a:r>
           </a:p>
         </p:txBody>
@@ -12367,7 +13481,7 @@
                 </a:solidFill>
                 <a:latin typeface="Calibri"/>
               </a:rPr>
-              <a:t>■ full-attention layers (where a shorter prompt helps)      ■ linear-attention layers (fixed-size state).  The benefit is architecture-dependent: a different model shifts it.</a:t>
+              <a:t>■ full-attention layers      ■ linear-attention layers (fixed-size state).  Measured: at the resident-session ceiling both arms hold the same number of sessions; the gist turns them over faster (H200: 85 vs 50 req/min at 100 resident).</a:t>
             </a:r>
           </a:p>
         </p:txBody>
@@ -12471,7 +13585,7 @@
                 </a:solidFill>
                 <a:latin typeface="Consolas"/>
               </a:rPr>
-              <a:t>THE CAPABILITY</a:t>
+              <a:t>THE COST LEVER</a:t>
             </a:r>
           </a:p>
         </p:txBody>
@@ -12513,69 +13627,21 @@
                 </a:solidFill>
                 <a:latin typeface="Georgia"/>
               </a:rPr>
-              <a:t>We built the lab, not just the result</a:t>
-            </a:r>
-          </a:p>
-        </p:txBody>
-      </p:sp>
-      <p:sp>
-        <p:nvSpPr>
-          <p:cNvPr id="5" name="Rounded Rectangle 4"/>
-          <p:cNvSpPr/>
-          <p:nvPr/>
-        </p:nvSpPr>
-        <p:spPr>
-          <a:xfrm>
-            <a:off x="640080" y="2560320"/>
-            <a:ext cx="1828800" cy="960120"/>
-          </a:xfrm>
-          <a:prstGeom prst="roundRect">
-            <a:avLst>
-              <a:gd name="adj" fmla="val 6000"/>
-            </a:avLst>
-          </a:prstGeom>
-          <a:solidFill>
-            <a:srgbClr val="141D21"/>
-          </a:solidFill>
-          <a:ln w="12700">
-            <a:solidFill>
-              <a:srgbClr val="25333A"/>
-            </a:solidFill>
-          </a:ln>
-          <a:effectLst/>
-        </p:spPr>
-        <p:style>
-          <a:lnRef idx="1">
-            <a:schemeClr val="accent1"/>
-          </a:lnRef>
-          <a:fillRef idx="3">
-            <a:schemeClr val="accent1"/>
-          </a:fillRef>
-          <a:effectRef idx="2">
-            <a:schemeClr val="accent1"/>
-          </a:effectRef>
-          <a:fontRef idx="minor">
-            <a:schemeClr val="lt1"/>
-          </a:fontRef>
-        </p:style>
-        <p:txBody>
-          <a:bodyPr rtlCol="0" anchor="ctr"/>
-          <a:lstStyle/>
-          <a:p>
-            <a:pPr algn="ctr"/>
-          </a:p>
-        </p:txBody>
-      </p:sp>
-      <p:sp>
-        <p:nvSpPr>
-          <p:cNvPr id="6" name="TextBox 5"/>
+              <a:t>Gisting lets a cheaper GPU match a pricier one</a:t>
+            </a:r>
+          </a:p>
+        </p:txBody>
+      </p:sp>
+      <p:sp>
+        <p:nvSpPr>
+          <p:cNvPr id="5" name="TextBox 4"/>
           <p:cNvSpPr txBox="1"/>
           <p:nvPr/>
         </p:nvSpPr>
         <p:spPr>
           <a:xfrm>
-            <a:off x="640080" y="2560320"/>
-            <a:ext cx="1828800" cy="960120"/>
+            <a:off x="640080" y="2011680"/>
+            <a:ext cx="2560320" cy="731520"/>
           </a:xfrm>
           <a:prstGeom prst="rect">
             <a:avLst/>
@@ -12583,755 +13649,7 @@
           <a:noFill/>
         </p:spPr>
         <p:txBody>
-          <a:bodyPr wrap="square" anchor="ctr">
-            <a:spAutoFit/>
-          </a:bodyPr>
-          <a:lstStyle/>
-          <a:p>
-            <a:pPr algn="ctr">
-              <a:lnSpc>
-                <a:spcPct val="100000"/>
-              </a:lnSpc>
-              <a:spcAft>
-                <a:spcPts val="0"/>
-              </a:spcAft>
-            </a:pPr>
-            <a:r>
-              <a:rPr sz="1400" b="1">
-                <a:solidFill>
-                  <a:srgbClr val="FFFFFF"/>
-                </a:solidFill>
-                <a:latin typeface="Calibri"/>
-              </a:rPr>
-              <a:t>Provision GPU</a:t>
-            </a:r>
-          </a:p>
-        </p:txBody>
-      </p:sp>
-      <p:sp>
-        <p:nvSpPr>
-          <p:cNvPr id="7" name="TextBox 6"/>
-          <p:cNvSpPr txBox="1"/>
-          <p:nvPr/>
-        </p:nvSpPr>
-        <p:spPr>
-          <a:xfrm>
-            <a:off x="2468880" y="2560320"/>
-            <a:ext cx="502920" cy="960120"/>
-          </a:xfrm>
-          <a:prstGeom prst="rect">
-            <a:avLst/>
-          </a:prstGeom>
-          <a:noFill/>
-        </p:spPr>
-        <p:txBody>
-          <a:bodyPr wrap="square" anchor="ctr">
-            <a:spAutoFit/>
-          </a:bodyPr>
-          <a:lstStyle/>
-          <a:p>
-            <a:pPr algn="ctr">
-              <a:lnSpc>
-                <a:spcPct val="100000"/>
-              </a:lnSpc>
-              <a:spcAft>
-                <a:spcPts val="0"/>
-              </a:spcAft>
-            </a:pPr>
-            <a:r>
-              <a:rPr sz="2000" b="1">
-                <a:solidFill>
-                  <a:srgbClr val="3FB0C6"/>
-                </a:solidFill>
-                <a:latin typeface="Calibri"/>
-              </a:rPr>
-              <a:t>→</a:t>
-            </a:r>
-          </a:p>
-        </p:txBody>
-      </p:sp>
-      <p:sp>
-        <p:nvSpPr>
-          <p:cNvPr id="8" name="Rounded Rectangle 7"/>
-          <p:cNvSpPr/>
-          <p:nvPr/>
-        </p:nvSpPr>
-        <p:spPr>
-          <a:xfrm>
-            <a:off x="2971800" y="2560320"/>
-            <a:ext cx="1234440" cy="960120"/>
-          </a:xfrm>
-          <a:prstGeom prst="roundRect">
-            <a:avLst>
-              <a:gd name="adj" fmla="val 6000"/>
-            </a:avLst>
-          </a:prstGeom>
-          <a:solidFill>
-            <a:srgbClr val="141D21"/>
-          </a:solidFill>
-          <a:ln w="12700">
-            <a:solidFill>
-              <a:srgbClr val="25333A"/>
-            </a:solidFill>
-          </a:ln>
-          <a:effectLst/>
-        </p:spPr>
-        <p:style>
-          <a:lnRef idx="1">
-            <a:schemeClr val="accent1"/>
-          </a:lnRef>
-          <a:fillRef idx="3">
-            <a:schemeClr val="accent1"/>
-          </a:fillRef>
-          <a:effectRef idx="2">
-            <a:schemeClr val="accent1"/>
-          </a:effectRef>
-          <a:fontRef idx="minor">
-            <a:schemeClr val="lt1"/>
-          </a:fontRef>
-        </p:style>
-        <p:txBody>
-          <a:bodyPr rtlCol="0" anchor="ctr"/>
-          <a:lstStyle/>
-          <a:p>
-            <a:pPr algn="ctr"/>
-          </a:p>
-        </p:txBody>
-      </p:sp>
-      <p:sp>
-        <p:nvSpPr>
-          <p:cNvPr id="9" name="TextBox 8"/>
-          <p:cNvSpPr txBox="1"/>
-          <p:nvPr/>
-        </p:nvSpPr>
-        <p:spPr>
-          <a:xfrm>
-            <a:off x="2971800" y="2560320"/>
-            <a:ext cx="1234440" cy="960120"/>
-          </a:xfrm>
-          <a:prstGeom prst="rect">
-            <a:avLst/>
-          </a:prstGeom>
-          <a:noFill/>
-        </p:spPr>
-        <p:txBody>
-          <a:bodyPr wrap="square" anchor="ctr">
-            <a:spAutoFit/>
-          </a:bodyPr>
-          <a:lstStyle/>
-          <a:p>
-            <a:pPr algn="ctr">
-              <a:lnSpc>
-                <a:spcPct val="100000"/>
-              </a:lnSpc>
-              <a:spcAft>
-                <a:spcPts val="0"/>
-              </a:spcAft>
-            </a:pPr>
-            <a:r>
-              <a:rPr sz="1400" b="1">
-                <a:solidFill>
-                  <a:srgbClr val="FFFFFF"/>
-                </a:solidFill>
-                <a:latin typeface="Calibri"/>
-              </a:rPr>
-              <a:t>Train</a:t>
-            </a:r>
-          </a:p>
-        </p:txBody>
-      </p:sp>
-      <p:sp>
-        <p:nvSpPr>
-          <p:cNvPr id="10" name="TextBox 9"/>
-          <p:cNvSpPr txBox="1"/>
-          <p:nvPr/>
-        </p:nvSpPr>
-        <p:spPr>
-          <a:xfrm>
-            <a:off x="4206240" y="2560320"/>
-            <a:ext cx="502920" cy="960120"/>
-          </a:xfrm>
-          <a:prstGeom prst="rect">
-            <a:avLst/>
-          </a:prstGeom>
-          <a:noFill/>
-        </p:spPr>
-        <p:txBody>
-          <a:bodyPr wrap="square" anchor="ctr">
-            <a:spAutoFit/>
-          </a:bodyPr>
-          <a:lstStyle/>
-          <a:p>
-            <a:pPr algn="ctr">
-              <a:lnSpc>
-                <a:spcPct val="100000"/>
-              </a:lnSpc>
-              <a:spcAft>
-                <a:spcPts val="0"/>
-              </a:spcAft>
-            </a:pPr>
-            <a:r>
-              <a:rPr sz="2000" b="1">
-                <a:solidFill>
-                  <a:srgbClr val="3FB0C6"/>
-                </a:solidFill>
-                <a:latin typeface="Calibri"/>
-              </a:rPr>
-              <a:t>→</a:t>
-            </a:r>
-          </a:p>
-        </p:txBody>
-      </p:sp>
-      <p:sp>
-        <p:nvSpPr>
-          <p:cNvPr id="11" name="Rounded Rectangle 10"/>
-          <p:cNvSpPr/>
-          <p:nvPr/>
-        </p:nvSpPr>
-        <p:spPr>
-          <a:xfrm>
-            <a:off x="4709159" y="2560320"/>
-            <a:ext cx="1234440" cy="960120"/>
-          </a:xfrm>
-          <a:prstGeom prst="roundRect">
-            <a:avLst>
-              <a:gd name="adj" fmla="val 6000"/>
-            </a:avLst>
-          </a:prstGeom>
-          <a:solidFill>
-            <a:srgbClr val="141D21"/>
-          </a:solidFill>
-          <a:ln w="12700">
-            <a:solidFill>
-              <a:srgbClr val="25333A"/>
-            </a:solidFill>
-          </a:ln>
-          <a:effectLst/>
-        </p:spPr>
-        <p:style>
-          <a:lnRef idx="1">
-            <a:schemeClr val="accent1"/>
-          </a:lnRef>
-          <a:fillRef idx="3">
-            <a:schemeClr val="accent1"/>
-          </a:fillRef>
-          <a:effectRef idx="2">
-            <a:schemeClr val="accent1"/>
-          </a:effectRef>
-          <a:fontRef idx="minor">
-            <a:schemeClr val="lt1"/>
-          </a:fontRef>
-        </p:style>
-        <p:txBody>
-          <a:bodyPr rtlCol="0" anchor="ctr"/>
-          <a:lstStyle/>
-          <a:p>
-            <a:pPr algn="ctr"/>
-          </a:p>
-        </p:txBody>
-      </p:sp>
-      <p:sp>
-        <p:nvSpPr>
-          <p:cNvPr id="12" name="TextBox 11"/>
-          <p:cNvSpPr txBox="1"/>
-          <p:nvPr/>
-        </p:nvSpPr>
-        <p:spPr>
-          <a:xfrm>
-            <a:off x="4709159" y="2560320"/>
-            <a:ext cx="1234440" cy="960120"/>
-          </a:xfrm>
-          <a:prstGeom prst="rect">
-            <a:avLst/>
-          </a:prstGeom>
-          <a:noFill/>
-        </p:spPr>
-        <p:txBody>
-          <a:bodyPr wrap="square" anchor="ctr">
-            <a:spAutoFit/>
-          </a:bodyPr>
-          <a:lstStyle/>
-          <a:p>
-            <a:pPr algn="ctr">
-              <a:lnSpc>
-                <a:spcPct val="100000"/>
-              </a:lnSpc>
-              <a:spcAft>
-                <a:spcPts val="0"/>
-              </a:spcAft>
-            </a:pPr>
-            <a:r>
-              <a:rPr sz="1400" b="1">
-                <a:solidFill>
-                  <a:srgbClr val="FFFFFF"/>
-                </a:solidFill>
-                <a:latin typeface="Calibri"/>
-              </a:rPr>
-              <a:t>Serve</a:t>
-            </a:r>
-          </a:p>
-        </p:txBody>
-      </p:sp>
-      <p:sp>
-        <p:nvSpPr>
-          <p:cNvPr id="13" name="TextBox 12"/>
-          <p:cNvSpPr txBox="1"/>
-          <p:nvPr/>
-        </p:nvSpPr>
-        <p:spPr>
-          <a:xfrm>
-            <a:off x="5943600" y="2560320"/>
-            <a:ext cx="502920" cy="960120"/>
-          </a:xfrm>
-          <a:prstGeom prst="rect">
-            <a:avLst/>
-          </a:prstGeom>
-          <a:noFill/>
-        </p:spPr>
-        <p:txBody>
-          <a:bodyPr wrap="square" anchor="ctr">
-            <a:spAutoFit/>
-          </a:bodyPr>
-          <a:lstStyle/>
-          <a:p>
-            <a:pPr algn="ctr">
-              <a:lnSpc>
-                <a:spcPct val="100000"/>
-              </a:lnSpc>
-              <a:spcAft>
-                <a:spcPts val="0"/>
-              </a:spcAft>
-            </a:pPr>
-            <a:r>
-              <a:rPr sz="2000" b="1">
-                <a:solidFill>
-                  <a:srgbClr val="3FB0C6"/>
-                </a:solidFill>
-                <a:latin typeface="Calibri"/>
-              </a:rPr>
-              <a:t>→</a:t>
-            </a:r>
-          </a:p>
-        </p:txBody>
-      </p:sp>
-      <p:sp>
-        <p:nvSpPr>
-          <p:cNvPr id="14" name="Rounded Rectangle 13"/>
-          <p:cNvSpPr/>
-          <p:nvPr/>
-        </p:nvSpPr>
-        <p:spPr>
-          <a:xfrm>
-            <a:off x="6446520" y="2560320"/>
-            <a:ext cx="1554480" cy="960120"/>
-          </a:xfrm>
-          <a:prstGeom prst="roundRect">
-            <a:avLst>
-              <a:gd name="adj" fmla="val 6000"/>
-            </a:avLst>
-          </a:prstGeom>
-          <a:solidFill>
-            <a:srgbClr val="141D21"/>
-          </a:solidFill>
-          <a:ln w="12700">
-            <a:solidFill>
-              <a:srgbClr val="25333A"/>
-            </a:solidFill>
-          </a:ln>
-          <a:effectLst/>
-        </p:spPr>
-        <p:style>
-          <a:lnRef idx="1">
-            <a:schemeClr val="accent1"/>
-          </a:lnRef>
-          <a:fillRef idx="3">
-            <a:schemeClr val="accent1"/>
-          </a:fillRef>
-          <a:effectRef idx="2">
-            <a:schemeClr val="accent1"/>
-          </a:effectRef>
-          <a:fontRef idx="minor">
-            <a:schemeClr val="lt1"/>
-          </a:fontRef>
-        </p:style>
-        <p:txBody>
-          <a:bodyPr rtlCol="0" anchor="ctr"/>
-          <a:lstStyle/>
-          <a:p>
-            <a:pPr algn="ctr"/>
-          </a:p>
-        </p:txBody>
-      </p:sp>
-      <p:sp>
-        <p:nvSpPr>
-          <p:cNvPr id="15" name="TextBox 14"/>
-          <p:cNvSpPr txBox="1"/>
-          <p:nvPr/>
-        </p:nvSpPr>
-        <p:spPr>
-          <a:xfrm>
-            <a:off x="6446520" y="2560320"/>
-            <a:ext cx="1554480" cy="960120"/>
-          </a:xfrm>
-          <a:prstGeom prst="rect">
-            <a:avLst/>
-          </a:prstGeom>
-          <a:noFill/>
-        </p:spPr>
-        <p:txBody>
-          <a:bodyPr wrap="square" anchor="ctr">
-            <a:spAutoFit/>
-          </a:bodyPr>
-          <a:lstStyle/>
-          <a:p>
-            <a:pPr algn="ctr">
-              <a:lnSpc>
-                <a:spcPct val="100000"/>
-              </a:lnSpc>
-              <a:spcAft>
-                <a:spcPts val="0"/>
-              </a:spcAft>
-            </a:pPr>
-            <a:r>
-              <a:rPr sz="1400" b="1">
-                <a:solidFill>
-                  <a:srgbClr val="FFFFFF"/>
-                </a:solidFill>
-                <a:latin typeface="Calibri"/>
-              </a:rPr>
-              <a:t>Evaluate</a:t>
-            </a:r>
-          </a:p>
-        </p:txBody>
-      </p:sp>
-      <p:sp>
-        <p:nvSpPr>
-          <p:cNvPr id="16" name="TextBox 15"/>
-          <p:cNvSpPr txBox="1"/>
-          <p:nvPr/>
-        </p:nvSpPr>
-        <p:spPr>
-          <a:xfrm>
-            <a:off x="8001000" y="2560320"/>
-            <a:ext cx="502920" cy="960120"/>
-          </a:xfrm>
-          <a:prstGeom prst="rect">
-            <a:avLst/>
-          </a:prstGeom>
-          <a:noFill/>
-        </p:spPr>
-        <p:txBody>
-          <a:bodyPr wrap="square" anchor="ctr">
-            <a:spAutoFit/>
-          </a:bodyPr>
-          <a:lstStyle/>
-          <a:p>
-            <a:pPr algn="ctr">
-              <a:lnSpc>
-                <a:spcPct val="100000"/>
-              </a:lnSpc>
-              <a:spcAft>
-                <a:spcPts val="0"/>
-              </a:spcAft>
-            </a:pPr>
-            <a:r>
-              <a:rPr sz="2000" b="1">
-                <a:solidFill>
-                  <a:srgbClr val="3FB0C6"/>
-                </a:solidFill>
-                <a:latin typeface="Calibri"/>
-              </a:rPr>
-              <a:t>→</a:t>
-            </a:r>
-          </a:p>
-        </p:txBody>
-      </p:sp>
-      <p:sp>
-        <p:nvSpPr>
-          <p:cNvPr id="17" name="Rounded Rectangle 16"/>
-          <p:cNvSpPr/>
-          <p:nvPr/>
-        </p:nvSpPr>
-        <p:spPr>
-          <a:xfrm>
-            <a:off x="8503920" y="2560320"/>
-            <a:ext cx="1371600" cy="960120"/>
-          </a:xfrm>
-          <a:prstGeom prst="roundRect">
-            <a:avLst>
-              <a:gd name="adj" fmla="val 6000"/>
-            </a:avLst>
-          </a:prstGeom>
-          <a:solidFill>
-            <a:srgbClr val="141D21"/>
-          </a:solidFill>
-          <a:ln w="12700">
-            <a:solidFill>
-              <a:srgbClr val="25333A"/>
-            </a:solidFill>
-          </a:ln>
-          <a:effectLst/>
-        </p:spPr>
-        <p:style>
-          <a:lnRef idx="1">
-            <a:schemeClr val="accent1"/>
-          </a:lnRef>
-          <a:fillRef idx="3">
-            <a:schemeClr val="accent1"/>
-          </a:fillRef>
-          <a:effectRef idx="2">
-            <a:schemeClr val="accent1"/>
-          </a:effectRef>
-          <a:fontRef idx="minor">
-            <a:schemeClr val="lt1"/>
-          </a:fontRef>
-        </p:style>
-        <p:txBody>
-          <a:bodyPr rtlCol="0" anchor="ctr"/>
-          <a:lstStyle/>
-          <a:p>
-            <a:pPr algn="ctr"/>
-          </a:p>
-        </p:txBody>
-      </p:sp>
-      <p:sp>
-        <p:nvSpPr>
-          <p:cNvPr id="18" name="TextBox 17"/>
-          <p:cNvSpPr txBox="1"/>
-          <p:nvPr/>
-        </p:nvSpPr>
-        <p:spPr>
-          <a:xfrm>
-            <a:off x="8503920" y="2560320"/>
-            <a:ext cx="1371600" cy="960120"/>
-          </a:xfrm>
-          <a:prstGeom prst="rect">
-            <a:avLst/>
-          </a:prstGeom>
-          <a:noFill/>
-        </p:spPr>
-        <p:txBody>
-          <a:bodyPr wrap="square" anchor="ctr">
-            <a:spAutoFit/>
-          </a:bodyPr>
-          <a:lstStyle/>
-          <a:p>
-            <a:pPr algn="ctr">
-              <a:lnSpc>
-                <a:spcPct val="100000"/>
-              </a:lnSpc>
-              <a:spcAft>
-                <a:spcPts val="0"/>
-              </a:spcAft>
-            </a:pPr>
-            <a:r>
-              <a:rPr sz="1400" b="1">
-                <a:solidFill>
-                  <a:srgbClr val="FFFFFF"/>
-                </a:solidFill>
-                <a:latin typeface="Calibri"/>
-              </a:rPr>
-              <a:t>Destroy</a:t>
-            </a:r>
-          </a:p>
-        </p:txBody>
-      </p:sp>
-      <p:sp>
-        <p:nvSpPr>
-          <p:cNvPr id="19" name="TextBox 18"/>
-          <p:cNvSpPr txBox="1"/>
-          <p:nvPr/>
-        </p:nvSpPr>
-        <p:spPr>
-          <a:xfrm>
-            <a:off x="9875520" y="2560320"/>
-            <a:ext cx="502920" cy="960120"/>
-          </a:xfrm>
-          <a:prstGeom prst="rect">
-            <a:avLst/>
-          </a:prstGeom>
-          <a:noFill/>
-        </p:spPr>
-        <p:txBody>
-          <a:bodyPr wrap="square" anchor="ctr">
-            <a:spAutoFit/>
-          </a:bodyPr>
-          <a:lstStyle/>
-          <a:p>
-            <a:pPr algn="ctr">
-              <a:lnSpc>
-                <a:spcPct val="100000"/>
-              </a:lnSpc>
-              <a:spcAft>
-                <a:spcPts val="0"/>
-              </a:spcAft>
-            </a:pPr>
-            <a:r>
-              <a:rPr sz="2000" b="1">
-                <a:solidFill>
-                  <a:srgbClr val="E08A4C"/>
-                </a:solidFill>
-                <a:latin typeface="Calibri"/>
-              </a:rPr>
-              <a:t>↺</a:t>
-            </a:r>
-          </a:p>
-        </p:txBody>
-      </p:sp>
-      <p:sp>
-        <p:nvSpPr>
-          <p:cNvPr id="20" name="Rounded Rectangle 19"/>
-          <p:cNvSpPr/>
-          <p:nvPr/>
-        </p:nvSpPr>
-        <p:spPr>
-          <a:xfrm>
-            <a:off x="10378440" y="2560320"/>
-            <a:ext cx="1554480" cy="960120"/>
-          </a:xfrm>
-          <a:prstGeom prst="roundRect">
-            <a:avLst>
-              <a:gd name="adj" fmla="val 6000"/>
-            </a:avLst>
-          </a:prstGeom>
-          <a:noFill/>
-          <a:ln w="12700">
-            <a:solidFill>
-              <a:srgbClr val="3A4A51"/>
-            </a:solidFill>
-          </a:ln>
-          <a:effectLst/>
-        </p:spPr>
-        <p:style>
-          <a:lnRef idx="1">
-            <a:schemeClr val="accent1"/>
-          </a:lnRef>
-          <a:fillRef idx="3">
-            <a:schemeClr val="accent1"/>
-          </a:fillRef>
-          <a:effectRef idx="2">
-            <a:schemeClr val="accent1"/>
-          </a:effectRef>
-          <a:fontRef idx="minor">
-            <a:schemeClr val="lt1"/>
-          </a:fontRef>
-        </p:style>
-        <p:txBody>
-          <a:bodyPr rtlCol="0" anchor="ctr"/>
-          <a:lstStyle/>
-          <a:p>
-            <a:pPr algn="ctr"/>
-          </a:p>
-        </p:txBody>
-      </p:sp>
-      <p:sp>
-        <p:nvSpPr>
-          <p:cNvPr id="21" name="TextBox 20"/>
-          <p:cNvSpPr txBox="1"/>
-          <p:nvPr/>
-        </p:nvSpPr>
-        <p:spPr>
-          <a:xfrm>
-            <a:off x="10378440" y="2560320"/>
-            <a:ext cx="1554480" cy="960120"/>
-          </a:xfrm>
-          <a:prstGeom prst="rect">
-            <a:avLst/>
-          </a:prstGeom>
-          <a:noFill/>
-        </p:spPr>
-        <p:txBody>
-          <a:bodyPr wrap="square" anchor="ctr">
-            <a:spAutoFit/>
-          </a:bodyPr>
-          <a:lstStyle/>
-          <a:p>
-            <a:pPr algn="ctr">
-              <a:lnSpc>
-                <a:spcPct val="100000"/>
-              </a:lnSpc>
-              <a:spcAft>
-                <a:spcPts val="0"/>
-              </a:spcAft>
-            </a:pPr>
-            <a:r>
-              <a:rPr sz="1300" b="0">
-                <a:solidFill>
-                  <a:srgbClr val="9FB2B6"/>
-                </a:solidFill>
-                <a:latin typeface="Calibri"/>
-              </a:rPr>
-              <a:t>next recipe</a:t>
-            </a:r>
-          </a:p>
-        </p:txBody>
-      </p:sp>
-      <p:sp>
-        <p:nvSpPr>
-          <p:cNvPr id="22" name="Rounded Rectangle 21"/>
-          <p:cNvSpPr/>
-          <p:nvPr/>
-        </p:nvSpPr>
-        <p:spPr>
-          <a:xfrm>
-            <a:off x="640080" y="3977639"/>
-            <a:ext cx="10881360" cy="868680"/>
-          </a:xfrm>
-          <a:prstGeom prst="roundRect">
-            <a:avLst>
-              <a:gd name="adj" fmla="val 6000"/>
-            </a:avLst>
-          </a:prstGeom>
-          <a:solidFill>
-            <a:srgbClr val="221A11"/>
-          </a:solidFill>
-          <a:ln w="12700">
-            <a:solidFill>
-              <a:srgbClr val="5A4A2A"/>
-            </a:solidFill>
-          </a:ln>
-          <a:effectLst/>
-        </p:spPr>
-        <p:style>
-          <a:lnRef idx="1">
-            <a:schemeClr val="accent1"/>
-          </a:lnRef>
-          <a:fillRef idx="3">
-            <a:schemeClr val="accent1"/>
-          </a:fillRef>
-          <a:effectRef idx="2">
-            <a:schemeClr val="accent1"/>
-          </a:effectRef>
-          <a:fontRef idx="minor">
-            <a:schemeClr val="lt1"/>
-          </a:fontRef>
-        </p:style>
-        <p:txBody>
-          <a:bodyPr rtlCol="0" anchor="ctr"/>
-          <a:lstStyle/>
-          <a:p>
-            <a:pPr algn="ctr"/>
-          </a:p>
-        </p:txBody>
-      </p:sp>
-      <p:sp>
-        <p:nvSpPr>
-          <p:cNvPr id="23" name="TextBox 22"/>
-          <p:cNvSpPr txBox="1"/>
-          <p:nvPr/>
-        </p:nvSpPr>
-        <p:spPr>
-          <a:xfrm>
-            <a:off x="868680" y="3977639"/>
-            <a:ext cx="10424160" cy="868680"/>
-          </a:xfrm>
-          <a:prstGeom prst="rect">
-            <a:avLst/>
-          </a:prstGeom>
-          <a:noFill/>
-        </p:spPr>
-        <p:txBody>
-          <a:bodyPr wrap="square" anchor="ctr">
+          <a:bodyPr wrap="square" anchor="t">
             <a:spAutoFit/>
           </a:bodyPr>
           <a:lstStyle/>
@@ -13345,27 +13663,405 @@
               </a:spcAft>
             </a:pPr>
             <a:r>
-              <a:rPr sz="1300" b="0">
-                <a:solidFill>
-                  <a:srgbClr val="E08A4C"/>
+              <a:rPr sz="3400" b="1">
+                <a:solidFill>
+                  <a:srgbClr val="4A5A60"/>
                 </a:solidFill>
                 <a:latin typeface="Consolas"/>
               </a:rPr>
-              <a:t>SPEND-SAFETY · structural  ·  idle watchdog · ledger at creation · sync-before-destroy · global deadline</a:t>
-            </a:r>
-          </a:p>
-        </p:txBody>
-      </p:sp>
-      <p:sp>
-        <p:nvSpPr>
-          <p:cNvPr id="24" name="TextBox 23"/>
+              <a:t>16.2</a:t>
+            </a:r>
+          </a:p>
+        </p:txBody>
+      </p:sp>
+      <p:sp>
+        <p:nvSpPr>
+          <p:cNvPr id="6" name="TextBox 5"/>
           <p:cNvSpPr txBox="1"/>
           <p:nvPr/>
         </p:nvSpPr>
         <p:spPr>
           <a:xfrm>
-            <a:off x="640080" y="5120640"/>
-            <a:ext cx="10881360" cy="731520"/>
+            <a:off x="640080" y="2697480"/>
+            <a:ext cx="2560320" cy="457200"/>
+          </a:xfrm>
+          <a:prstGeom prst="rect">
+            <a:avLst/>
+          </a:prstGeom>
+          <a:noFill/>
+        </p:spPr>
+        <p:txBody>
+          <a:bodyPr wrap="square" anchor="t">
+            <a:spAutoFit/>
+          </a:bodyPr>
+          <a:lstStyle/>
+          <a:p>
+            <a:pPr algn="l">
+              <a:lnSpc>
+                <a:spcPct val="100000"/>
+              </a:lnSpc>
+              <a:spcAft>
+                <a:spcPts val="0"/>
+              </a:spcAft>
+            </a:pPr>
+            <a:r>
+              <a:rPr sz="1200" b="0">
+                <a:solidFill>
+                  <a:srgbClr val="9FB2B6"/>
+                </a:solidFill>
+                <a:latin typeface="Consolas"/>
+              </a:rPr>
+              <a:t>H100 · full prompt</a:t>
+            </a:r>
+          </a:p>
+        </p:txBody>
+      </p:sp>
+      <p:sp>
+        <p:nvSpPr>
+          <p:cNvPr id="7" name="TextBox 6"/>
+          <p:cNvSpPr txBox="1"/>
+          <p:nvPr/>
+        </p:nvSpPr>
+        <p:spPr>
+          <a:xfrm>
+            <a:off x="3383280" y="2011680"/>
+            <a:ext cx="2560320" cy="731520"/>
+          </a:xfrm>
+          <a:prstGeom prst="rect">
+            <a:avLst/>
+          </a:prstGeom>
+          <a:noFill/>
+        </p:spPr>
+        <p:txBody>
+          <a:bodyPr wrap="square" anchor="t">
+            <a:spAutoFit/>
+          </a:bodyPr>
+          <a:lstStyle/>
+          <a:p>
+            <a:pPr algn="l">
+              <a:lnSpc>
+                <a:spcPct val="100000"/>
+              </a:lnSpc>
+              <a:spcAft>
+                <a:spcPts val="0"/>
+              </a:spcAft>
+            </a:pPr>
+            <a:r>
+              <a:rPr sz="3400" b="1">
+                <a:solidFill>
+                  <a:srgbClr val="C39BE0"/>
+                </a:solidFill>
+                <a:latin typeface="Consolas"/>
+              </a:rPr>
+              <a:t>23.2</a:t>
+            </a:r>
+          </a:p>
+        </p:txBody>
+      </p:sp>
+      <p:sp>
+        <p:nvSpPr>
+          <p:cNvPr id="8" name="TextBox 7"/>
+          <p:cNvSpPr txBox="1"/>
+          <p:nvPr/>
+        </p:nvSpPr>
+        <p:spPr>
+          <a:xfrm>
+            <a:off x="3383280" y="2697480"/>
+            <a:ext cx="2560320" cy="457200"/>
+          </a:xfrm>
+          <a:prstGeom prst="rect">
+            <a:avLst/>
+          </a:prstGeom>
+          <a:noFill/>
+        </p:spPr>
+        <p:txBody>
+          <a:bodyPr wrap="square" anchor="t">
+            <a:spAutoFit/>
+          </a:bodyPr>
+          <a:lstStyle/>
+          <a:p>
+            <a:pPr algn="l">
+              <a:lnSpc>
+                <a:spcPct val="100000"/>
+              </a:lnSpc>
+              <a:spcAft>
+                <a:spcPts val="0"/>
+              </a:spcAft>
+            </a:pPr>
+            <a:r>
+              <a:rPr sz="1200" b="0">
+                <a:solidFill>
+                  <a:srgbClr val="9FB2B6"/>
+                </a:solidFill>
+                <a:latin typeface="Consolas"/>
+              </a:rPr>
+              <a:t>H100 · gist 8:1</a:t>
+            </a:r>
+          </a:p>
+        </p:txBody>
+      </p:sp>
+      <p:sp>
+        <p:nvSpPr>
+          <p:cNvPr id="9" name="TextBox 8"/>
+          <p:cNvSpPr txBox="1"/>
+          <p:nvPr/>
+        </p:nvSpPr>
+        <p:spPr>
+          <a:xfrm>
+            <a:off x="6126480" y="2011680"/>
+            <a:ext cx="2560320" cy="731520"/>
+          </a:xfrm>
+          <a:prstGeom prst="rect">
+            <a:avLst/>
+          </a:prstGeom>
+          <a:noFill/>
+        </p:spPr>
+        <p:txBody>
+          <a:bodyPr wrap="square" anchor="t">
+            <a:spAutoFit/>
+          </a:bodyPr>
+          <a:lstStyle/>
+          <a:p>
+            <a:pPr algn="l">
+              <a:lnSpc>
+                <a:spcPct val="100000"/>
+              </a:lnSpc>
+              <a:spcAft>
+                <a:spcPts val="0"/>
+              </a:spcAft>
+            </a:pPr>
+            <a:r>
+              <a:rPr sz="3400" b="1">
+                <a:solidFill>
+                  <a:srgbClr val="3FB0C6"/>
+                </a:solidFill>
+                <a:latin typeface="Consolas"/>
+              </a:rPr>
+              <a:t>22.5</a:t>
+            </a:r>
+          </a:p>
+        </p:txBody>
+      </p:sp>
+      <p:sp>
+        <p:nvSpPr>
+          <p:cNvPr id="10" name="TextBox 9"/>
+          <p:cNvSpPr txBox="1"/>
+          <p:nvPr/>
+        </p:nvSpPr>
+        <p:spPr>
+          <a:xfrm>
+            <a:off x="6126480" y="2697480"/>
+            <a:ext cx="2560320" cy="457200"/>
+          </a:xfrm>
+          <a:prstGeom prst="rect">
+            <a:avLst/>
+          </a:prstGeom>
+          <a:noFill/>
+        </p:spPr>
+        <p:txBody>
+          <a:bodyPr wrap="square" anchor="t">
+            <a:spAutoFit/>
+          </a:bodyPr>
+          <a:lstStyle/>
+          <a:p>
+            <a:pPr algn="l">
+              <a:lnSpc>
+                <a:spcPct val="100000"/>
+              </a:lnSpc>
+              <a:spcAft>
+                <a:spcPts val="0"/>
+              </a:spcAft>
+            </a:pPr>
+            <a:r>
+              <a:rPr sz="1200" b="0">
+                <a:solidFill>
+                  <a:srgbClr val="9FB2B6"/>
+                </a:solidFill>
+                <a:latin typeface="Consolas"/>
+              </a:rPr>
+              <a:t>H200 · full prompt</a:t>
+            </a:r>
+          </a:p>
+        </p:txBody>
+      </p:sp>
+      <p:sp>
+        <p:nvSpPr>
+          <p:cNvPr id="11" name="TextBox 10"/>
+          <p:cNvSpPr txBox="1"/>
+          <p:nvPr/>
+        </p:nvSpPr>
+        <p:spPr>
+          <a:xfrm>
+            <a:off x="8869680" y="2011680"/>
+            <a:ext cx="2560320" cy="731520"/>
+          </a:xfrm>
+          <a:prstGeom prst="rect">
+            <a:avLst/>
+          </a:prstGeom>
+          <a:noFill/>
+        </p:spPr>
+        <p:txBody>
+          <a:bodyPr wrap="square" anchor="t">
+            <a:spAutoFit/>
+          </a:bodyPr>
+          <a:lstStyle/>
+          <a:p>
+            <a:pPr algn="l">
+              <a:lnSpc>
+                <a:spcPct val="100000"/>
+              </a:lnSpc>
+              <a:spcAft>
+                <a:spcPts val="0"/>
+              </a:spcAft>
+            </a:pPr>
+            <a:r>
+              <a:rPr sz="3400" b="1">
+                <a:solidFill>
+                  <a:srgbClr val="4A5A60"/>
+                </a:solidFill>
+                <a:latin typeface="Consolas"/>
+              </a:rPr>
+              <a:t>22.0</a:t>
+            </a:r>
+          </a:p>
+        </p:txBody>
+      </p:sp>
+      <p:sp>
+        <p:nvSpPr>
+          <p:cNvPr id="12" name="TextBox 11"/>
+          <p:cNvSpPr txBox="1"/>
+          <p:nvPr/>
+        </p:nvSpPr>
+        <p:spPr>
+          <a:xfrm>
+            <a:off x="8869680" y="2697480"/>
+            <a:ext cx="2560320" cy="457200"/>
+          </a:xfrm>
+          <a:prstGeom prst="rect">
+            <a:avLst/>
+          </a:prstGeom>
+          <a:noFill/>
+        </p:spPr>
+        <p:txBody>
+          <a:bodyPr wrap="square" anchor="t">
+            <a:spAutoFit/>
+          </a:bodyPr>
+          <a:lstStyle/>
+          <a:p>
+            <a:pPr algn="l">
+              <a:lnSpc>
+                <a:spcPct val="100000"/>
+              </a:lnSpc>
+              <a:spcAft>
+                <a:spcPts val="0"/>
+              </a:spcAft>
+            </a:pPr>
+            <a:r>
+              <a:rPr sz="1200" b="0">
+                <a:solidFill>
+                  <a:srgbClr val="9FB2B6"/>
+                </a:solidFill>
+                <a:latin typeface="Consolas"/>
+              </a:rPr>
+              <a:t>H200 · gist 8:1</a:t>
+            </a:r>
+          </a:p>
+        </p:txBody>
+      </p:sp>
+      <p:sp>
+        <p:nvSpPr>
+          <p:cNvPr id="13" name="TextBox 12"/>
+          <p:cNvSpPr txBox="1"/>
+          <p:nvPr/>
+        </p:nvSpPr>
+        <p:spPr>
+          <a:xfrm>
+            <a:off x="640080" y="3246120"/>
+            <a:ext cx="10881360" cy="457200"/>
+          </a:xfrm>
+          <a:prstGeom prst="rect">
+            <a:avLst/>
+          </a:prstGeom>
+          <a:noFill/>
+        </p:spPr>
+        <p:txBody>
+          <a:bodyPr wrap="square" anchor="t">
+            <a:spAutoFit/>
+          </a:bodyPr>
+          <a:lstStyle/>
+          <a:p>
+            <a:pPr algn="l">
+              <a:lnSpc>
+                <a:spcPct val="100000"/>
+              </a:lnSpc>
+              <a:spcAft>
+                <a:spcPts val="0"/>
+              </a:spcAft>
+            </a:pPr>
+            <a:r>
+              <a:rPr sz="1200" b="0">
+                <a:solidFill>
+                  <a:srgbClr val="9FB2B6"/>
+                </a:solidFill>
+                <a:latin typeface="Consolas"/>
+              </a:rPr>
+              <a:t>peak requests per minute, per dollar-hour of GPU rental (spot prices on the day of the run)</a:t>
+            </a:r>
+          </a:p>
+        </p:txBody>
+      </p:sp>
+      <p:sp>
+        <p:nvSpPr>
+          <p:cNvPr id="14" name="TextBox 13"/>
+          <p:cNvSpPr txBox="1"/>
+          <p:nvPr/>
+        </p:nvSpPr>
+        <p:spPr>
+          <a:xfrm>
+            <a:off x="640080" y="3840480"/>
+            <a:ext cx="10881360" cy="1280160"/>
+          </a:xfrm>
+          <a:prstGeom prst="rect">
+            <a:avLst/>
+          </a:prstGeom>
+          <a:noFill/>
+        </p:spPr>
+        <p:txBody>
+          <a:bodyPr wrap="square" anchor="t">
+            <a:spAutoFit/>
+          </a:bodyPr>
+          <a:lstStyle/>
+          <a:p>
+            <a:pPr algn="l">
+              <a:lnSpc>
+                <a:spcPct val="125000"/>
+              </a:lnSpc>
+              <a:spcAft>
+                <a:spcPts val="0"/>
+              </a:spcAft>
+            </a:pPr>
+            <a:r>
+              <a:rPr sz="1700" b="0">
+                <a:solidFill>
+                  <a:srgbClr val="EEF3F3"/>
+                </a:solidFill>
+                <a:latin typeface="Calibri"/>
+              </a:rPr>
+              <a:t>On the bigger H200 (143 GB), gist's peak gain vanished at normal load (-2%) and appeared only under pressure (3.1x at 128 sessions). On the H100 (95 GB) it was +44%. The benefit is proportional to how memory-constrained the hardware is relative to the prompt.</a:t>
+            </a:r>
+          </a:p>
+        </p:txBody>
+      </p:sp>
+      <p:sp>
+        <p:nvSpPr>
+          <p:cNvPr id="15" name="TextBox 14"/>
+          <p:cNvSpPr txBox="1"/>
+          <p:nvPr/>
+        </p:nvSpPr>
+        <p:spPr>
+          <a:xfrm>
+            <a:off x="640080" y="5303520"/>
+            <a:ext cx="10881360" cy="914400"/>
           </a:xfrm>
           <a:prstGeom prst="rect">
             <a:avLst/>
@@ -13387,13 +14083,13 @@
               </a:spcAft>
             </a:pPr>
             <a:r>
-              <a:rPr sz="1400" b="0">
+              <a:rPr sz="1300" b="0">
                 <a:solidFill>
                   <a:srgbClr val="9FB2B6"/>
                 </a:solidFill>
                 <a:latin typeface="Calibri"/>
               </a:rPr>
-              <a:t>One detached controller drives every recipe end to end, unattended. Makes the next model cheap to try: the capability outlasts this study.</a:t>
+              <a:t>Read it as a cost lever, not a speed lever: gist on the cheaper card delivers the expensive card's throughput per dollar. Where prompts don't share prefixes (no cache help), gist's 2–4x advantage holds on any card.</a:t>
             </a:r>
           </a:p>
         </p:txBody>

</xml_diff>